<commit_message>
Add isolated public demo and clear visual documentation
</commit_message>
<xml_diff>
--- a/submission/BuildTrustAI_Presentation.pptx
+++ b/submission/BuildTrustAI_Presentation.pptx
@@ -2,21 +2,21 @@
 <file path=ppt/presentation.xml><?xml version="1.0" encoding="utf-8"?>
 <p:presentation xmlns:p="http://schemas.openxmlformats.org/presentationml/2006/main">
   <p:sldMasterIdLst>
-    <p:sldMasterId xmlns:r="http://schemas.openxmlformats.org/officeDocument/2006/relationships" id="2147483648" r:id="Rd08a68ad9b394500"/>
+    <p:sldMasterId xmlns:r="http://schemas.openxmlformats.org/officeDocument/2006/relationships" id="2147483648" r:id="Rc916f305988744fa"/>
   </p:sldMasterIdLst>
   <p:notesMasterIdLst>
-    <p:notesMasterId xmlns:r="http://schemas.openxmlformats.org/officeDocument/2006/relationships" r:id="R3a4eb517628e4df8"/>
+    <p:notesMasterId xmlns:r="http://schemas.openxmlformats.org/officeDocument/2006/relationships" r:id="Re833edcf6a1a4a73"/>
   </p:notesMasterIdLst>
   <p:sldIdLst>
-    <p:sldId xmlns:r="http://schemas.openxmlformats.org/officeDocument/2006/relationships" id="256" r:id="R46f3a65c495d4c7a"/>
-    <p:sldId xmlns:r="http://schemas.openxmlformats.org/officeDocument/2006/relationships" id="257" r:id="R30bd31effe7c4513"/>
-    <p:sldId xmlns:r="http://schemas.openxmlformats.org/officeDocument/2006/relationships" id="258" r:id="Rbcb54571fdac4b50"/>
-    <p:sldId xmlns:r="http://schemas.openxmlformats.org/officeDocument/2006/relationships" id="259" r:id="R7bd2f85178cd498e"/>
-    <p:sldId xmlns:r="http://schemas.openxmlformats.org/officeDocument/2006/relationships" id="260" r:id="R6e1b638eb6d14bd4"/>
-    <p:sldId xmlns:r="http://schemas.openxmlformats.org/officeDocument/2006/relationships" id="261" r:id="R93c02ed9b7ef497d"/>
-    <p:sldId xmlns:r="http://schemas.openxmlformats.org/officeDocument/2006/relationships" id="262" r:id="Rdb27284808284067"/>
-    <p:sldId xmlns:r="http://schemas.openxmlformats.org/officeDocument/2006/relationships" id="263" r:id="R7f971e46865b43f5"/>
-    <p:sldId xmlns:r="http://schemas.openxmlformats.org/officeDocument/2006/relationships" id="264" r:id="R1176cafe59ee47be"/>
+    <p:sldId xmlns:r="http://schemas.openxmlformats.org/officeDocument/2006/relationships" id="256" r:id="Rd64881cda68c4d7b"/>
+    <p:sldId xmlns:r="http://schemas.openxmlformats.org/officeDocument/2006/relationships" id="257" r:id="R638e68d182a64bac"/>
+    <p:sldId xmlns:r="http://schemas.openxmlformats.org/officeDocument/2006/relationships" id="258" r:id="R1aeb773071184558"/>
+    <p:sldId xmlns:r="http://schemas.openxmlformats.org/officeDocument/2006/relationships" id="259" r:id="R8eb9b55322fd47f6"/>
+    <p:sldId xmlns:r="http://schemas.openxmlformats.org/officeDocument/2006/relationships" id="260" r:id="Rce0816aac91349cd"/>
+    <p:sldId xmlns:r="http://schemas.openxmlformats.org/officeDocument/2006/relationships" id="261" r:id="R66440b5aa87c49c5"/>
+    <p:sldId xmlns:r="http://schemas.openxmlformats.org/officeDocument/2006/relationships" id="262" r:id="Rf7273b287eac41f5"/>
+    <p:sldId xmlns:r="http://schemas.openxmlformats.org/officeDocument/2006/relationships" id="263" r:id="Rb056f6fc5e9049bc"/>
+    <p:sldId xmlns:r="http://schemas.openxmlformats.org/officeDocument/2006/relationships" id="264" r:id="R07fd4fc82fb24860"/>
   </p:sldIdLst>
   <p:sldSz cx="12192000" cy="6858000"/>
   <p:notesSz cx="6858000" cy="9144000"/>
@@ -450,7 +450,7 @@
           <a:lstStyle xmlns:a="http://schemas.openxmlformats.org/drawingml/2006/main"/>
           <a:p xmlns:a="http://schemas.openxmlformats.org/drawingml/2006/main">
             <a:r>
-              <a:t>0:00–0:40. Introduce the construction SME problem and the exact product boundary. BuildTrust AI performs real local document, finance, authorization and ledger operations. All settlement is simulated. Source: prompt/prompt.md and README.md.</a:t>
+              <a:t>0:00–0:40. BuildTrust AI helps construction teams check costs and review payments. This is a working local app, not a set of sample screen designs. Its records and calculations are real application operations, but the projects and transfers are fictional. No bank is connected. A visitor can start the separate public demo and use the four passwords in the README. Explain that people approve financial actions. Give the audience a moment to read the product name. Sources: README.md; features.md; prompt/prompt.md.</a:t>
             </a:r>
           </a:p>
         </p:txBody>
@@ -520,7 +520,7 @@
           <a:lstStyle xmlns:a="http://schemas.openxmlformats.org/drawingml/2006/main"/>
           <a:p xmlns:a="http://schemas.openxmlformats.org/drawingml/2006/main">
             <a:r>
-              <a:t>0:40–1:30. A BOQ establishes scope, a PO records contracted supply, a GRN certifies accepted delivery, and an invoice states the supplier claim. Neither estimates nor an invoice alone establish entitlement. This is the business problem; do not invent market-size or loss statistics. Source: prompt/prompt.md; demo/fixtures/scenario-a-inflated.pdf. The pictured record is fictional.</a:t>
+              <a:t>0:40–1:30. A bill of quantities lists approved quantities. A purchase order records what was ordered and at what rate. A delivery receipt records accepted supply. An invoice states what the supplier wants to be paid. These records answer different questions. The invoice alone cannot prove that goods arrived or that the amount is authorized. Point to the pictured fictional invoice, then explain that the app keeps the original file and its source references. Uploaded words such as approved do not grant authority. Sources: prompt/prompt.md; demo/fixtures/scenario-a-inflated.pdf; docs/financial-rules.md.</a:t>
             </a:r>
           </a:p>
         </p:txBody>
@@ -590,7 +590,7 @@
           <a:lstStyle xmlns:a="http://schemas.openxmlformats.org/drawingml/2006/main"/>
           <a:p xmlns:a="http://schemas.openxmlformats.org/drawingml/2006/main">
             <a:r>
-              <a:t>1:30–2:20. Two independent tests are required: is the supplier entitled to the claimed amount, and can the company preserve its cash reserve? The stress project has BDT 150,000 and a valid BDT 70,000 claim, leaving BDT 80,000 versus a BDT 100,000 reserve. The screenshot is a separate actual browser test run. Sources: submission/execution-evidence/scenario-e.json and screenshots/05-cashflow.png.</a:t>
+              <a:t>1:30–2:20. A valid invoice can still be unsafe to pay today. The app checks recorded cash and daily forecasts. Both the base forecast and the delayed-customer-receipts forecast must keep the required reserve. In the stress example, cash is BDT 150,000 and the invoice is 70,000. Paying would leave 80,000, below the 100,000 reserve, so payment is blocked. Future expected receipts are not cash already received. Explain the three visible scenarios and the matching daily table. The pictured chart comes from a separate actual test run. Sources: scenario-e.json; screenshots/05-cashflow.png; docs/financial-rules.md.</a:t>
             </a:r>
           </a:p>
         </p:txBody>
@@ -660,7 +660,7 @@
           <a:lstStyle xmlns:a="http://schemas.openxmlformats.org/drawingml/2006/main"/>
           <a:p xmlns:a="http://schemas.openxmlformats.org/drawingml/2006/main">
             <a:r>
-              <a:t>2:20–3:15. Explain the actual persisted workflow. Intake and extraction read actual files; matching, risk and cash flow invoke deterministic services; a successful workflow prepares and reserves a proposal and pauses for a different human. Execution occurs only via an explicit authenticated API action. Audit evidence records each transition. Sources: backend/app/workflow.py; technical-documentation.md; actual scenario A/B workflow steps.</a:t>
+              <a:t>2:20–3:15. Follow the saved steps from documents to payment. The app reads actual files, compares approved records and checks risks and cash using fixed rules. If everything passes, it prepares an exact proposal and reserves the required cash and delivery quantity. It then waits. A different authorized person must review and approve. Execution needs another explicit confirmation and fresh checks. A failed transaction rolls back its financial changes. The receipt, ledger and audit provide evidence of the outcome. Pause at the approval stage to emphasize that automation cannot cross it. Sources: backend/app/workflow.py; docs/technical-documentation.md; scenarios A and B.</a:t>
             </a:r>
           </a:p>
         </p:txBody>
@@ -730,7 +730,7 @@
           <a:lstStyle xmlns:a="http://schemas.openxmlformats.org/drawingml/2006/main"/>
           <a:p xmlns:a="http://schemas.openxmlformats.org/drawingml/2006/main">
             <a:r>
-              <a:t>3:15–4:10. The UI calls FastAPI with database-enforced identity and project access. The persisted state machine invokes deterministic engines. Approval and execution are separate human actions. SQLite commits payment, cash, subledger and success audit evidence atomically. Optional Ollama prose has no payment credentials or write tools. The diagram consists of editable native slide objects. Source: docs/architecture.mmd and actual backend source.</a:t>
+              <a:t>3:15–4:10. The browser has fourteen connected areas. It sends requests to FastAPI, which checks login, current role and project access. Saved workflows call document, quantity, pricing and finance services. The server uses Decimal calculations and stores money as integer minor units. SQLite keeps the records and private files keep the source evidence. Payment, cash, ledger and success audit are saved in one transaction. Optional AI only explains evidence and falls back to built-in text if unavailable. It cannot approve or execute. Point through the diagram and answer where the human decision sits. Sources: docs/architecture.md; docs/architecture.mmd; backend source.</a:t>
             </a:r>
           </a:p>
         </p:txBody>
@@ -800,7 +800,7 @@
           <a:lstStyle xmlns:a="http://schemas.openxmlformats.org/drawingml/2006/main"/>
           <a:p xmlns:a="http://schemas.openxmlformats.org/drawingml/2006/main">
             <a:r>
-              <a:t>4:10–5:30. Walk through Scenario A. BOQ, PO and accepted delivery each support 80 tonnes; invoice claims 95 tonnes at BDT 70,000/tonne. Supported amount is 5,600,000; claim is 6,650,000; excess is 1,050,000 and 18.75%. Deterministic blocking findings prevent preparation/settlement. The screenshot comes from an actual UI run, and the separate HTTP evidence reproduces the same amounts. Source: submission/execution-evidence/scenario-a.json; screenshots/02-inflated-invoice.png.</a:t>
+              <a:t>4:10–5:30. Walk through the table slowly. Approved quantities, the order and accepted delivery each support 80 tonnes. The invoice claims 95 at BDT 70,000 per tonne. Supported value is 5,600,000 and the claim is 6,650,000. Subtracting gives 1,050,000. The extra 15 tonnes divided by 80 gives 18.75 percent. The app blocks the unsupported claim and shows the source comparison. Point to the actual UI screenshot and explain its kilogram display conversion. No delivery quantity is consumed by a blocked invoice. The screenshot and HTTP evidence are separate runs with the same verified arithmetic. Sources: scenario-a.json; screenshots/08-four-way-focus.png; docs/financial-rules.md.</a:t>
             </a:r>
           </a:p>
         </p:txBody>
@@ -870,7 +870,7 @@
           <a:lstStyle xmlns:a="http://schemas.openxmlformats.org/drawingml/2006/main"/>
           <a:p xmlns:a="http://schemas.openxmlformats.org/drawingml/2006/main">
             <a:r>
-              <a:t>5:30–6:40. A separate compliant cement invoice passes all checks. Operator prepares; a different Finance Manager approves BDT 70,000; a human explicitly confirms simulated execution. Cash changes from 1,000,000 to 930,000 once. Scenario H retries the exact execution and returns the same receipt with one deduction. Screenshot and HTTP evidence are separate runs; their unique mock references are expected to differ. Sources: scenario-b.json, scenario-h.json, and screenshots/04-mock-receipt.png.</a:t>
+              <a:t>5:30–6:40. The separate cement invoice passes the quantity, price, supplier and cash checks. An Operator prepares it and a different Finance Manager approves BDT 70,000. A person confirms execution. Cash changes from 1,000,000 to 930,000 once. The mock receipt identifies the simulation. Explain the retry rule: the same request key returns the same result instead of another cash deduction. Amount and beneficiary come from the approval, not a new browser value. All financial updates either save together or roll back together. The receipt screenshot and HTTP scenarios have different run IDs. Sources: scenario-b.json; scenario-h.json; screenshots/09-receipt-focus.png.</a:t>
             </a:r>
           </a:p>
         </p:txBody>
@@ -940,7 +940,7 @@
           <a:lstStyle xmlns:a="http://schemas.openxmlformats.org/drawingml/2006/main"/>
           <a:p xmlns:a="http://schemas.openxmlformats.org/drawingml/2006/main">
             <a:r>
-              <a:t>6:40–7:50. Permission tiers, project access, independent approval, exact snapshots, current cash checks, receipt allocations and mandatory idempotency are implemented. Report only executed counts: 191 backend tests, 8 frontend tests, 16 browser workflows and 8 HTTP scenarios. Fresh Windows installation also passed. The audit chain is local tamper evidence; unrestricted DB administrators could rewrite it. Sources: docs/test-results.md, execution-evidence logs, clean-install.json, scenario manifests, and security-self-assessment.md.</a:t>
+              <a:t>6:40–7:50. The table shows actual local results: 203 backend tests, 8 frontend tests, 16 browser workflows and eight original HTTP scenarios. Separate public-demo checks verify four documented logins and preserve the private profile. Tests cover denied roles, changed approvals, expiry, duplicate quantities, competing execution, rollback and retries. Fresh installation checks use a source copy. A passing suite is evidence for tested behavior, not complete security assurance. The audit chain can find inconsistent retained events, but a full database owner can rewrite it. Independent security and assistive-technology reviews remain separate. Sources: verification-summary.json; test logs; public-demo-install.json; docs/security-self-assessment.md.</a:t>
             </a:r>
           </a:p>
         </p:txBody>
@@ -1010,7 +1010,7 @@
           <a:lstStyle xmlns:a="http://schemas.openxmlformats.org/drawingml/2006/main"/>
           <a:p xmlns:a="http://schemas.openxmlformats.org/drawingml/2006/main">
             <a:r>
-              <a:t>7:50–8:50. Show the fictional estimate example: 20 tonnes at 70,000 increases to 74,000 per tonne. Cost increases by 80,000, the scheduled forecast falls from 600,000 to 520,000, and recorded cash remains 2,000,000. Explain component mapping, separately reviewed certificates and corrections, and protected PO amendments. Actual browser and API evidence support these workflows. Paid provider acceptance, representative Bengali documents, professional rule approval, platform checks and team submission remain external gates. Sources: docs/completion-verification.md; screenshots/upgrade-price-comparison.png; execution-evidence/verification-summary.json.</a:t>
+              <a:t>7:50–8:50. In the fictional upgrade project, 20 tonnes at 70,000 cost 1,400,000. Selecting an eligible 74,000 rate changes cost to 1,480,000, an increase of 80,000. The scheduled cash forecast drops from 600,000 to 520,000, but recorded cash stays 2,000,000. The wrong grade cannot be selected. A different Manager checks the estimate and a separate Admin approves. Other areas cover quantities, accounting, contracts, installments and separate correction reviews. Paid search, real documents and professional acceptance need their own evidence. The public demo and complete source are available through the README and authorized GitHub repository. Sources: docs/completion-verification.md; upgrade screenshots; verification-summary.json; README.md.</a:t>
             </a:r>
           </a:p>
         </p:txBody>
@@ -1057,7 +1057,7 @@
           <p:cNvPr id="3" name="Title">
             <a:extLst xmlns:a="http://schemas.openxmlformats.org/drawingml/2006/main">
               <a:ext uri="{FF2B5EF4-FFF2-40B4-BE49-F238E27FC236}">
-                <a16:creationId xmlns:a16="http://schemas.microsoft.com/office/drawing/2014/main" id="{608DDAB3-124A-4442-9595-DD55FB38FCC4}"/>
+                <a16:creationId xmlns:a16="http://schemas.microsoft.com/office/drawing/2014/main" id="{B52A263E-5E9A-493B-92F7-B39291E64F3C}"/>
               </a:ext>
             </a:extLst>
           </p:cNvPr>
@@ -1286,7 +1286,7 @@
           <p:cNvPr id="2" name="Subtitle">
             <a:extLst xmlns:a="http://schemas.openxmlformats.org/drawingml/2006/main">
               <a:ext uri="{FF2B5EF4-FFF2-40B4-BE49-F238E27FC236}">
-                <a16:creationId xmlns:a16="http://schemas.microsoft.com/office/drawing/2014/main" id="{CE55DA66-92BD-47CF-AF49-28DE7E064787}"/>
+                <a16:creationId xmlns:a16="http://schemas.microsoft.com/office/drawing/2014/main" id="{53090934-090A-4334-B810-670DBBF4D457}"/>
               </a:ext>
             </a:extLst>
           </p:cNvPr>
@@ -1532,7 +1532,7 @@
           <p:cNvPr id="2" name="Section title">
             <a:extLst xmlns:a="http://schemas.openxmlformats.org/drawingml/2006/main">
               <a:ext uri="{FF2B5EF4-FFF2-40B4-BE49-F238E27FC236}">
-                <a16:creationId xmlns:a16="http://schemas.microsoft.com/office/drawing/2014/main" id="{1CE75E5F-148E-4100-800F-1CE380688E8D}"/>
+                <a16:creationId xmlns:a16="http://schemas.microsoft.com/office/drawing/2014/main" id="{261F47D0-E9B6-4502-B8A7-93ADD13D9F85}"/>
               </a:ext>
             </a:extLst>
           </p:cNvPr>
@@ -1778,7 +1778,7 @@
           <p:cNvPr id="3" name="Title">
             <a:extLst xmlns:a="http://schemas.openxmlformats.org/drawingml/2006/main">
               <a:ext uri="{FF2B5EF4-FFF2-40B4-BE49-F238E27FC236}">
-                <a16:creationId xmlns:a16="http://schemas.microsoft.com/office/drawing/2014/main" id="{5215FD9F-D152-4717-A703-CC620FFCAC95}"/>
+                <a16:creationId xmlns:a16="http://schemas.microsoft.com/office/drawing/2014/main" id="{731AF13F-DEC5-4210-A3DC-CB13CFB31513}"/>
               </a:ext>
             </a:extLst>
           </p:cNvPr>
@@ -2007,7 +2007,7 @@
           <p:cNvPr id="2" name="Body">
             <a:extLst xmlns:a="http://schemas.openxmlformats.org/drawingml/2006/main">
               <a:ext uri="{FF2B5EF4-FFF2-40B4-BE49-F238E27FC236}">
-                <a16:creationId xmlns:a16="http://schemas.microsoft.com/office/drawing/2014/main" id="{EE738D53-CCDE-46B5-A2A8-4965300F9589}"/>
+                <a16:creationId xmlns:a16="http://schemas.microsoft.com/office/drawing/2014/main" id="{862CCFEF-C2B6-439C-96A2-CAA0E9CD0B8F}"/>
               </a:ext>
             </a:extLst>
           </p:cNvPr>
@@ -2253,7 +2253,7 @@
           <p:cNvPr id="4" name="Title">
             <a:extLst xmlns:a="http://schemas.openxmlformats.org/drawingml/2006/main">
               <a:ext uri="{FF2B5EF4-FFF2-40B4-BE49-F238E27FC236}">
-                <a16:creationId xmlns:a16="http://schemas.microsoft.com/office/drawing/2014/main" id="{79A9929F-A605-43BD-9ECC-CD8A46A11FC9}"/>
+                <a16:creationId xmlns:a16="http://schemas.microsoft.com/office/drawing/2014/main" id="{5D2A09D4-A12E-4C98-BB51-6AAE0E7BBD95}"/>
               </a:ext>
             </a:extLst>
           </p:cNvPr>
@@ -2482,7 +2482,7 @@
           <p:cNvPr id="2" name="Left column">
             <a:extLst xmlns:a="http://schemas.openxmlformats.org/drawingml/2006/main">
               <a:ext uri="{FF2B5EF4-FFF2-40B4-BE49-F238E27FC236}">
-                <a16:creationId xmlns:a16="http://schemas.microsoft.com/office/drawing/2014/main" id="{5ED0FE47-D5CE-4A17-BBBB-12085F9221A3}"/>
+                <a16:creationId xmlns:a16="http://schemas.microsoft.com/office/drawing/2014/main" id="{2FCE7952-53FA-449F-88BF-0350F8911767}"/>
               </a:ext>
             </a:extLst>
           </p:cNvPr>
@@ -2711,7 +2711,7 @@
           <p:cNvPr id="3" name="Right column">
             <a:extLst xmlns:a="http://schemas.openxmlformats.org/drawingml/2006/main">
               <a:ext uri="{FF2B5EF4-FFF2-40B4-BE49-F238E27FC236}">
-                <a16:creationId xmlns:a16="http://schemas.microsoft.com/office/drawing/2014/main" id="{048899F8-41CE-4F74-B45E-D199339CA54A}"/>
+                <a16:creationId xmlns:a16="http://schemas.microsoft.com/office/drawing/2014/main" id="{DB80952B-C713-464A-AC7B-33D3D6691814}"/>
               </a:ext>
             </a:extLst>
           </p:cNvPr>
@@ -2957,7 +2957,7 @@
           <p:cNvPr id="3" name="Title">
             <a:extLst xmlns:a="http://schemas.openxmlformats.org/drawingml/2006/main">
               <a:ext uri="{FF2B5EF4-FFF2-40B4-BE49-F238E27FC236}">
-                <a16:creationId xmlns:a16="http://schemas.microsoft.com/office/drawing/2014/main" id="{98190FAA-7761-49E7-901B-DFB7F4B6B741}"/>
+                <a16:creationId xmlns:a16="http://schemas.microsoft.com/office/drawing/2014/main" id="{490C19B7-4A83-414F-AFC2-A2E6C51F3B17}"/>
               </a:ext>
             </a:extLst>
           </p:cNvPr>
@@ -3186,7 +3186,7 @@
           <p:cNvPr id="2" name="Left column">
             <a:extLst xmlns:a="http://schemas.openxmlformats.org/drawingml/2006/main">
               <a:ext uri="{FF2B5EF4-FFF2-40B4-BE49-F238E27FC236}">
-                <a16:creationId xmlns:a16="http://schemas.microsoft.com/office/drawing/2014/main" id="{D32FB4BA-1749-4919-B2AA-82461B28AEF6}"/>
+                <a16:creationId xmlns:a16="http://schemas.microsoft.com/office/drawing/2014/main" id="{00D46A3C-8BC9-416D-978B-3E6BA017F64E}"/>
               </a:ext>
             </a:extLst>
           </p:cNvPr>
@@ -3453,12 +3453,12 @@
   </p:cSld>
   <p:clrMap bg1="lt1" tx1="dk1" bg2="lt2" tx2="dk2" accent1="accent1" accent2="accent2" accent3="accent3" accent4="accent4" accent5="accent5" accent6="accent6" hlink="hlink" folHlink="folHlink"/>
   <p:sldLayoutIdLst>
-    <p:sldLayoutId xmlns:r="http://schemas.openxmlformats.org/officeDocument/2006/relationships" id="2147483649" r:id="Re6ab2b6dd65042ac"/>
-    <p:sldLayoutId xmlns:r="http://schemas.openxmlformats.org/officeDocument/2006/relationships" id="2147483650" r:id="R16a26a67a1d0467b"/>
-    <p:sldLayoutId xmlns:r="http://schemas.openxmlformats.org/officeDocument/2006/relationships" id="2147483651" r:id="Rbc0b5a48117d44f2"/>
-    <p:sldLayoutId xmlns:r="http://schemas.openxmlformats.org/officeDocument/2006/relationships" id="2147483652" r:id="R527ea52913a141d3"/>
-    <p:sldLayoutId xmlns:r="http://schemas.openxmlformats.org/officeDocument/2006/relationships" id="2147483653" r:id="Re9fa841d150f47d9"/>
-    <p:sldLayoutId xmlns:r="http://schemas.openxmlformats.org/officeDocument/2006/relationships" id="2147483654" r:id="R1691dfbd69e24f98"/>
+    <p:sldLayoutId xmlns:r="http://schemas.openxmlformats.org/officeDocument/2006/relationships" id="2147483649" r:id="Rbc2fb3c6620349c6"/>
+    <p:sldLayoutId xmlns:r="http://schemas.openxmlformats.org/officeDocument/2006/relationships" id="2147483650" r:id="R7cea6afc74ea414b"/>
+    <p:sldLayoutId xmlns:r="http://schemas.openxmlformats.org/officeDocument/2006/relationships" id="2147483651" r:id="R3375d2c0d3014eb6"/>
+    <p:sldLayoutId xmlns:r="http://schemas.openxmlformats.org/officeDocument/2006/relationships" id="2147483652" r:id="R5afa493950a144f9"/>
+    <p:sldLayoutId xmlns:r="http://schemas.openxmlformats.org/officeDocument/2006/relationships" id="2147483653" r:id="R6e6d392db45f4b82"/>
+    <p:sldLayoutId xmlns:r="http://schemas.openxmlformats.org/officeDocument/2006/relationships" id="2147483654" r:id="R486cba07fee847a4"/>
   </p:sldLayoutIdLst>
   <p:txStyles>
     <p:titleStyle>
@@ -4009,7 +4009,7 @@
           <p:cNvPr id="7" name="">
             <a:extLst xmlns:a="http://schemas.openxmlformats.org/drawingml/2006/main">
               <a:ext uri="{FF2B5EF4-FFF2-40B4-BE49-F238E27FC236}">
-                <a16:creationId xmlns:a16="http://schemas.microsoft.com/office/drawing/2014/main" id="{48BE55FA-3321-42D8-929F-345633AAF0ED}"/>
+                <a16:creationId xmlns:a16="http://schemas.microsoft.com/office/drawing/2014/main" id="{48194833-FC63-4B0C-837F-D2EC208CB376}"/>
               </a:ext>
             </a:extLst>
           </p:cNvPr>
@@ -4165,7 +4165,7 @@
           <p:cNvPr id="2" name="">
             <a:extLst xmlns:a="http://schemas.openxmlformats.org/drawingml/2006/main">
               <a:ext uri="{FF2B5EF4-FFF2-40B4-BE49-F238E27FC236}">
-                <a16:creationId xmlns:a16="http://schemas.microsoft.com/office/drawing/2014/main" id="{952D755D-9327-4A82-BC4C-11E93EFF1960}"/>
+                <a16:creationId xmlns:a16="http://schemas.microsoft.com/office/drawing/2014/main" id="{BA44E41E-3E84-4E91-A482-95F0E6128184}"/>
               </a:ext>
             </a:extLst>
           </p:cNvPr>
@@ -4321,7 +4321,7 @@
           <p:cNvPr id="3" name="">
             <a:extLst xmlns:a="http://schemas.openxmlformats.org/drawingml/2006/main">
               <a:ext uri="{FF2B5EF4-FFF2-40B4-BE49-F238E27FC236}">
-                <a16:creationId xmlns:a16="http://schemas.microsoft.com/office/drawing/2014/main" id="{5D307183-C7A0-4C1E-A3D7-146F7B51322B}"/>
+                <a16:creationId xmlns:a16="http://schemas.microsoft.com/office/drawing/2014/main" id="{4878567F-9532-4D7E-AD3A-0B58015C631F}"/>
               </a:ext>
             </a:extLst>
           </p:cNvPr>
@@ -4477,7 +4477,7 @@
           <p:cNvPr id="4" name="">
             <a:extLst xmlns:a="http://schemas.openxmlformats.org/drawingml/2006/main">
               <a:ext uri="{FF2B5EF4-FFF2-40B4-BE49-F238E27FC236}">
-                <a16:creationId xmlns:a16="http://schemas.microsoft.com/office/drawing/2014/main" id="{460F9788-8291-4F76-828B-887EFD7EFE3F}"/>
+                <a16:creationId xmlns:a16="http://schemas.microsoft.com/office/drawing/2014/main" id="{8A1EA08A-9BC5-4530-AF11-102E88FE8A60}"/>
               </a:ext>
             </a:extLst>
           </p:cNvPr>
@@ -4623,7 +4623,7 @@
                 <a:ea typeface="Arial"/>
                 <a:cs typeface="Arial"/>
               </a:rPr>
-              <a:t>An autonomous construction</a:t>
+              <a:t>Construction costs</a:t>
             </a:r>
           </a:p>
           <a:p xmlns:a="http://schemas.openxmlformats.org/drawingml/2006/main">
@@ -4646,7 +4646,7 @@
                 <a:ea typeface="Arial"/>
                 <a:cs typeface="Arial"/>
               </a:rPr>
-              <a:t>finance copilot</a:t>
+              <a:t>and payment review</a:t>
             </a:r>
           </a:p>
         </p:txBody>
@@ -4656,7 +4656,7 @@
           <p:cNvPr id="5" name="">
             <a:extLst xmlns:a="http://schemas.openxmlformats.org/drawingml/2006/main">
               <a:ext uri="{FF2B5EF4-FFF2-40B4-BE49-F238E27FC236}">
-                <a16:creationId xmlns:a16="http://schemas.microsoft.com/office/drawing/2014/main" id="{ABE693D1-6879-4A78-90BD-D40179ACB657}"/>
+                <a16:creationId xmlns:a16="http://schemas.microsoft.com/office/drawing/2014/main" id="{89BD5237-8DA1-4436-82FB-9DC9DBE315EC}"/>
               </a:ext>
             </a:extLst>
           </p:cNvPr>
@@ -4802,7 +4802,7 @@
                 <a:ea typeface="Arial"/>
                 <a:cs typeface="Arial"/>
               </a:rPr>
-              <a:t>From Construction Documents to Secure Financial Decisions.</a:t>
+              <a:t>Clear evidence for construction finance.</a:t>
             </a:r>
           </a:p>
         </p:txBody>
@@ -4812,7 +4812,7 @@
           <p:cNvPr id="6" name="">
             <a:extLst xmlns:a="http://schemas.openxmlformats.org/drawingml/2006/main">
               <a:ext uri="{FF2B5EF4-FFF2-40B4-BE49-F238E27FC236}">
-                <a16:creationId xmlns:a16="http://schemas.microsoft.com/office/drawing/2014/main" id="{4C56B03E-28A9-404A-B76D-3C9DC09FD205}"/>
+                <a16:creationId xmlns:a16="http://schemas.microsoft.com/office/drawing/2014/main" id="{0AAF9841-5103-42DE-8709-71C143609E3B}"/>
               </a:ext>
             </a:extLst>
           </p:cNvPr>
@@ -4966,7 +4966,7 @@
     </p:spTree>
     <p:extLst>
       <p:ext uri="{BB962C8B-B14F-4D97-AF65-F5344CB8AC3E}">
-        <p14:creationId xmlns:p14="http://schemas.microsoft.com/office/powerpoint/2010/main" val="442195914"/>
+        <p14:creationId xmlns:p14="http://schemas.microsoft.com/office/powerpoint/2010/main" val="1828050"/>
       </p:ext>
     </p:extLst>
   </p:cSld>
@@ -4997,7 +4997,7 @@
           <p:cNvPr id="7" name="">
             <a:extLst xmlns:a="http://schemas.openxmlformats.org/drawingml/2006/main">
               <a:ext uri="{FF2B5EF4-FFF2-40B4-BE49-F238E27FC236}">
-                <a16:creationId xmlns:a16="http://schemas.microsoft.com/office/drawing/2014/main" id="{19B9C7F1-483A-4775-B9C4-7F98D83291A1}"/>
+                <a16:creationId xmlns:a16="http://schemas.microsoft.com/office/drawing/2014/main" id="{1F3DE603-7397-4656-B2A4-430469666B9D}"/>
               </a:ext>
             </a:extLst>
           </p:cNvPr>
@@ -5143,7 +5143,7 @@
                 <a:ea typeface="Arial"/>
                 <a:cs typeface="Arial"/>
               </a:rPr>
-              <a:t>The construction payment problem</a:t>
+              <a:t>Four records before payment</a:t>
             </a:r>
           </a:p>
         </p:txBody>
@@ -5153,7 +5153,7 @@
           <p:cNvPr id="2" name="">
             <a:extLst xmlns:a="http://schemas.openxmlformats.org/drawingml/2006/main">
               <a:ext uri="{FF2B5EF4-FFF2-40B4-BE49-F238E27FC236}">
-                <a16:creationId xmlns:a16="http://schemas.microsoft.com/office/drawing/2014/main" id="{9E979C27-FC66-4397-ABDF-3542BE3A88C5}"/>
+                <a16:creationId xmlns:a16="http://schemas.microsoft.com/office/drawing/2014/main" id="{B97CF7A3-1910-4B6C-B3AA-95409390DA18}"/>
               </a:ext>
             </a:extLst>
           </p:cNvPr>
@@ -5309,7 +5309,7 @@
           <p:cNvPr id="3" name="">
             <a:extLst xmlns:a="http://schemas.openxmlformats.org/drawingml/2006/main">
               <a:ext uri="{FF2B5EF4-FFF2-40B4-BE49-F238E27FC236}">
-                <a16:creationId xmlns:a16="http://schemas.microsoft.com/office/drawing/2014/main" id="{A43FA7D3-09AF-4678-AF82-BF642ACEA77D}"/>
+                <a16:creationId xmlns:a16="http://schemas.microsoft.com/office/drawing/2014/main" id="{325880C5-E2C1-4D6E-A627-BB80D33823CD}"/>
               </a:ext>
             </a:extLst>
           </p:cNvPr>
@@ -5465,7 +5465,7 @@
           <p:cNvPr id="4" name="">
             <a:extLst xmlns:a="http://schemas.openxmlformats.org/drawingml/2006/main">
               <a:ext uri="{FF2B5EF4-FFF2-40B4-BE49-F238E27FC236}">
-                <a16:creationId xmlns:a16="http://schemas.microsoft.com/office/drawing/2014/main" id="{4F4A043C-B21E-41E3-81A9-357FC3A94A81}"/>
+                <a16:creationId xmlns:a16="http://schemas.microsoft.com/office/drawing/2014/main" id="{7F3CFBA6-584A-49B7-A560-135032179392}"/>
               </a:ext>
             </a:extLst>
           </p:cNvPr>
@@ -5611,7 +5611,7 @@
                 <a:ea typeface="Arial"/>
                 <a:cs typeface="Arial"/>
               </a:rPr>
-              <a:t>Evidence for supplier entitlement</a:t>
+              <a:t>The records must agree</a:t>
             </a:r>
           </a:p>
         </p:txBody>
@@ -5621,7 +5621,7 @@
           <p:cNvPr id="5" name="">
             <a:extLst xmlns:a="http://schemas.openxmlformats.org/drawingml/2006/main">
               <a:ext uri="{FF2B5EF4-FFF2-40B4-BE49-F238E27FC236}">
-                <a16:creationId xmlns:a16="http://schemas.microsoft.com/office/drawing/2014/main" id="{20AEEA5F-7B55-49DB-85AF-D2A3F5AE265C}"/>
+                <a16:creationId xmlns:a16="http://schemas.microsoft.com/office/drawing/2014/main" id="{667602D9-C0E7-460E-83F9-0A58F5BF363D}"/>
               </a:ext>
             </a:extLst>
           </p:cNvPr>
@@ -5767,7 +5767,7 @@
                 <a:ea typeface="Arial"/>
                 <a:cs typeface="Arial"/>
               </a:rPr>
-              <a:t>A purchase order establishes the contract.</a:t>
+              <a:t>BOQ: the approved quantities.</a:t>
             </a:r>
           </a:p>
           <a:p xmlns:a="http://schemas.openxmlformats.org/drawingml/2006/main">
@@ -5795,7 +5795,7 @@
                 <a:ea typeface="Arial"/>
                 <a:cs typeface="Arial"/>
               </a:rPr>
-              <a:t>An accepted receipt supports entitlement.</a:t>
+              <a:t>PO and receipt: order and delivery.</a:t>
             </a:r>
           </a:p>
           <a:p xmlns:a="http://schemas.openxmlformats.org/drawingml/2006/main">
@@ -5823,7 +5823,7 @@
                 <a:ea typeface="Arial"/>
                 <a:cs typeface="Arial"/>
               </a:rPr>
-              <a:t>An invoice still needs verification.</a:t>
+              <a:t>Invoice: a claim to check.</a:t>
             </a:r>
           </a:p>
         </p:txBody>
@@ -5833,7 +5833,7 @@
           <p:cNvPr id="6" name="">
             <a:extLst xmlns:a="http://schemas.openxmlformats.org/drawingml/2006/main">
               <a:ext uri="{FF2B5EF4-FFF2-40B4-BE49-F238E27FC236}">
-                <a16:creationId xmlns:a16="http://schemas.microsoft.com/office/drawing/2014/main" id="{08A8B003-ABA0-4689-B70F-3ACDF4890EC7}"/>
+                <a16:creationId xmlns:a16="http://schemas.microsoft.com/office/drawing/2014/main" id="{7C8B180E-07CF-45B6-8302-465C899E8D33}"/>
               </a:ext>
             </a:extLst>
           </p:cNvPr>
@@ -5843,7 +5843,7 @@
           <p:nvPr/>
         </p:nvPicPr>
         <p:blipFill>
-          <a:blip xmlns:r="http://schemas.openxmlformats.org/officeDocument/2006/relationships" xmlns:a="http://schemas.openxmlformats.org/drawingml/2006/main" r:embed="R418b003ba5df48e1"/>
+          <a:blip xmlns:r="http://schemas.openxmlformats.org/officeDocument/2006/relationships" xmlns:a="http://schemas.openxmlformats.org/drawingml/2006/main" r:embed="R8fab77e03271484b"/>
           <a:stretch xmlns:a="http://schemas.openxmlformats.org/drawingml/2006/main"/>
         </p:blipFill>
         <p:spPr>
@@ -5859,7 +5859,7 @@
     </p:spTree>
     <p:extLst>
       <p:ext uri="{BB962C8B-B14F-4D97-AF65-F5344CB8AC3E}">
-        <p14:creationId xmlns:p14="http://schemas.microsoft.com/office/powerpoint/2010/main" val="396363806"/>
+        <p14:creationId xmlns:p14="http://schemas.microsoft.com/office/powerpoint/2010/main" val="1365824496"/>
       </p:ext>
     </p:extLst>
   </p:cSld>
@@ -5890,7 +5890,7 @@
           <p:cNvPr id="9" name="">
             <a:extLst xmlns:a="http://schemas.openxmlformats.org/drawingml/2006/main">
               <a:ext uri="{FF2B5EF4-FFF2-40B4-BE49-F238E27FC236}">
-                <a16:creationId xmlns:a16="http://schemas.microsoft.com/office/drawing/2014/main" id="{D1433A3E-5D06-49E7-AF8F-FFAD29920685}"/>
+                <a16:creationId xmlns:a16="http://schemas.microsoft.com/office/drawing/2014/main" id="{9FA9DE71-96B4-459D-B10C-68EE9139A870}"/>
               </a:ext>
             </a:extLst>
           </p:cNvPr>
@@ -6036,7 +6036,7 @@
                 <a:ea typeface="Arial"/>
                 <a:cs typeface="Arial"/>
               </a:rPr>
-              <a:t>Entitlement and liquidity</a:t>
+              <a:t>Cash and the minimum reserve</a:t>
             </a:r>
           </a:p>
         </p:txBody>
@@ -6046,7 +6046,7 @@
           <p:cNvPr id="2" name="">
             <a:extLst xmlns:a="http://schemas.openxmlformats.org/drawingml/2006/main">
               <a:ext uri="{FF2B5EF4-FFF2-40B4-BE49-F238E27FC236}">
-                <a16:creationId xmlns:a16="http://schemas.microsoft.com/office/drawing/2014/main" id="{04D8F6FA-E9B3-4D83-A255-743AF7938EE0}"/>
+                <a16:creationId xmlns:a16="http://schemas.microsoft.com/office/drawing/2014/main" id="{DE32EF21-9C54-4B41-A419-C4067FBF95D3}"/>
               </a:ext>
             </a:extLst>
           </p:cNvPr>
@@ -6202,7 +6202,7 @@
           <p:cNvPr id="3" name="">
             <a:extLst xmlns:a="http://schemas.openxmlformats.org/drawingml/2006/main">
               <a:ext uri="{FF2B5EF4-FFF2-40B4-BE49-F238E27FC236}">
-                <a16:creationId xmlns:a16="http://schemas.microsoft.com/office/drawing/2014/main" id="{E78FC33C-9C98-41B8-BF7A-59836767AB3D}"/>
+                <a16:creationId xmlns:a16="http://schemas.microsoft.com/office/drawing/2014/main" id="{665A47B4-84AD-4C85-84FE-D299C8EAB6C7}"/>
               </a:ext>
             </a:extLst>
           </p:cNvPr>
@@ -6358,7 +6358,7 @@
           <p:cNvPr id="4" name="">
             <a:extLst xmlns:a="http://schemas.openxmlformats.org/drawingml/2006/main">
               <a:ext uri="{FF2B5EF4-FFF2-40B4-BE49-F238E27FC236}">
-                <a16:creationId xmlns:a16="http://schemas.microsoft.com/office/drawing/2014/main" id="{5E25C8CE-4D88-4AB2-BB4B-841788EFB743}"/>
+                <a16:creationId xmlns:a16="http://schemas.microsoft.com/office/drawing/2014/main" id="{A8706D6E-2114-46A7-B9DD-4E0357A5301A}"/>
               </a:ext>
             </a:extLst>
           </p:cNvPr>
@@ -6504,7 +6504,7 @@
                 <a:ea typeface="Arial"/>
                 <a:cs typeface="Arial"/>
               </a:rPr>
-              <a:t>A valid invoice can still</a:t>
+              <a:t>A correct invoice may</a:t>
             </a:r>
           </a:p>
           <a:p xmlns:a="http://schemas.openxmlformats.org/drawingml/2006/main">
@@ -6527,7 +6527,7 @@
                 <a:ea typeface="Arial"/>
                 <a:cs typeface="Arial"/>
               </a:rPr>
-              <a:t>be unsafe to pay today.</a:t>
+              <a:t>need to wait for cash.</a:t>
             </a:r>
           </a:p>
         </p:txBody>
@@ -6537,7 +6537,7 @@
           <p:cNvPr id="5" name="">
             <a:extLst xmlns:a="http://schemas.openxmlformats.org/drawingml/2006/main">
               <a:ext uri="{FF2B5EF4-FFF2-40B4-BE49-F238E27FC236}">
-                <a16:creationId xmlns:a16="http://schemas.microsoft.com/office/drawing/2014/main" id="{E4857309-3DC7-486C-970A-C1ACB5B1F37B}"/>
+                <a16:creationId xmlns:a16="http://schemas.microsoft.com/office/drawing/2014/main" id="{FCD70DA3-69BD-4F09-8CF7-3FAC54FE0668}"/>
               </a:ext>
             </a:extLst>
           </p:cNvPr>
@@ -6693,7 +6693,7 @@
           <p:cNvPr id="6" name="">
             <a:extLst xmlns:a="http://schemas.openxmlformats.org/drawingml/2006/main">
               <a:ext uri="{FF2B5EF4-FFF2-40B4-BE49-F238E27FC236}">
-                <a16:creationId xmlns:a16="http://schemas.microsoft.com/office/drawing/2014/main" id="{8C4C32D7-8FFA-4903-A230-CF8D418415EB}"/>
+                <a16:creationId xmlns:a16="http://schemas.microsoft.com/office/drawing/2014/main" id="{FD091A3A-B2EA-46A8-811D-FF40723DA02E}"/>
               </a:ext>
             </a:extLst>
           </p:cNvPr>
@@ -6839,7 +6839,7 @@
                 <a:ea typeface="Arial"/>
                 <a:cs typeface="Arial"/>
               </a:rPr>
-              <a:t>Required demonstration cash reserve</a:t>
+              <a:t>Minimum cash kept in the demo</a:t>
             </a:r>
           </a:p>
         </p:txBody>
@@ -6849,7 +6849,7 @@
           <p:cNvPr id="7" name="">
             <a:extLst xmlns:a="http://schemas.openxmlformats.org/drawingml/2006/main">
               <a:ext uri="{FF2B5EF4-FFF2-40B4-BE49-F238E27FC236}">
-                <a16:creationId xmlns:a16="http://schemas.microsoft.com/office/drawing/2014/main" id="{038FB934-4A73-401F-907A-71EA67911E45}"/>
+                <a16:creationId xmlns:a16="http://schemas.microsoft.com/office/drawing/2014/main" id="{467B7CAC-999B-49C0-854A-6100FF06BEF7}"/>
               </a:ext>
             </a:extLst>
           </p:cNvPr>
@@ -6995,7 +6995,7 @@
                 <a:ea typeface="Arial"/>
                 <a:cs typeface="Arial"/>
               </a:rPr>
-              <a:t>Base and delayed receivables must pass.</a:t>
+              <a:t>Base and delayed receipts must pass.</a:t>
             </a:r>
           </a:p>
           <a:p xmlns:a="http://schemas.openxmlformats.org/drawingml/2006/main">
@@ -7018,7 +7018,7 @@
                 <a:ea typeface="Arial"/>
                 <a:cs typeface="Arial"/>
               </a:rPr>
-              <a:t>Cost-pressure scenarios remain visible.</a:t>
+              <a:t>Higher future costs show a warning.</a:t>
             </a:r>
           </a:p>
         </p:txBody>
@@ -7028,7 +7028,7 @@
           <p:cNvPr id="8" name="">
             <a:extLst xmlns:a="http://schemas.openxmlformats.org/drawingml/2006/main">
               <a:ext uri="{FF2B5EF4-FFF2-40B4-BE49-F238E27FC236}">
-                <a16:creationId xmlns:a16="http://schemas.microsoft.com/office/drawing/2014/main" id="{062701A7-57D0-4123-A289-858BCE339BEF}"/>
+                <a16:creationId xmlns:a16="http://schemas.microsoft.com/office/drawing/2014/main" id="{115799A0-B74E-40DA-80F7-F54B942F030B}"/>
               </a:ext>
             </a:extLst>
           </p:cNvPr>
@@ -7038,7 +7038,7 @@
           <p:nvPr/>
         </p:nvPicPr>
         <p:blipFill>
-          <a:blip xmlns:r="http://schemas.openxmlformats.org/officeDocument/2006/relationships" xmlns:a="http://schemas.openxmlformats.org/drawingml/2006/main" r:embed="Rb1117c1d625f4695"/>
+          <a:blip xmlns:r="http://schemas.openxmlformats.org/officeDocument/2006/relationships" xmlns:a="http://schemas.openxmlformats.org/drawingml/2006/main" r:embed="R15db016a6c684985"/>
           <a:stretch xmlns:a="http://schemas.openxmlformats.org/drawingml/2006/main"/>
         </p:blipFill>
         <p:spPr>
@@ -7054,7 +7054,7 @@
     </p:spTree>
     <p:extLst>
       <p:ext uri="{BB962C8B-B14F-4D97-AF65-F5344CB8AC3E}">
-        <p14:creationId xmlns:p14="http://schemas.microsoft.com/office/powerpoint/2010/main" val="1078242970"/>
+        <p14:creationId xmlns:p14="http://schemas.microsoft.com/office/powerpoint/2010/main" val="1138058020"/>
       </p:ext>
     </p:extLst>
   </p:cSld>
@@ -7085,7 +7085,7 @@
           <p:cNvPr id="8" name="">
             <a:extLst xmlns:a="http://schemas.openxmlformats.org/drawingml/2006/main">
               <a:ext uri="{FF2B5EF4-FFF2-40B4-BE49-F238E27FC236}">
-                <a16:creationId xmlns:a16="http://schemas.microsoft.com/office/drawing/2014/main" id="{FCC1B2BB-F3D8-4B6C-8030-8819588085DD}"/>
+                <a16:creationId xmlns:a16="http://schemas.microsoft.com/office/drawing/2014/main" id="{7E3DDD6C-F4CA-4B8C-903C-E4D645FD0E92}"/>
               </a:ext>
             </a:extLst>
           </p:cNvPr>
@@ -7231,7 +7231,7 @@
                 <a:ea typeface="Arial"/>
                 <a:cs typeface="Arial"/>
               </a:rPr>
-              <a:t>A complete financial workflow</a:t>
+              <a:t>Payment review</a:t>
             </a:r>
           </a:p>
         </p:txBody>
@@ -7241,7 +7241,7 @@
           <p:cNvPr id="2" name="">
             <a:extLst xmlns:a="http://schemas.openxmlformats.org/drawingml/2006/main">
               <a:ext uri="{FF2B5EF4-FFF2-40B4-BE49-F238E27FC236}">
-                <a16:creationId xmlns:a16="http://schemas.microsoft.com/office/drawing/2014/main" id="{A2954BB8-0176-4483-80FD-7CD181A3350D}"/>
+                <a16:creationId xmlns:a16="http://schemas.microsoft.com/office/drawing/2014/main" id="{8583D884-7AF5-4259-B1E4-178E5F6642F3}"/>
               </a:ext>
             </a:extLst>
           </p:cNvPr>
@@ -7397,7 +7397,7 @@
           <p:cNvPr id="3" name="">
             <a:extLst xmlns:a="http://schemas.openxmlformats.org/drawingml/2006/main">
               <a:ext uri="{FF2B5EF4-FFF2-40B4-BE49-F238E27FC236}">
-                <a16:creationId xmlns:a16="http://schemas.microsoft.com/office/drawing/2014/main" id="{B0EAC635-3ED1-46B7-9726-1418235C2F56}"/>
+                <a16:creationId xmlns:a16="http://schemas.microsoft.com/office/drawing/2014/main" id="{1ED94A44-B712-4047-976C-27FE4972FCCD}"/>
               </a:ext>
             </a:extLst>
           </p:cNvPr>
@@ -7553,7 +7553,7 @@
           <p:cNvPr id="4" name="">
             <a:extLst xmlns:a="http://schemas.openxmlformats.org/drawingml/2006/main">
               <a:ext uri="{FF2B5EF4-FFF2-40B4-BE49-F238E27FC236}">
-                <a16:creationId xmlns:a16="http://schemas.microsoft.com/office/drawing/2014/main" id="{A76E117D-23D4-4771-A1E2-03B7274D5823}"/>
+                <a16:creationId xmlns:a16="http://schemas.microsoft.com/office/drawing/2014/main" id="{349546BD-7B64-4592-B81C-1F636FC8E2DC}"/>
               </a:ext>
             </a:extLst>
           </p:cNvPr>
@@ -7699,7 +7699,7 @@
                 <a:ea typeface="Arial"/>
                 <a:cs typeface="Arial"/>
               </a:rPr>
-              <a:t>BOQ     +     Purchase order     +     Accepted receipt     +     Invoice</a:t>
+              <a:t>Approved quantities   +   Order   +   Delivery   +   Invoice</a:t>
             </a:r>
           </a:p>
         </p:txBody>
@@ -7709,7 +7709,7 @@
           <p:cNvPr id="5" name="">
             <a:extLst xmlns:a="http://schemas.openxmlformats.org/drawingml/2006/main">
               <a:ext uri="{FF2B5EF4-FFF2-40B4-BE49-F238E27FC236}">
-                <a16:creationId xmlns:a16="http://schemas.microsoft.com/office/drawing/2014/main" id="{74A420C4-5A08-40DC-BDEA-3A00EC10B4AD}"/>
+                <a16:creationId xmlns:a16="http://schemas.microsoft.com/office/drawing/2014/main" id="{CB50A114-7FB0-4FEF-9890-E4EC38E7F41D}"/>
               </a:ext>
             </a:extLst>
           </p:cNvPr>
@@ -7855,7 +7855,7 @@
                 <a:ea typeface="Arial"/>
                 <a:cs typeface="Arial"/>
               </a:rPr>
-              <a:t>Extract and review  →  Reconcile  →  Assess risk  →  Check liquidity</a:t>
+              <a:t>Read files  →  Compare records  →  Check risks and cash</a:t>
             </a:r>
           </a:p>
         </p:txBody>
@@ -7865,7 +7865,7 @@
           <p:cNvPr id="6" name="">
             <a:extLst xmlns:a="http://schemas.openxmlformats.org/drawingml/2006/main">
               <a:ext uri="{FF2B5EF4-FFF2-40B4-BE49-F238E27FC236}">
-                <a16:creationId xmlns:a16="http://schemas.microsoft.com/office/drawing/2014/main" id="{F69A2FE2-A9E4-4C5B-8B1B-9AFE6D055546}"/>
+                <a16:creationId xmlns:a16="http://schemas.microsoft.com/office/drawing/2014/main" id="{D2EA15CF-B697-48E7-9EED-D7D504C2A7F8}"/>
               </a:ext>
             </a:extLst>
           </p:cNvPr>
@@ -8011,7 +8011,7 @@
                 <a:ea typeface="Arial"/>
                 <a:cs typeface="Arial"/>
               </a:rPr>
-              <a:t>Prepare exact payment  →  Independent human approval</a:t>
+              <a:t>Exact proposal  →  Approval by a different person</a:t>
             </a:r>
           </a:p>
         </p:txBody>
@@ -8021,7 +8021,7 @@
           <p:cNvPr id="7" name="">
             <a:extLst xmlns:a="http://schemas.openxmlformats.org/drawingml/2006/main">
               <a:ext uri="{FF2B5EF4-FFF2-40B4-BE49-F238E27FC236}">
-                <a16:creationId xmlns:a16="http://schemas.microsoft.com/office/drawing/2014/main" id="{88DEF8F9-9A58-46DA-92AD-CBDF09B45EF0}"/>
+                <a16:creationId xmlns:a16="http://schemas.microsoft.com/office/drawing/2014/main" id="{701FBA0C-903C-49B4-9F59-2C25BCD24B59}"/>
               </a:ext>
             </a:extLst>
           </p:cNvPr>
@@ -8167,7 +8167,7 @@
                 <a:ea typeface="Arial"/>
                 <a:cs typeface="Arial"/>
               </a:rPr>
-              <a:t>Revalidate  →  Atomic sandbox settlement  →  Ledger and audit evidence</a:t>
+              <a:t>Recheck  →  Simulated payment  →  Receipt, ledger and audit</a:t>
             </a:r>
           </a:p>
         </p:txBody>
@@ -8175,7 +8175,7 @@
     </p:spTree>
     <p:extLst>
       <p:ext uri="{BB962C8B-B14F-4D97-AF65-F5344CB8AC3E}">
-        <p14:creationId xmlns:p14="http://schemas.microsoft.com/office/powerpoint/2010/main" val="167397564"/>
+        <p14:creationId xmlns:p14="http://schemas.microsoft.com/office/powerpoint/2010/main" val="550808420"/>
       </p:ext>
     </p:extLst>
   </p:cSld>
@@ -8206,7 +8206,7 @@
           <p:cNvPr id="17" name="">
             <a:extLst xmlns:a="http://schemas.openxmlformats.org/drawingml/2006/main">
               <a:ext uri="{FF2B5EF4-FFF2-40B4-BE49-F238E27FC236}">
-                <a16:creationId xmlns:a16="http://schemas.microsoft.com/office/drawing/2014/main" id="{7D03C6D8-2BA3-4BC1-9181-53CD35CD7955}"/>
+                <a16:creationId xmlns:a16="http://schemas.microsoft.com/office/drawing/2014/main" id="{F4095E7B-FF53-4EEB-817F-1C8AEA309F5D}"/>
               </a:ext>
             </a:extLst>
           </p:cNvPr>
@@ -8352,7 +8352,7 @@
                 <a:ea typeface="Arial"/>
                 <a:cs typeface="Arial"/>
               </a:rPr>
-              <a:t>System architecture</a:t>
+              <a:t>How the app works</a:t>
             </a:r>
           </a:p>
         </p:txBody>
@@ -8362,7 +8362,7 @@
           <p:cNvPr id="2" name="">
             <a:extLst xmlns:a="http://schemas.openxmlformats.org/drawingml/2006/main">
               <a:ext uri="{FF2B5EF4-FFF2-40B4-BE49-F238E27FC236}">
-                <a16:creationId xmlns:a16="http://schemas.microsoft.com/office/drawing/2014/main" id="{CE98BCF6-1C5D-4A8C-A8C0-43B6D665149E}"/>
+                <a16:creationId xmlns:a16="http://schemas.microsoft.com/office/drawing/2014/main" id="{84D16908-6B51-4681-AD0E-1CBD64F121A6}"/>
               </a:ext>
             </a:extLst>
           </p:cNvPr>
@@ -8518,7 +8518,7 @@
           <p:cNvPr id="3" name="">
             <a:extLst xmlns:a="http://schemas.openxmlformats.org/drawingml/2006/main">
               <a:ext uri="{FF2B5EF4-FFF2-40B4-BE49-F238E27FC236}">
-                <a16:creationId xmlns:a16="http://schemas.microsoft.com/office/drawing/2014/main" id="{9C5F2B92-FEB6-4B88-A36A-DFC8B6F418EE}"/>
+                <a16:creationId xmlns:a16="http://schemas.microsoft.com/office/drawing/2014/main" id="{8F26EB95-0D4B-4100-9DC3-839A83B017E0}"/>
               </a:ext>
             </a:extLst>
           </p:cNvPr>
@@ -8674,7 +8674,7 @@
           <p:cNvPr id="4" name="">
             <a:extLst xmlns:a="http://schemas.openxmlformats.org/drawingml/2006/main">
               <a:ext uri="{FF2B5EF4-FFF2-40B4-BE49-F238E27FC236}">
-                <a16:creationId xmlns:a16="http://schemas.microsoft.com/office/drawing/2014/main" id="{CB6654D9-C956-4A69-BB91-BA3B84DA993B}"/>
+                <a16:creationId xmlns:a16="http://schemas.microsoft.com/office/drawing/2014/main" id="{DD223DD7-396A-46F1-8B6C-D57379A71399}"/>
               </a:ext>
             </a:extLst>
           </p:cNvPr>
@@ -8857,7 +8857,7 @@
           <p:cNvPr id="5" name="">
             <a:extLst xmlns:a="http://schemas.openxmlformats.org/drawingml/2006/main">
               <a:ext uri="{FF2B5EF4-FFF2-40B4-BE49-F238E27FC236}">
-                <a16:creationId xmlns:a16="http://schemas.microsoft.com/office/drawing/2014/main" id="{58DFC89B-09FD-435F-AACC-8DE9A83CB9A3}"/>
+                <a16:creationId xmlns:a16="http://schemas.microsoft.com/office/drawing/2014/main" id="{1A84AFFE-6840-4870-A0A9-3E69ED9C87B8}"/>
               </a:ext>
             </a:extLst>
           </p:cNvPr>
@@ -9030,7 +9030,7 @@
                 <a:ea typeface="Arial"/>
                 <a:cs typeface="Arial"/>
               </a:rPr>
-              <a:t>Role + project authorization</a:t>
+              <a:t>Role and project checks</a:t>
             </a:r>
           </a:p>
         </p:txBody>
@@ -9040,7 +9040,7 @@
           <p:cNvPr id="6" name="">
             <a:extLst xmlns:a="http://schemas.openxmlformats.org/drawingml/2006/main">
               <a:ext uri="{FF2B5EF4-FFF2-40B4-BE49-F238E27FC236}">
-                <a16:creationId xmlns:a16="http://schemas.microsoft.com/office/drawing/2014/main" id="{96B7748B-C462-4EC6-9A26-1B0A97463E02}"/>
+                <a16:creationId xmlns:a16="http://schemas.microsoft.com/office/drawing/2014/main" id="{FF2501EF-CFA4-4EB1-B2E5-08F998994FB5}"/>
               </a:ext>
             </a:extLst>
           </p:cNvPr>
@@ -9223,7 +9223,7 @@
           <p:cNvPr id="7" name="">
             <a:extLst xmlns:a="http://schemas.openxmlformats.org/drawingml/2006/main">
               <a:ext uri="{FF2B5EF4-FFF2-40B4-BE49-F238E27FC236}">
-                <a16:creationId xmlns:a16="http://schemas.microsoft.com/office/drawing/2014/main" id="{B1A7A3D2-5FF1-4336-8AB4-CFBCE6994D8F}"/>
+                <a16:creationId xmlns:a16="http://schemas.microsoft.com/office/drawing/2014/main" id="{92B22CC5-D0B5-4475-B97C-BDBD09A02ADB}"/>
               </a:ext>
             </a:extLst>
           </p:cNvPr>
@@ -9379,7 +9379,7 @@
           <p:cNvPr id="8" name="">
             <a:extLst xmlns:a="http://schemas.openxmlformats.org/drawingml/2006/main">
               <a:ext uri="{FF2B5EF4-FFF2-40B4-BE49-F238E27FC236}">
-                <a16:creationId xmlns:a16="http://schemas.microsoft.com/office/drawing/2014/main" id="{8CBC92B2-4F2E-496A-B23D-54AFA66863B5}"/>
+                <a16:creationId xmlns:a16="http://schemas.microsoft.com/office/drawing/2014/main" id="{B09F8C49-27B8-49C8-98FA-42A724F996C6}"/>
               </a:ext>
             </a:extLst>
           </p:cNvPr>
@@ -9535,7 +9535,7 @@
           <p:cNvPr id="9" name="">
             <a:extLst xmlns:a="http://schemas.openxmlformats.org/drawingml/2006/main">
               <a:ext uri="{FF2B5EF4-FFF2-40B4-BE49-F238E27FC236}">
-                <a16:creationId xmlns:a16="http://schemas.microsoft.com/office/drawing/2014/main" id="{2B20C5FE-BCEC-4A68-AA9D-F999D91BF6B9}"/>
+                <a16:creationId xmlns:a16="http://schemas.microsoft.com/office/drawing/2014/main" id="{1A0162B6-91C4-46EC-AED9-7FD097EAA728}"/>
               </a:ext>
             </a:extLst>
           </p:cNvPr>
@@ -9685,7 +9685,7 @@
                 <a:ea typeface="Arial"/>
                 <a:cs typeface="Arial"/>
               </a:rPr>
-              <a:t>Persisted workflow</a:t>
+              <a:t>Saved workflow</a:t>
             </a:r>
           </a:p>
           <a:p xmlns:a="http://schemas.openxmlformats.org/drawingml/2006/main">
@@ -9708,7 +9708,7 @@
                 <a:ea typeface="Arial"/>
                 <a:cs typeface="Arial"/>
               </a:rPr>
-              <a:t>Typed tool steps</a:t>
+              <a:t>Steps and evidence</a:t>
             </a:r>
           </a:p>
         </p:txBody>
@@ -9718,7 +9718,7 @@
           <p:cNvPr id="10" name="">
             <a:extLst xmlns:a="http://schemas.openxmlformats.org/drawingml/2006/main">
               <a:ext uri="{FF2B5EF4-FFF2-40B4-BE49-F238E27FC236}">
-                <a16:creationId xmlns:a16="http://schemas.microsoft.com/office/drawing/2014/main" id="{9C764442-1CCD-436E-B0EF-C448ABD8A41B}"/>
+                <a16:creationId xmlns:a16="http://schemas.microsoft.com/office/drawing/2014/main" id="{3897FCB1-8B44-4269-93B3-6D730CA1140D}"/>
               </a:ext>
             </a:extLst>
           </p:cNvPr>
@@ -9868,7 +9868,7 @@
                 <a:ea typeface="Arial"/>
                 <a:cs typeface="Arial"/>
               </a:rPr>
-              <a:t>Deterministic engines</a:t>
+              <a:t>Rule-based checks</a:t>
             </a:r>
           </a:p>
           <a:p xmlns:a="http://schemas.openxmlformats.org/drawingml/2006/main">
@@ -9891,7 +9891,7 @@
                 <a:ea typeface="Arial"/>
                 <a:cs typeface="Arial"/>
               </a:rPr>
-              <a:t>Matching · risk · cash flow</a:t>
+              <a:t>Claims, risk and cash</a:t>
             </a:r>
           </a:p>
         </p:txBody>
@@ -9901,7 +9901,7 @@
           <p:cNvPr id="11" name="">
             <a:extLst xmlns:a="http://schemas.openxmlformats.org/drawingml/2006/main">
               <a:ext uri="{FF2B5EF4-FFF2-40B4-BE49-F238E27FC236}">
-                <a16:creationId xmlns:a16="http://schemas.microsoft.com/office/drawing/2014/main" id="{9301ABEB-F97E-49BB-905E-E438E9384D5F}"/>
+                <a16:creationId xmlns:a16="http://schemas.microsoft.com/office/drawing/2014/main" id="{1095626B-AF75-455A-8FA9-C89A7129F005}"/>
               </a:ext>
             </a:extLst>
           </p:cNvPr>
@@ -10074,7 +10074,7 @@
                 <a:ea typeface="Arial"/>
                 <a:cs typeface="Arial"/>
               </a:rPr>
-              <a:t>Idempotent payment</a:t>
+              <a:t>Payment record</a:t>
             </a:r>
           </a:p>
         </p:txBody>
@@ -10084,7 +10084,7 @@
           <p:cNvPr id="12" name="">
             <a:extLst xmlns:a="http://schemas.openxmlformats.org/drawingml/2006/main">
               <a:ext uri="{FF2B5EF4-FFF2-40B4-BE49-F238E27FC236}">
-                <a16:creationId xmlns:a16="http://schemas.microsoft.com/office/drawing/2014/main" id="{14B08C4A-0D4C-470D-936E-8A7505DF9FCD}"/>
+                <a16:creationId xmlns:a16="http://schemas.microsoft.com/office/drawing/2014/main" id="{134A1E08-F629-470D-9424-6420D615B324}"/>
               </a:ext>
             </a:extLst>
           </p:cNvPr>
@@ -10240,7 +10240,7 @@
           <p:cNvPr id="13" name="">
             <a:extLst xmlns:a="http://schemas.openxmlformats.org/drawingml/2006/main">
               <a:ext uri="{FF2B5EF4-FFF2-40B4-BE49-F238E27FC236}">
-                <a16:creationId xmlns:a16="http://schemas.microsoft.com/office/drawing/2014/main" id="{52423898-CA88-487E-8A3F-2E5D20786D7F}"/>
+                <a16:creationId xmlns:a16="http://schemas.microsoft.com/office/drawing/2014/main" id="{2FEBDF5B-8621-4764-9254-8717BA979FB7}"/>
               </a:ext>
             </a:extLst>
           </p:cNvPr>
@@ -10396,7 +10396,7 @@
           <p:cNvPr id="14" name="">
             <a:extLst xmlns:a="http://schemas.openxmlformats.org/drawingml/2006/main">
               <a:ext uri="{FF2B5EF4-FFF2-40B4-BE49-F238E27FC236}">
-                <a16:creationId xmlns:a16="http://schemas.microsoft.com/office/drawing/2014/main" id="{E3E00E09-F244-4623-8BAB-D8F4FD06F1BB}"/>
+                <a16:creationId xmlns:a16="http://schemas.microsoft.com/office/drawing/2014/main" id="{AB151847-D7CE-4ED1-8AE7-BEE1D15AB459}"/>
               </a:ext>
             </a:extLst>
           </p:cNvPr>
@@ -10552,7 +10552,7 @@
           <p:cNvPr id="15" name="">
             <a:extLst xmlns:a="http://schemas.openxmlformats.org/drawingml/2006/main">
               <a:ext uri="{FF2B5EF4-FFF2-40B4-BE49-F238E27FC236}">
-                <a16:creationId xmlns:a16="http://schemas.microsoft.com/office/drawing/2014/main" id="{2D2646E4-E147-422D-BBFA-526E835E56F2}"/>
+                <a16:creationId xmlns:a16="http://schemas.microsoft.com/office/drawing/2014/main" id="{00AA963D-0415-4F1F-8A04-B84ECD9D5A7A}"/>
               </a:ext>
             </a:extLst>
           </p:cNvPr>
@@ -10708,7 +10708,7 @@
           <p:cNvPr id="16" name="">
             <a:extLst xmlns:a="http://schemas.openxmlformats.org/drawingml/2006/main">
               <a:ext uri="{FF2B5EF4-FFF2-40B4-BE49-F238E27FC236}">
-                <a16:creationId xmlns:a16="http://schemas.microsoft.com/office/drawing/2014/main" id="{2DB306ED-292C-43ED-8CBF-46660436376B}"/>
+                <a16:creationId xmlns:a16="http://schemas.microsoft.com/office/drawing/2014/main" id="{11020D91-D3EE-470D-BD2A-4E8FB09A5532}"/>
               </a:ext>
             </a:extLst>
           </p:cNvPr>
@@ -10854,7 +10854,7 @@
                 <a:ea typeface="Arial"/>
                 <a:cs typeface="Arial"/>
               </a:rPr>
-              <a:t>Optional model: explanation only. Financial authority stays in deterministic code.</a:t>
+              <a:t>AI can explain the evidence. People approve financial actions.</a:t>
             </a:r>
           </a:p>
         </p:txBody>
@@ -10862,7 +10862,7 @@
     </p:spTree>
     <p:extLst>
       <p:ext uri="{BB962C8B-B14F-4D97-AF65-F5344CB8AC3E}">
-        <p14:creationId xmlns:p14="http://schemas.microsoft.com/office/powerpoint/2010/main" val="1121971990"/>
+        <p14:creationId xmlns:p14="http://schemas.microsoft.com/office/powerpoint/2010/main" val="837505189"/>
       </p:ext>
     </p:extLst>
   </p:cSld>
@@ -10893,7 +10893,7 @@
           <p:cNvPr id="8" name="">
             <a:extLst xmlns:a="http://schemas.openxmlformats.org/drawingml/2006/main">
               <a:ext uri="{FF2B5EF4-FFF2-40B4-BE49-F238E27FC236}">
-                <a16:creationId xmlns:a16="http://schemas.microsoft.com/office/drawing/2014/main" id="{D0745194-BCC4-4B23-9030-66ECBE0357F9}"/>
+                <a16:creationId xmlns:a16="http://schemas.microsoft.com/office/drawing/2014/main" id="{7E61E142-68C0-4FD0-BE7E-D87FF36A9EAC}"/>
               </a:ext>
             </a:extLst>
           </p:cNvPr>
@@ -11039,7 +11039,7 @@
                 <a:ea typeface="Arial"/>
                 <a:cs typeface="Arial"/>
               </a:rPr>
-              <a:t>Inflated steel invoice detected</a:t>
+              <a:t>An inflated steel invoice</a:t>
             </a:r>
           </a:p>
         </p:txBody>
@@ -11049,7 +11049,7 @@
           <p:cNvPr id="2" name="">
             <a:extLst xmlns:a="http://schemas.openxmlformats.org/drawingml/2006/main">
               <a:ext uri="{FF2B5EF4-FFF2-40B4-BE49-F238E27FC236}">
-                <a16:creationId xmlns:a16="http://schemas.microsoft.com/office/drawing/2014/main" id="{CDDBAE79-8810-41BF-9C4D-4EA6E0F55693}"/>
+                <a16:creationId xmlns:a16="http://schemas.microsoft.com/office/drawing/2014/main" id="{166FA854-122B-4836-BDC9-4BBC9530A0D4}"/>
               </a:ext>
             </a:extLst>
           </p:cNvPr>
@@ -11205,7 +11205,7 @@
           <p:cNvPr id="3" name="">
             <a:extLst xmlns:a="http://schemas.openxmlformats.org/drawingml/2006/main">
               <a:ext uri="{FF2B5EF4-FFF2-40B4-BE49-F238E27FC236}">
-                <a16:creationId xmlns:a16="http://schemas.microsoft.com/office/drawing/2014/main" id="{6F166BD8-43D9-4B69-86E9-CC0F2860F000}"/>
+                <a16:creationId xmlns:a16="http://schemas.microsoft.com/office/drawing/2014/main" id="{42CC9535-C223-4549-9134-76D38E469422}"/>
               </a:ext>
             </a:extLst>
           </p:cNvPr>
@@ -11361,7 +11361,7 @@
           <p:cNvPr id="4" name="">
             <a:extLst xmlns:a="http://schemas.openxmlformats.org/drawingml/2006/main">
               <a:ext uri="{FF2B5EF4-FFF2-40B4-BE49-F238E27FC236}">
-                <a16:creationId xmlns:a16="http://schemas.microsoft.com/office/drawing/2014/main" id="{7771ABFB-2E86-4C74-9F91-4C7C93324E53}"/>
+                <a16:creationId xmlns:a16="http://schemas.microsoft.com/office/drawing/2014/main" id="{7ACD7DC4-EAFA-4BDB-B5FA-BC6FE377D14D}"/>
               </a:ext>
             </a:extLst>
           </p:cNvPr>
@@ -11801,7 +11801,7 @@
           <p:cNvPr id="5" name="">
             <a:extLst xmlns:a="http://schemas.openxmlformats.org/drawingml/2006/main">
               <a:ext uri="{FF2B5EF4-FFF2-40B4-BE49-F238E27FC236}">
-                <a16:creationId xmlns:a16="http://schemas.microsoft.com/office/drawing/2014/main" id="{914E9029-AD26-467C-BB27-8329233124F4}"/>
+                <a16:creationId xmlns:a16="http://schemas.microsoft.com/office/drawing/2014/main" id="{832B394B-E0A5-45A4-912A-83A62C07879A}"/>
               </a:ext>
             </a:extLst>
           </p:cNvPr>
@@ -11957,7 +11957,7 @@
           <p:cNvPr id="6" name="">
             <a:extLst xmlns:a="http://schemas.openxmlformats.org/drawingml/2006/main">
               <a:ext uri="{FF2B5EF4-FFF2-40B4-BE49-F238E27FC236}">
-                <a16:creationId xmlns:a16="http://schemas.microsoft.com/office/drawing/2014/main" id="{A63090CC-B506-4304-A31B-438E98354501}"/>
+                <a16:creationId xmlns:a16="http://schemas.microsoft.com/office/drawing/2014/main" id="{1D6A3CED-11C2-42EA-AD34-84C2C14DD341}"/>
               </a:ext>
             </a:extLst>
           </p:cNvPr>
@@ -12103,7 +12103,7 @@
                 <a:ea typeface="Arial"/>
                 <a:cs typeface="Arial"/>
               </a:rPr>
-              <a:t>Unsupported claim  ·  18.75% variance  ·  BLOCKED</a:t>
+              <a:t>Extra claim: 18.75% above supported quantity. Payment blocked.</a:t>
             </a:r>
           </a:p>
         </p:txBody>
@@ -12113,7 +12113,7 @@
           <p:cNvPr id="7" name="">
             <a:extLst xmlns:a="http://schemas.openxmlformats.org/drawingml/2006/main">
               <a:ext uri="{FF2B5EF4-FFF2-40B4-BE49-F238E27FC236}">
-                <a16:creationId xmlns:a16="http://schemas.microsoft.com/office/drawing/2014/main" id="{8A3B03E6-516D-4FB4-9ED2-43C61F2C8D3C}"/>
+                <a16:creationId xmlns:a16="http://schemas.microsoft.com/office/drawing/2014/main" id="{76984364-1630-40BE-8F98-F28D9DF6F9AB}"/>
               </a:ext>
             </a:extLst>
           </p:cNvPr>
@@ -12123,7 +12123,7 @@
           <p:nvPr/>
         </p:nvPicPr>
         <p:blipFill>
-          <a:blip xmlns:r="http://schemas.openxmlformats.org/officeDocument/2006/relationships" xmlns:a="http://schemas.openxmlformats.org/drawingml/2006/main" r:embed="R6808a87a8ce94479"/>
+          <a:blip xmlns:r="http://schemas.openxmlformats.org/officeDocument/2006/relationships" xmlns:a="http://schemas.openxmlformats.org/drawingml/2006/main" r:embed="R44aade95ddc845b2"/>
           <a:stretch xmlns:a="http://schemas.openxmlformats.org/drawingml/2006/main"/>
         </p:blipFill>
         <p:spPr>
@@ -12139,7 +12139,7 @@
     </p:spTree>
     <p:extLst>
       <p:ext uri="{BB962C8B-B14F-4D97-AF65-F5344CB8AC3E}">
-        <p14:creationId xmlns:p14="http://schemas.microsoft.com/office/powerpoint/2010/main" val="615218654"/>
+        <p14:creationId xmlns:p14="http://schemas.microsoft.com/office/powerpoint/2010/main" val="733509236"/>
       </p:ext>
     </p:extLst>
   </p:cSld>
@@ -12170,7 +12170,7 @@
           <p:cNvPr id="10" name="">
             <a:extLst xmlns:a="http://schemas.openxmlformats.org/drawingml/2006/main">
               <a:ext uri="{FF2B5EF4-FFF2-40B4-BE49-F238E27FC236}">
-                <a16:creationId xmlns:a16="http://schemas.microsoft.com/office/drawing/2014/main" id="{74F5C2A9-7E09-4428-A341-3F37D98C37E7}"/>
+                <a16:creationId xmlns:a16="http://schemas.microsoft.com/office/drawing/2014/main" id="{09883ADE-BC4D-4FA2-97D8-1C574EAEBAC6}"/>
               </a:ext>
             </a:extLst>
           </p:cNvPr>
@@ -12316,7 +12316,7 @@
                 <a:ea typeface="Arial"/>
                 <a:cs typeface="Arial"/>
               </a:rPr>
-              <a:t>An authorized sandbox transaction</a:t>
+              <a:t>One approved payment</a:t>
             </a:r>
           </a:p>
         </p:txBody>
@@ -12326,7 +12326,7 @@
           <p:cNvPr id="2" name="">
             <a:extLst xmlns:a="http://schemas.openxmlformats.org/drawingml/2006/main">
               <a:ext uri="{FF2B5EF4-FFF2-40B4-BE49-F238E27FC236}">
-                <a16:creationId xmlns:a16="http://schemas.microsoft.com/office/drawing/2014/main" id="{041D507B-55D2-4F8E-ACBB-CFF86BC6B98E}"/>
+                <a16:creationId xmlns:a16="http://schemas.microsoft.com/office/drawing/2014/main" id="{9AA4F295-DF28-408C-AA7A-6A7107EF2DCC}"/>
               </a:ext>
             </a:extLst>
           </p:cNvPr>
@@ -12482,7 +12482,7 @@
           <p:cNvPr id="3" name="">
             <a:extLst xmlns:a="http://schemas.openxmlformats.org/drawingml/2006/main">
               <a:ext uri="{FF2B5EF4-FFF2-40B4-BE49-F238E27FC236}">
-                <a16:creationId xmlns:a16="http://schemas.microsoft.com/office/drawing/2014/main" id="{53E3BEAF-89D3-426E-8857-EB79825FB8FD}"/>
+                <a16:creationId xmlns:a16="http://schemas.microsoft.com/office/drawing/2014/main" id="{F5D23C42-7CE0-4ABB-BC40-367BFD64CED2}"/>
               </a:ext>
             </a:extLst>
           </p:cNvPr>
@@ -12638,7 +12638,7 @@
           <p:cNvPr id="4" name="">
             <a:extLst xmlns:a="http://schemas.openxmlformats.org/drawingml/2006/main">
               <a:ext uri="{FF2B5EF4-FFF2-40B4-BE49-F238E27FC236}">
-                <a16:creationId xmlns:a16="http://schemas.microsoft.com/office/drawing/2014/main" id="{3E555585-E38F-43BD-8100-EA2238466941}"/>
+                <a16:creationId xmlns:a16="http://schemas.microsoft.com/office/drawing/2014/main" id="{68A6DB4A-EF18-4456-9E8C-43445776852B}"/>
               </a:ext>
             </a:extLst>
           </p:cNvPr>
@@ -12794,7 +12794,7 @@
           <p:cNvPr id="5" name="">
             <a:extLst xmlns:a="http://schemas.openxmlformats.org/drawingml/2006/main">
               <a:ext uri="{FF2B5EF4-FFF2-40B4-BE49-F238E27FC236}">
-                <a16:creationId xmlns:a16="http://schemas.microsoft.com/office/drawing/2014/main" id="{718DF5B6-3C2C-46B7-A7FD-44BB96D6369A}"/>
+                <a16:creationId xmlns:a16="http://schemas.microsoft.com/office/drawing/2014/main" id="{BB7434F3-4F8C-4351-AE07-EC9510892D1E}"/>
               </a:ext>
             </a:extLst>
           </p:cNvPr>
@@ -12940,7 +12940,7 @@
                 <a:ea typeface="Arial"/>
                 <a:cs typeface="Arial"/>
               </a:rPr>
-              <a:t>One approved simulated settlement</a:t>
+              <a:t>One approved simulated payment</a:t>
             </a:r>
           </a:p>
         </p:txBody>
@@ -12950,7 +12950,7 @@
           <p:cNvPr id="6" name="">
             <a:extLst xmlns:a="http://schemas.openxmlformats.org/drawingml/2006/main">
               <a:ext uri="{FF2B5EF4-FFF2-40B4-BE49-F238E27FC236}">
-                <a16:creationId xmlns:a16="http://schemas.microsoft.com/office/drawing/2014/main" id="{C2F621D9-3245-4002-9DD7-74F212FFC802}"/>
+                <a16:creationId xmlns:a16="http://schemas.microsoft.com/office/drawing/2014/main" id="{A3273BC3-CB30-440E-9DBF-9797BCB05AEA}"/>
               </a:ext>
             </a:extLst>
           </p:cNvPr>
@@ -13106,7 +13106,7 @@
           <p:cNvPr id="7" name="">
             <a:extLst xmlns:a="http://schemas.openxmlformats.org/drawingml/2006/main">
               <a:ext uri="{FF2B5EF4-FFF2-40B4-BE49-F238E27FC236}">
-                <a16:creationId xmlns:a16="http://schemas.microsoft.com/office/drawing/2014/main" id="{33BB9D28-10C6-4440-9DAF-CD962AAC6F46}"/>
+                <a16:creationId xmlns:a16="http://schemas.microsoft.com/office/drawing/2014/main" id="{DB7F6D87-0F5E-4E15-9B0B-3F8F118C6B4F}"/>
               </a:ext>
             </a:extLst>
           </p:cNvPr>
@@ -13252,7 +13252,7 @@
                 <a:ea typeface="Arial"/>
                 <a:cs typeface="Arial"/>
               </a:rPr>
-              <a:t>Recorded cash balance in BDT</a:t>
+              <a:t>Recorded cash in BDT</a:t>
             </a:r>
           </a:p>
         </p:txBody>
@@ -13262,7 +13262,7 @@
           <p:cNvPr id="8" name="">
             <a:extLst xmlns:a="http://schemas.openxmlformats.org/drawingml/2006/main">
               <a:ext uri="{FF2B5EF4-FFF2-40B4-BE49-F238E27FC236}">
-                <a16:creationId xmlns:a16="http://schemas.microsoft.com/office/drawing/2014/main" id="{A98D5A21-CC89-4804-821E-7034CE160644}"/>
+                <a16:creationId xmlns:a16="http://schemas.microsoft.com/office/drawing/2014/main" id="{8F499CCB-A8F8-446B-ACBA-E350819050FD}"/>
               </a:ext>
             </a:extLst>
           </p:cNvPr>
@@ -13408,7 +13408,7 @@
                 <a:ea typeface="Arial"/>
                 <a:cs typeface="Arial"/>
               </a:rPr>
-              <a:t>Same request key → same receipt</a:t>
+              <a:t>Repeat request: same receipt</a:t>
             </a:r>
           </a:p>
           <a:p xmlns:a="http://schemas.openxmlformats.org/drawingml/2006/main">
@@ -13431,7 +13431,7 @@
                 <a:ea typeface="Arial"/>
                 <a:cs typeface="Arial"/>
               </a:rPr>
-              <a:t>No second cash deduction</a:t>
+              <a:t>Cash changes only once</a:t>
             </a:r>
           </a:p>
         </p:txBody>
@@ -13441,7 +13441,7 @@
           <p:cNvPr id="9" name="">
             <a:extLst xmlns:a="http://schemas.openxmlformats.org/drawingml/2006/main">
               <a:ext uri="{FF2B5EF4-FFF2-40B4-BE49-F238E27FC236}">
-                <a16:creationId xmlns:a16="http://schemas.microsoft.com/office/drawing/2014/main" id="{3E93F716-0701-4385-ADF8-54AA183F4655}"/>
+                <a16:creationId xmlns:a16="http://schemas.microsoft.com/office/drawing/2014/main" id="{6E65F5BA-BEBE-46A4-924D-193750B237D9}"/>
               </a:ext>
             </a:extLst>
           </p:cNvPr>
@@ -13451,7 +13451,7 @@
           <p:nvPr/>
         </p:nvPicPr>
         <p:blipFill>
-          <a:blip xmlns:r="http://schemas.openxmlformats.org/officeDocument/2006/relationships" xmlns:a="http://schemas.openxmlformats.org/drawingml/2006/main" r:embed="R35be621c10134199"/>
+          <a:blip xmlns:r="http://schemas.openxmlformats.org/officeDocument/2006/relationships" xmlns:a="http://schemas.openxmlformats.org/drawingml/2006/main" r:embed="R2d46ef3310f64827"/>
           <a:stretch xmlns:a="http://schemas.openxmlformats.org/drawingml/2006/main"/>
         </p:blipFill>
         <p:spPr>
@@ -13467,7 +13467,7 @@
     </p:spTree>
     <p:extLst>
       <p:ext uri="{BB962C8B-B14F-4D97-AF65-F5344CB8AC3E}">
-        <p14:creationId xmlns:p14="http://schemas.microsoft.com/office/powerpoint/2010/main" val="534962930"/>
+        <p14:creationId xmlns:p14="http://schemas.microsoft.com/office/powerpoint/2010/main" val="1432368541"/>
       </p:ext>
     </p:extLst>
   </p:cSld>
@@ -13498,7 +13498,7 @@
           <p:cNvPr id="7" name="">
             <a:extLst xmlns:a="http://schemas.openxmlformats.org/drawingml/2006/main">
               <a:ext uri="{FF2B5EF4-FFF2-40B4-BE49-F238E27FC236}">
-                <a16:creationId xmlns:a16="http://schemas.microsoft.com/office/drawing/2014/main" id="{B2284EC0-F429-4B91-95C1-C9F5DA5EF8BC}"/>
+                <a16:creationId xmlns:a16="http://schemas.microsoft.com/office/drawing/2014/main" id="{896AEDE1-79A1-499E-AEAC-B3CD49FEA662}"/>
               </a:ext>
             </a:extLst>
           </p:cNvPr>
@@ -13644,7 +13644,7 @@
                 <a:ea typeface="Arial"/>
                 <a:cs typeface="Arial"/>
               </a:rPr>
-              <a:t>Security and execution evidence</a:t>
+              <a:t>Checks and limits</a:t>
             </a:r>
           </a:p>
         </p:txBody>
@@ -13654,7 +13654,7 @@
           <p:cNvPr id="2" name="">
             <a:extLst xmlns:a="http://schemas.openxmlformats.org/drawingml/2006/main">
               <a:ext uri="{FF2B5EF4-FFF2-40B4-BE49-F238E27FC236}">
-                <a16:creationId xmlns:a16="http://schemas.microsoft.com/office/drawing/2014/main" id="{0CA5D61C-3B2A-4590-8AB4-FCE56CA722E9}"/>
+                <a16:creationId xmlns:a16="http://schemas.microsoft.com/office/drawing/2014/main" id="{1E22328C-60EC-430F-9242-36E92954C85C}"/>
               </a:ext>
             </a:extLst>
           </p:cNvPr>
@@ -13810,7 +13810,7 @@
           <p:cNvPr id="3" name="">
             <a:extLst xmlns:a="http://schemas.openxmlformats.org/drawingml/2006/main">
               <a:ext uri="{FF2B5EF4-FFF2-40B4-BE49-F238E27FC236}">
-                <a16:creationId xmlns:a16="http://schemas.microsoft.com/office/drawing/2014/main" id="{C836C90E-BAF5-42BB-BE62-DEB372E4E310}"/>
+                <a16:creationId xmlns:a16="http://schemas.microsoft.com/office/drawing/2014/main" id="{2F9F52F3-0A06-498A-AAAA-BB646DB1EC57}"/>
               </a:ext>
             </a:extLst>
           </p:cNvPr>
@@ -13966,7 +13966,7 @@
           <p:cNvPr id="4" name="">
             <a:extLst xmlns:a="http://schemas.openxmlformats.org/drawingml/2006/main">
               <a:ext uri="{FF2B5EF4-FFF2-40B4-BE49-F238E27FC236}">
-                <a16:creationId xmlns:a16="http://schemas.microsoft.com/office/drawing/2014/main" id="{7ACCB718-2F00-4017-BB40-A05A93DB313D}"/>
+                <a16:creationId xmlns:a16="http://schemas.microsoft.com/office/drawing/2014/main" id="{6D44E37A-C1BC-48C8-A68C-AD8E812DCE1D}"/>
               </a:ext>
             </a:extLst>
           </p:cNvPr>
@@ -14140,7 +14140,7 @@
                 <a:ea typeface="Arial"/>
                 <a:cs typeface="Arial"/>
               </a:rPr>
-              <a:t>Exact payment snapshots</a:t>
+              <a:t>Exact saved evidence</a:t>
             </a:r>
           </a:p>
           <a:p xmlns:a="http://schemas.openxmlformats.org/drawingml/2006/main">
@@ -14168,7 +14168,7 @@
                 <a:ea typeface="Arial"/>
                 <a:cs typeface="Arial"/>
               </a:rPr>
-              <a:t>Atomic, idempotent settlement</a:t>
+              <a:t>One payment transaction</a:t>
             </a:r>
           </a:p>
           <a:p xmlns:a="http://schemas.openxmlformats.org/drawingml/2006/main">
@@ -14196,7 +14196,7 @@
                 <a:ea typeface="Arial"/>
                 <a:cs typeface="Arial"/>
               </a:rPr>
-              <a:t>Verified local audit chain</a:t>
+              <a:t>Local audit verification</a:t>
             </a:r>
           </a:p>
         </p:txBody>
@@ -14206,7 +14206,7 @@
           <p:cNvPr id="5" name="">
             <a:extLst xmlns:a="http://schemas.openxmlformats.org/drawingml/2006/main">
               <a:ext uri="{FF2B5EF4-FFF2-40B4-BE49-F238E27FC236}">
-                <a16:creationId xmlns:a16="http://schemas.microsoft.com/office/drawing/2014/main" id="{766C1C58-2486-431E-9F7A-B8A88D1D0842}"/>
+                <a16:creationId xmlns:a16="http://schemas.microsoft.com/office/drawing/2014/main" id="{CD5354BF-E04D-4539-A69B-FC0DC081A7A5}"/>
               </a:ext>
             </a:extLst>
           </p:cNvPr>
@@ -14374,7 +14374,7 @@
                           <a:ea typeface="Arial"/>
                           <a:cs typeface="Arial"/>
                         </a:rPr>
-                        <a:t>191</a:t>
+                        <a:t>203</a:t>
                       </a:r>
                     </a:p>
                   </a:txBody>
@@ -14646,7 +14646,7 @@
           <p:cNvPr id="6" name="">
             <a:extLst xmlns:a="http://schemas.openxmlformats.org/drawingml/2006/main">
               <a:ext uri="{FF2B5EF4-FFF2-40B4-BE49-F238E27FC236}">
-                <a16:creationId xmlns:a16="http://schemas.microsoft.com/office/drawing/2014/main" id="{8084A357-A38A-44D9-A95D-F886436200A3}"/>
+                <a16:creationId xmlns:a16="http://schemas.microsoft.com/office/drawing/2014/main" id="{D153D4F4-437F-4778-A9EC-9BD5FD812B2F}"/>
               </a:ext>
             </a:extLst>
           </p:cNvPr>
@@ -14792,7 +14792,7 @@
                 <a:ea typeface="Arial"/>
                 <a:cs typeface="Arial"/>
               </a:rPr>
-              <a:t>Local hash chaining cannot prevent a privileged database administrator from rewriting history.</a:t>
+              <a:t>A full database owner can rewrite the local audit chain.</a:t>
             </a:r>
           </a:p>
         </p:txBody>
@@ -14800,7 +14800,7 @@
     </p:spTree>
     <p:extLst>
       <p:ext uri="{BB962C8B-B14F-4D97-AF65-F5344CB8AC3E}">
-        <p14:creationId xmlns:p14="http://schemas.microsoft.com/office/powerpoint/2010/main" val="1306599916"/>
+        <p14:creationId xmlns:p14="http://schemas.microsoft.com/office/powerpoint/2010/main" val="183608808"/>
       </p:ext>
     </p:extLst>
   </p:cSld>
@@ -14831,7 +14831,7 @@
           <p:cNvPr id="10" name="">
             <a:extLst xmlns:a="http://schemas.openxmlformats.org/drawingml/2006/main">
               <a:ext uri="{FF2B5EF4-FFF2-40B4-BE49-F238E27FC236}">
-                <a16:creationId xmlns:a16="http://schemas.microsoft.com/office/drawing/2014/main" id="{E28B159B-D624-4D0A-A419-A3A35905F9EA}"/>
+                <a16:creationId xmlns:a16="http://schemas.microsoft.com/office/drawing/2014/main" id="{5BD45E17-9DE9-499B-8E98-F60A1B8C049E}"/>
               </a:ext>
             </a:extLst>
           </p:cNvPr>
@@ -14977,7 +14977,7 @@
                 <a:ea typeface="Arial"/>
                 <a:cs typeface="Arial"/>
               </a:rPr>
-              <a:t>Cost planning and commercial controls</a:t>
+              <a:t>Price and estimate changes</a:t>
             </a:r>
           </a:p>
         </p:txBody>
@@ -14987,7 +14987,7 @@
           <p:cNvPr id="2" name="">
             <a:extLst xmlns:a="http://schemas.openxmlformats.org/drawingml/2006/main">
               <a:ext uri="{FF2B5EF4-FFF2-40B4-BE49-F238E27FC236}">
-                <a16:creationId xmlns:a16="http://schemas.microsoft.com/office/drawing/2014/main" id="{E932A252-8DBC-4564-985F-046A0355D4FE}"/>
+                <a16:creationId xmlns:a16="http://schemas.microsoft.com/office/drawing/2014/main" id="{65209AF7-BB58-4646-AB18-4BBBEAB93689}"/>
               </a:ext>
             </a:extLst>
           </p:cNvPr>
@@ -15143,7 +15143,7 @@
           <p:cNvPr id="3" name="">
             <a:extLst xmlns:a="http://schemas.openxmlformats.org/drawingml/2006/main">
               <a:ext uri="{FF2B5EF4-FFF2-40B4-BE49-F238E27FC236}">
-                <a16:creationId xmlns:a16="http://schemas.microsoft.com/office/drawing/2014/main" id="{FA0B9A59-7F31-4D8E-9D39-8312ADDA4549}"/>
+                <a16:creationId xmlns:a16="http://schemas.microsoft.com/office/drawing/2014/main" id="{C19BCF08-FD29-42F5-BF78-E0707FA92D2E}"/>
               </a:ext>
             </a:extLst>
           </p:cNvPr>
@@ -15299,7 +15299,7 @@
           <p:cNvPr id="4" name="">
             <a:extLst xmlns:a="http://schemas.openxmlformats.org/drawingml/2006/main">
               <a:ext uri="{FF2B5EF4-FFF2-40B4-BE49-F238E27FC236}">
-                <a16:creationId xmlns:a16="http://schemas.microsoft.com/office/drawing/2014/main" id="{87291812-F113-4571-AE00-09378FFE5206}"/>
+                <a16:creationId xmlns:a16="http://schemas.microsoft.com/office/drawing/2014/main" id="{30292761-BAD3-491E-8407-5B573245E7F9}"/>
               </a:ext>
             </a:extLst>
           </p:cNvPr>
@@ -15455,7 +15455,7 @@
           <p:cNvPr id="5" name="">
             <a:extLst xmlns:a="http://schemas.openxmlformats.org/drawingml/2006/main">
               <a:ext uri="{FF2B5EF4-FFF2-40B4-BE49-F238E27FC236}">
-                <a16:creationId xmlns:a16="http://schemas.microsoft.com/office/drawing/2014/main" id="{62B9C242-374D-4E68-87DB-89E34E6F7EF9}"/>
+                <a16:creationId xmlns:a16="http://schemas.microsoft.com/office/drawing/2014/main" id="{A0487BA2-3EB0-4834-8DE5-E7F052230B35}"/>
               </a:ext>
             </a:extLst>
           </p:cNvPr>
@@ -15601,7 +15601,7 @@
                 <a:ea typeface="Arial"/>
                 <a:cs typeface="Arial"/>
               </a:rPr>
-              <a:t>Increase in the fictional 20-tonne estimate</a:t>
+              <a:t>Extra cost for the fictional 20 tonnes</a:t>
             </a:r>
           </a:p>
         </p:txBody>
@@ -15611,7 +15611,7 @@
           <p:cNvPr id="6" name="">
             <a:extLst xmlns:a="http://schemas.openxmlformats.org/drawingml/2006/main">
               <a:ext uri="{FF2B5EF4-FFF2-40B4-BE49-F238E27FC236}">
-                <a16:creationId xmlns:a16="http://schemas.microsoft.com/office/drawing/2014/main" id="{F44EB954-D6B2-481B-8D8F-30DF81C6C304}"/>
+                <a16:creationId xmlns:a16="http://schemas.microsoft.com/office/drawing/2014/main" id="{CAF03CA8-4073-473A-A541-7F5D31EAA286}"/>
               </a:ext>
             </a:extLst>
           </p:cNvPr>
@@ -15767,7 +15767,7 @@
           <p:cNvPr id="7" name="">
             <a:extLst xmlns:a="http://schemas.openxmlformats.org/drawingml/2006/main">
               <a:ext uri="{FF2B5EF4-FFF2-40B4-BE49-F238E27FC236}">
-                <a16:creationId xmlns:a16="http://schemas.microsoft.com/office/drawing/2014/main" id="{E5A90202-A39E-4577-82DE-7D865C0959AB}"/>
+                <a16:creationId xmlns:a16="http://schemas.microsoft.com/office/drawing/2014/main" id="{18768C34-4D8D-477A-BF1A-E6D03678EA2D}"/>
               </a:ext>
             </a:extLst>
           </p:cNvPr>
@@ -15913,7 +15913,7 @@
                 <a:ea typeface="Arial"/>
                 <a:cs typeface="Arial"/>
               </a:rPr>
-              <a:t>Scheduled forecast in BDT. Recorded cash stays at 2,000,000.</a:t>
+              <a:t>Forecast cash in BDT. Recorded cash stays at 2,000,000.</a:t>
             </a:r>
           </a:p>
         </p:txBody>
@@ -15923,7 +15923,7 @@
           <p:cNvPr id="8" name="">
             <a:extLst xmlns:a="http://schemas.openxmlformats.org/drawingml/2006/main">
               <a:ext uri="{FF2B5EF4-FFF2-40B4-BE49-F238E27FC236}">
-                <a16:creationId xmlns:a16="http://schemas.microsoft.com/office/drawing/2014/main" id="{495D97BE-5BE1-46C4-A6F8-D0EFAFD98824}"/>
+                <a16:creationId xmlns:a16="http://schemas.microsoft.com/office/drawing/2014/main" id="{94733104-FB88-4F8B-AFEF-3440B60068F7}"/>
               </a:ext>
             </a:extLst>
           </p:cNvPr>
@@ -15933,7 +15933,7 @@
           <p:nvPr/>
         </p:nvPicPr>
         <p:blipFill>
-          <a:blip xmlns:r="http://schemas.openxmlformats.org/officeDocument/2006/relationships" xmlns:a="http://schemas.openxmlformats.org/drawingml/2006/main" r:embed="R3503b8767e6f4dd6"/>
+          <a:blip xmlns:r="http://schemas.openxmlformats.org/officeDocument/2006/relationships" xmlns:a="http://schemas.openxmlformats.org/drawingml/2006/main" r:embed="R138af91f15ae4a40"/>
           <a:stretch xmlns:a="http://schemas.openxmlformats.org/drawingml/2006/main"/>
         </p:blipFill>
         <p:spPr>
@@ -15951,7 +15951,7 @@
           <p:cNvPr id="9" name="">
             <a:extLst xmlns:a="http://schemas.openxmlformats.org/drawingml/2006/main">
               <a:ext uri="{FF2B5EF4-FFF2-40B4-BE49-F238E27FC236}">
-                <a16:creationId xmlns:a16="http://schemas.microsoft.com/office/drawing/2014/main" id="{7447DA60-3C98-4917-B994-743D19D98DC0}"/>
+                <a16:creationId xmlns:a16="http://schemas.microsoft.com/office/drawing/2014/main" id="{B26047EE-98DA-4D16-8EFB-E7023067F49F}"/>
               </a:ext>
             </a:extLst>
           </p:cNvPr>
@@ -16097,7 +16097,7 @@
                 <a:ea typeface="Arial"/>
                 <a:cs typeface="Arial"/>
               </a:rPr>
-              <a:t>Independent reviews protect procurement, cost corrections and every cash installment.</a:t>
+              <a:t>More tools: quantities, contracts, installments and reviewed corrections.</a:t>
             </a:r>
           </a:p>
         </p:txBody>
@@ -16105,7 +16105,7 @@
     </p:spTree>
     <p:extLst>
       <p:ext uri="{BB962C8B-B14F-4D97-AF65-F5344CB8AC3E}">
-        <p14:creationId xmlns:p14="http://schemas.microsoft.com/office/powerpoint/2010/main" val="1633095013"/>
+        <p14:creationId xmlns:p14="http://schemas.microsoft.com/office/powerpoint/2010/main" val="1580532482"/>
       </p:ext>
     </p:extLst>
   </p:cSld>

</xml_diff>

<commit_message>
Keep planning files private and refresh public release documentation
</commit_message>
<xml_diff>
--- a/submission/BuildTrustAI_Presentation.pptx
+++ b/submission/BuildTrustAI_Presentation.pptx
@@ -450,7 +450,7 @@
           <a:lstStyle xmlns:a="http://schemas.openxmlformats.org/drawingml/2006/main"/>
           <a:p xmlns:a="http://schemas.openxmlformats.org/drawingml/2006/main">
             <a:r>
-              <a:t>0:00–0:40. BuildTrust AI helps construction teams check costs and review payments. This is a working local app, not a set of sample screen designs. Its records and calculations are real application operations, but the projects and transfers are fictional. No bank is connected. A visitor can start the separate public demo and use the four passwords in the README. Explain that people approve financial actions. Give the audience a moment to read the product name. Sources: README.md; features.md; prompt/prompt.md.</a:t>
+              <a:t>0:00–0:40. BuildTrust AI helps construction teams check costs and review payments. This is a working local app, not a set of sample screen designs. Its records and calculations are real application operations, but the projects and transfers are fictional. No bank is connected. A visitor can start the separate public demo and use the four passwords in the README. Explain that people approve financial actions. Give the audience a moment to read the product name. Sources: README.md; features.md; docs/technical-documentation.md.</a:t>
             </a:r>
           </a:p>
         </p:txBody>
@@ -520,7 +520,7 @@
           <a:lstStyle xmlns:a="http://schemas.openxmlformats.org/drawingml/2006/main"/>
           <a:p xmlns:a="http://schemas.openxmlformats.org/drawingml/2006/main">
             <a:r>
-              <a:t>0:40–1:30. A bill of quantities lists approved quantities. A purchase order records what was ordered and at what rate. A delivery receipt records accepted supply. An invoice states what the supplier wants to be paid. These records answer different questions. The invoice alone cannot prove that goods arrived or that the amount is authorized. Point to the pictured fictional invoice, then explain that the app keeps the original file and its source references. Uploaded words such as approved do not grant authority. Sources: prompt/prompt.md; demo/fixtures/scenario-a-inflated.pdf; docs/financial-rules.md.</a:t>
+              <a:t>0:40–1:30. A bill of quantities lists approved quantities. A purchase order records what was ordered and at what rate. A delivery receipt records accepted supply. An invoice states what the supplier wants to be paid. These records answer different questions. The invoice alone cannot prove that goods arrived or that the amount is authorized. Point to the pictured fictional invoice, then explain that the app keeps the original file and its source references. Uploaded words such as approved do not grant authority. Sources: docs/technical-documentation.md; demo/fixtures/scenario-a-inflated.pdf; docs/financial-rules.md.</a:t>
             </a:r>
           </a:p>
         </p:txBody>

</xml_diff>

<commit_message>
Harden sessions, recovery, provider budgets and private storage
</commit_message>
<xml_diff>
--- a/submission/BuildTrustAI_Presentation.pptx
+++ b/submission/BuildTrustAI_Presentation.pptx
@@ -2,21 +2,21 @@
 <file path=ppt/presentation.xml><?xml version="1.0" encoding="utf-8"?>
 <p:presentation xmlns:p="http://schemas.openxmlformats.org/presentationml/2006/main">
   <p:sldMasterIdLst>
-    <p:sldMasterId xmlns:r="http://schemas.openxmlformats.org/officeDocument/2006/relationships" id="2147483648" r:id="Rc916f305988744fa"/>
+    <p:sldMasterId xmlns:r="http://schemas.openxmlformats.org/officeDocument/2006/relationships" id="2147483648" r:id="R1d16593f550045b5"/>
   </p:sldMasterIdLst>
   <p:notesMasterIdLst>
-    <p:notesMasterId xmlns:r="http://schemas.openxmlformats.org/officeDocument/2006/relationships" r:id="Re833edcf6a1a4a73"/>
+    <p:notesMasterId xmlns:r="http://schemas.openxmlformats.org/officeDocument/2006/relationships" r:id="R78a4d4bdb3d6479d"/>
   </p:notesMasterIdLst>
   <p:sldIdLst>
-    <p:sldId xmlns:r="http://schemas.openxmlformats.org/officeDocument/2006/relationships" id="256" r:id="Rd64881cda68c4d7b"/>
-    <p:sldId xmlns:r="http://schemas.openxmlformats.org/officeDocument/2006/relationships" id="257" r:id="R638e68d182a64bac"/>
-    <p:sldId xmlns:r="http://schemas.openxmlformats.org/officeDocument/2006/relationships" id="258" r:id="R1aeb773071184558"/>
-    <p:sldId xmlns:r="http://schemas.openxmlformats.org/officeDocument/2006/relationships" id="259" r:id="R8eb9b55322fd47f6"/>
-    <p:sldId xmlns:r="http://schemas.openxmlformats.org/officeDocument/2006/relationships" id="260" r:id="Rce0816aac91349cd"/>
-    <p:sldId xmlns:r="http://schemas.openxmlformats.org/officeDocument/2006/relationships" id="261" r:id="R66440b5aa87c49c5"/>
-    <p:sldId xmlns:r="http://schemas.openxmlformats.org/officeDocument/2006/relationships" id="262" r:id="Rf7273b287eac41f5"/>
-    <p:sldId xmlns:r="http://schemas.openxmlformats.org/officeDocument/2006/relationships" id="263" r:id="Rb056f6fc5e9049bc"/>
-    <p:sldId xmlns:r="http://schemas.openxmlformats.org/officeDocument/2006/relationships" id="264" r:id="R07fd4fc82fb24860"/>
+    <p:sldId xmlns:r="http://schemas.openxmlformats.org/officeDocument/2006/relationships" id="256" r:id="R3fd8382407cb4384"/>
+    <p:sldId xmlns:r="http://schemas.openxmlformats.org/officeDocument/2006/relationships" id="257" r:id="Raf15624f11b54520"/>
+    <p:sldId xmlns:r="http://schemas.openxmlformats.org/officeDocument/2006/relationships" id="258" r:id="Rb937c27887ec4d7d"/>
+    <p:sldId xmlns:r="http://schemas.openxmlformats.org/officeDocument/2006/relationships" id="259" r:id="Re10e6551fb534dd3"/>
+    <p:sldId xmlns:r="http://schemas.openxmlformats.org/officeDocument/2006/relationships" id="260" r:id="Rf874a2c5a52041be"/>
+    <p:sldId xmlns:r="http://schemas.openxmlformats.org/officeDocument/2006/relationships" id="261" r:id="Rad26df668ffb4d3d"/>
+    <p:sldId xmlns:r="http://schemas.openxmlformats.org/officeDocument/2006/relationships" id="262" r:id="Rcb8cf4c1c6f14b4f"/>
+    <p:sldId xmlns:r="http://schemas.openxmlformats.org/officeDocument/2006/relationships" id="263" r:id="R6b6d1c9adc9a493f"/>
+    <p:sldId xmlns:r="http://schemas.openxmlformats.org/officeDocument/2006/relationships" id="264" r:id="R6b0f397ba79e440d"/>
   </p:sldIdLst>
   <p:sldSz cx="12192000" cy="6858000"/>
   <p:notesSz cx="6858000" cy="9144000"/>
@@ -940,7 +940,7 @@
           <a:lstStyle xmlns:a="http://schemas.openxmlformats.org/drawingml/2006/main"/>
           <a:p xmlns:a="http://schemas.openxmlformats.org/drawingml/2006/main">
             <a:r>
-              <a:t>6:40–7:50. The table shows actual local results: 203 backend tests, 8 frontend tests, 16 browser workflows and eight original HTTP scenarios. Separate public-demo checks verify four documented logins and preserve the private profile. Tests cover denied roles, changed approvals, expiry, duplicate quantities, competing execution, rollback and retries. Fresh installation checks use a source copy. A passing suite is evidence for tested behavior, not complete security assurance. The audit chain can find inconsistent retained events, but a full database owner can rewrite it. Independent security and assistive-technology reviews remain separate. Sources: verification-summary.json; test logs; public-demo-install.json; docs/security-self-assessment.md.</a:t>
+              <a:t>6:40–7:50. The table shows actual local results: 225 backend tests, 8 frontend tests, 18 browser workflows and eight original HTTP scenarios. Separate public-demo checks verify four documented logins and preserve the private profile. Tests cover denied roles, changed approvals, expiry, duplicate quantities, competing execution, rollback and retries. Fresh installation checks use a source copy. A passing suite is evidence for tested behavior, not complete security assurance. The audit chain can find inconsistent retained events, but a full database owner can rewrite it. The twenty-item security report also covers revocable sessions, one-time offline recovery, private backups, secret scanning and persistent usage caps. The four public demo passwords stay fixed. Independent security and assistive-technology reviews remain separate. Sources: verification-summary.json; test logs; public-demo-install.json; docs/security-self-assessment.md.</a:t>
             </a:r>
           </a:p>
         </p:txBody>
@@ -1057,7 +1057,7 @@
           <p:cNvPr id="3" name="Title">
             <a:extLst xmlns:a="http://schemas.openxmlformats.org/drawingml/2006/main">
               <a:ext uri="{FF2B5EF4-FFF2-40B4-BE49-F238E27FC236}">
-                <a16:creationId xmlns:a16="http://schemas.microsoft.com/office/drawing/2014/main" id="{B52A263E-5E9A-493B-92F7-B39291E64F3C}"/>
+                <a16:creationId xmlns:a16="http://schemas.microsoft.com/office/drawing/2014/main" id="{07B6597B-F768-414F-AFBA-01BB90618666}"/>
               </a:ext>
             </a:extLst>
           </p:cNvPr>
@@ -1286,7 +1286,7 @@
           <p:cNvPr id="2" name="Subtitle">
             <a:extLst xmlns:a="http://schemas.openxmlformats.org/drawingml/2006/main">
               <a:ext uri="{FF2B5EF4-FFF2-40B4-BE49-F238E27FC236}">
-                <a16:creationId xmlns:a16="http://schemas.microsoft.com/office/drawing/2014/main" id="{53090934-090A-4334-B810-670DBBF4D457}"/>
+                <a16:creationId xmlns:a16="http://schemas.microsoft.com/office/drawing/2014/main" id="{29CC0BAF-3504-444D-AC22-6557D57CD54E}"/>
               </a:ext>
             </a:extLst>
           </p:cNvPr>
@@ -1532,7 +1532,7 @@
           <p:cNvPr id="2" name="Section title">
             <a:extLst xmlns:a="http://schemas.openxmlformats.org/drawingml/2006/main">
               <a:ext uri="{FF2B5EF4-FFF2-40B4-BE49-F238E27FC236}">
-                <a16:creationId xmlns:a16="http://schemas.microsoft.com/office/drawing/2014/main" id="{261F47D0-E9B6-4502-B8A7-93ADD13D9F85}"/>
+                <a16:creationId xmlns:a16="http://schemas.microsoft.com/office/drawing/2014/main" id="{B81675F4-CEBE-48CE-8DC9-23EF096DABA2}"/>
               </a:ext>
             </a:extLst>
           </p:cNvPr>
@@ -1778,7 +1778,7 @@
           <p:cNvPr id="3" name="Title">
             <a:extLst xmlns:a="http://schemas.openxmlformats.org/drawingml/2006/main">
               <a:ext uri="{FF2B5EF4-FFF2-40B4-BE49-F238E27FC236}">
-                <a16:creationId xmlns:a16="http://schemas.microsoft.com/office/drawing/2014/main" id="{731AF13F-DEC5-4210-A3DC-CB13CFB31513}"/>
+                <a16:creationId xmlns:a16="http://schemas.microsoft.com/office/drawing/2014/main" id="{D7376D18-128B-40BF-A62E-AF1B1F31B1AC}"/>
               </a:ext>
             </a:extLst>
           </p:cNvPr>
@@ -2007,7 +2007,7 @@
           <p:cNvPr id="2" name="Body">
             <a:extLst xmlns:a="http://schemas.openxmlformats.org/drawingml/2006/main">
               <a:ext uri="{FF2B5EF4-FFF2-40B4-BE49-F238E27FC236}">
-                <a16:creationId xmlns:a16="http://schemas.microsoft.com/office/drawing/2014/main" id="{862CCFEF-C2B6-439C-96A2-CAA0E9CD0B8F}"/>
+                <a16:creationId xmlns:a16="http://schemas.microsoft.com/office/drawing/2014/main" id="{07711F6A-42CD-44A3-BD68-C2507DF1A2C1}"/>
               </a:ext>
             </a:extLst>
           </p:cNvPr>
@@ -2253,7 +2253,7 @@
           <p:cNvPr id="4" name="Title">
             <a:extLst xmlns:a="http://schemas.openxmlformats.org/drawingml/2006/main">
               <a:ext uri="{FF2B5EF4-FFF2-40B4-BE49-F238E27FC236}">
-                <a16:creationId xmlns:a16="http://schemas.microsoft.com/office/drawing/2014/main" id="{5D2A09D4-A12E-4C98-BB51-6AAE0E7BBD95}"/>
+                <a16:creationId xmlns:a16="http://schemas.microsoft.com/office/drawing/2014/main" id="{FC9D8805-E046-468E-871C-D66BD9EDED59}"/>
               </a:ext>
             </a:extLst>
           </p:cNvPr>
@@ -2482,7 +2482,7 @@
           <p:cNvPr id="2" name="Left column">
             <a:extLst xmlns:a="http://schemas.openxmlformats.org/drawingml/2006/main">
               <a:ext uri="{FF2B5EF4-FFF2-40B4-BE49-F238E27FC236}">
-                <a16:creationId xmlns:a16="http://schemas.microsoft.com/office/drawing/2014/main" id="{2FCE7952-53FA-449F-88BF-0350F8911767}"/>
+                <a16:creationId xmlns:a16="http://schemas.microsoft.com/office/drawing/2014/main" id="{CC47B1C5-EC85-4A5D-ABAE-95E11FE71E87}"/>
               </a:ext>
             </a:extLst>
           </p:cNvPr>
@@ -2711,7 +2711,7 @@
           <p:cNvPr id="3" name="Right column">
             <a:extLst xmlns:a="http://schemas.openxmlformats.org/drawingml/2006/main">
               <a:ext uri="{FF2B5EF4-FFF2-40B4-BE49-F238E27FC236}">
-                <a16:creationId xmlns:a16="http://schemas.microsoft.com/office/drawing/2014/main" id="{DB80952B-C713-464A-AC7B-33D3D6691814}"/>
+                <a16:creationId xmlns:a16="http://schemas.microsoft.com/office/drawing/2014/main" id="{4AFCF9EC-E536-49AF-9004-0DBD3786AB31}"/>
               </a:ext>
             </a:extLst>
           </p:cNvPr>
@@ -2957,7 +2957,7 @@
           <p:cNvPr id="3" name="Title">
             <a:extLst xmlns:a="http://schemas.openxmlformats.org/drawingml/2006/main">
               <a:ext uri="{FF2B5EF4-FFF2-40B4-BE49-F238E27FC236}">
-                <a16:creationId xmlns:a16="http://schemas.microsoft.com/office/drawing/2014/main" id="{490C19B7-4A83-414F-AFC2-A2E6C51F3B17}"/>
+                <a16:creationId xmlns:a16="http://schemas.microsoft.com/office/drawing/2014/main" id="{C4E15FA4-2F8C-4CC6-93F8-C02AFB06D33D}"/>
               </a:ext>
             </a:extLst>
           </p:cNvPr>
@@ -3186,7 +3186,7 @@
           <p:cNvPr id="2" name="Left column">
             <a:extLst xmlns:a="http://schemas.openxmlformats.org/drawingml/2006/main">
               <a:ext uri="{FF2B5EF4-FFF2-40B4-BE49-F238E27FC236}">
-                <a16:creationId xmlns:a16="http://schemas.microsoft.com/office/drawing/2014/main" id="{00D46A3C-8BC9-416D-978B-3E6BA017F64E}"/>
+                <a16:creationId xmlns:a16="http://schemas.microsoft.com/office/drawing/2014/main" id="{BEF4090E-5BBC-4162-9413-B867689BC44F}"/>
               </a:ext>
             </a:extLst>
           </p:cNvPr>
@@ -3453,12 +3453,12 @@
   </p:cSld>
   <p:clrMap bg1="lt1" tx1="dk1" bg2="lt2" tx2="dk2" accent1="accent1" accent2="accent2" accent3="accent3" accent4="accent4" accent5="accent5" accent6="accent6" hlink="hlink" folHlink="folHlink"/>
   <p:sldLayoutIdLst>
-    <p:sldLayoutId xmlns:r="http://schemas.openxmlformats.org/officeDocument/2006/relationships" id="2147483649" r:id="Rbc2fb3c6620349c6"/>
-    <p:sldLayoutId xmlns:r="http://schemas.openxmlformats.org/officeDocument/2006/relationships" id="2147483650" r:id="R7cea6afc74ea414b"/>
-    <p:sldLayoutId xmlns:r="http://schemas.openxmlformats.org/officeDocument/2006/relationships" id="2147483651" r:id="R3375d2c0d3014eb6"/>
-    <p:sldLayoutId xmlns:r="http://schemas.openxmlformats.org/officeDocument/2006/relationships" id="2147483652" r:id="R5afa493950a144f9"/>
-    <p:sldLayoutId xmlns:r="http://schemas.openxmlformats.org/officeDocument/2006/relationships" id="2147483653" r:id="R6e6d392db45f4b82"/>
-    <p:sldLayoutId xmlns:r="http://schemas.openxmlformats.org/officeDocument/2006/relationships" id="2147483654" r:id="R486cba07fee847a4"/>
+    <p:sldLayoutId xmlns:r="http://schemas.openxmlformats.org/officeDocument/2006/relationships" id="2147483649" r:id="Rf89afeb4da27496b"/>
+    <p:sldLayoutId xmlns:r="http://schemas.openxmlformats.org/officeDocument/2006/relationships" id="2147483650" r:id="Rbf8c1552256c493b"/>
+    <p:sldLayoutId xmlns:r="http://schemas.openxmlformats.org/officeDocument/2006/relationships" id="2147483651" r:id="R613cca14d2654c44"/>
+    <p:sldLayoutId xmlns:r="http://schemas.openxmlformats.org/officeDocument/2006/relationships" id="2147483652" r:id="Rbc441527c5e84e09"/>
+    <p:sldLayoutId xmlns:r="http://schemas.openxmlformats.org/officeDocument/2006/relationships" id="2147483653" r:id="R9efc7394896d4c83"/>
+    <p:sldLayoutId xmlns:r="http://schemas.openxmlformats.org/officeDocument/2006/relationships" id="2147483654" r:id="Rdfe1ce67febc4d74"/>
   </p:sldLayoutIdLst>
   <p:txStyles>
     <p:titleStyle>
@@ -4009,7 +4009,7 @@
           <p:cNvPr id="7" name="">
             <a:extLst xmlns:a="http://schemas.openxmlformats.org/drawingml/2006/main">
               <a:ext uri="{FF2B5EF4-FFF2-40B4-BE49-F238E27FC236}">
-                <a16:creationId xmlns:a16="http://schemas.microsoft.com/office/drawing/2014/main" id="{48194833-FC63-4B0C-837F-D2EC208CB376}"/>
+                <a16:creationId xmlns:a16="http://schemas.microsoft.com/office/drawing/2014/main" id="{CB62F4D2-4FC9-4C5C-9B52-5DCF82D648FF}"/>
               </a:ext>
             </a:extLst>
           </p:cNvPr>
@@ -4165,7 +4165,7 @@
           <p:cNvPr id="2" name="">
             <a:extLst xmlns:a="http://schemas.openxmlformats.org/drawingml/2006/main">
               <a:ext uri="{FF2B5EF4-FFF2-40B4-BE49-F238E27FC236}">
-                <a16:creationId xmlns:a16="http://schemas.microsoft.com/office/drawing/2014/main" id="{BA44E41E-3E84-4E91-A482-95F0E6128184}"/>
+                <a16:creationId xmlns:a16="http://schemas.microsoft.com/office/drawing/2014/main" id="{A34AC906-1888-4E56-9FE4-20E99BD0E217}"/>
               </a:ext>
             </a:extLst>
           </p:cNvPr>
@@ -4321,7 +4321,7 @@
           <p:cNvPr id="3" name="">
             <a:extLst xmlns:a="http://schemas.openxmlformats.org/drawingml/2006/main">
               <a:ext uri="{FF2B5EF4-FFF2-40B4-BE49-F238E27FC236}">
-                <a16:creationId xmlns:a16="http://schemas.microsoft.com/office/drawing/2014/main" id="{4878567F-9532-4D7E-AD3A-0B58015C631F}"/>
+                <a16:creationId xmlns:a16="http://schemas.microsoft.com/office/drawing/2014/main" id="{D88BFD13-C428-4335-B3B5-F574EBD32B35}"/>
               </a:ext>
             </a:extLst>
           </p:cNvPr>
@@ -4477,7 +4477,7 @@
           <p:cNvPr id="4" name="">
             <a:extLst xmlns:a="http://schemas.openxmlformats.org/drawingml/2006/main">
               <a:ext uri="{FF2B5EF4-FFF2-40B4-BE49-F238E27FC236}">
-                <a16:creationId xmlns:a16="http://schemas.microsoft.com/office/drawing/2014/main" id="{8A1EA08A-9BC5-4530-AF11-102E88FE8A60}"/>
+                <a16:creationId xmlns:a16="http://schemas.microsoft.com/office/drawing/2014/main" id="{9B038615-D87E-4272-8961-0790C8CF1568}"/>
               </a:ext>
             </a:extLst>
           </p:cNvPr>
@@ -4656,7 +4656,7 @@
           <p:cNvPr id="5" name="">
             <a:extLst xmlns:a="http://schemas.openxmlformats.org/drawingml/2006/main">
               <a:ext uri="{FF2B5EF4-FFF2-40B4-BE49-F238E27FC236}">
-                <a16:creationId xmlns:a16="http://schemas.microsoft.com/office/drawing/2014/main" id="{89BD5237-8DA1-4436-82FB-9DC9DBE315EC}"/>
+                <a16:creationId xmlns:a16="http://schemas.microsoft.com/office/drawing/2014/main" id="{E05CA722-D6A9-4A41-8673-F1CE76928D5B}"/>
               </a:ext>
             </a:extLst>
           </p:cNvPr>
@@ -4812,7 +4812,7 @@
           <p:cNvPr id="6" name="">
             <a:extLst xmlns:a="http://schemas.openxmlformats.org/drawingml/2006/main">
               <a:ext uri="{FF2B5EF4-FFF2-40B4-BE49-F238E27FC236}">
-                <a16:creationId xmlns:a16="http://schemas.microsoft.com/office/drawing/2014/main" id="{0AAF9841-5103-42DE-8709-71C143609E3B}"/>
+                <a16:creationId xmlns:a16="http://schemas.microsoft.com/office/drawing/2014/main" id="{C11A83DE-F979-456E-966D-613F3C4519BF}"/>
               </a:ext>
             </a:extLst>
           </p:cNvPr>
@@ -4966,7 +4966,7 @@
     </p:spTree>
     <p:extLst>
       <p:ext uri="{BB962C8B-B14F-4D97-AF65-F5344CB8AC3E}">
-        <p14:creationId xmlns:p14="http://schemas.microsoft.com/office/powerpoint/2010/main" val="1828050"/>
+        <p14:creationId xmlns:p14="http://schemas.microsoft.com/office/powerpoint/2010/main" val="354845499"/>
       </p:ext>
     </p:extLst>
   </p:cSld>
@@ -4997,7 +4997,7 @@
           <p:cNvPr id="7" name="">
             <a:extLst xmlns:a="http://schemas.openxmlformats.org/drawingml/2006/main">
               <a:ext uri="{FF2B5EF4-FFF2-40B4-BE49-F238E27FC236}">
-                <a16:creationId xmlns:a16="http://schemas.microsoft.com/office/drawing/2014/main" id="{1F3DE603-7397-4656-B2A4-430469666B9D}"/>
+                <a16:creationId xmlns:a16="http://schemas.microsoft.com/office/drawing/2014/main" id="{A697521C-C9EA-438B-AC2E-3192A394DE73}"/>
               </a:ext>
             </a:extLst>
           </p:cNvPr>
@@ -5153,7 +5153,7 @@
           <p:cNvPr id="2" name="">
             <a:extLst xmlns:a="http://schemas.openxmlformats.org/drawingml/2006/main">
               <a:ext uri="{FF2B5EF4-FFF2-40B4-BE49-F238E27FC236}">
-                <a16:creationId xmlns:a16="http://schemas.microsoft.com/office/drawing/2014/main" id="{B97CF7A3-1910-4B6C-B3AA-95409390DA18}"/>
+                <a16:creationId xmlns:a16="http://schemas.microsoft.com/office/drawing/2014/main" id="{81FB507C-C4FF-4A8E-987D-B85F7B6803E3}"/>
               </a:ext>
             </a:extLst>
           </p:cNvPr>
@@ -5309,7 +5309,7 @@
           <p:cNvPr id="3" name="">
             <a:extLst xmlns:a="http://schemas.openxmlformats.org/drawingml/2006/main">
               <a:ext uri="{FF2B5EF4-FFF2-40B4-BE49-F238E27FC236}">
-                <a16:creationId xmlns:a16="http://schemas.microsoft.com/office/drawing/2014/main" id="{325880C5-E2C1-4D6E-A627-BB80D33823CD}"/>
+                <a16:creationId xmlns:a16="http://schemas.microsoft.com/office/drawing/2014/main" id="{9D137614-9882-4481-AF8F-40F85F6EF13C}"/>
               </a:ext>
             </a:extLst>
           </p:cNvPr>
@@ -5465,7 +5465,7 @@
           <p:cNvPr id="4" name="">
             <a:extLst xmlns:a="http://schemas.openxmlformats.org/drawingml/2006/main">
               <a:ext uri="{FF2B5EF4-FFF2-40B4-BE49-F238E27FC236}">
-                <a16:creationId xmlns:a16="http://schemas.microsoft.com/office/drawing/2014/main" id="{7F3CFBA6-584A-49B7-A560-135032179392}"/>
+                <a16:creationId xmlns:a16="http://schemas.microsoft.com/office/drawing/2014/main" id="{022CFBBF-1989-4342-9DA5-192B6AEBB2A1}"/>
               </a:ext>
             </a:extLst>
           </p:cNvPr>
@@ -5621,7 +5621,7 @@
           <p:cNvPr id="5" name="">
             <a:extLst xmlns:a="http://schemas.openxmlformats.org/drawingml/2006/main">
               <a:ext uri="{FF2B5EF4-FFF2-40B4-BE49-F238E27FC236}">
-                <a16:creationId xmlns:a16="http://schemas.microsoft.com/office/drawing/2014/main" id="{667602D9-C0E7-460E-83F9-0A58F5BF363D}"/>
+                <a16:creationId xmlns:a16="http://schemas.microsoft.com/office/drawing/2014/main" id="{97353943-85AC-4E08-B7AC-5BED57FD7E9F}"/>
               </a:ext>
             </a:extLst>
           </p:cNvPr>
@@ -5833,7 +5833,7 @@
           <p:cNvPr id="6" name="">
             <a:extLst xmlns:a="http://schemas.openxmlformats.org/drawingml/2006/main">
               <a:ext uri="{FF2B5EF4-FFF2-40B4-BE49-F238E27FC236}">
-                <a16:creationId xmlns:a16="http://schemas.microsoft.com/office/drawing/2014/main" id="{7C8B180E-07CF-45B6-8302-465C899E8D33}"/>
+                <a16:creationId xmlns:a16="http://schemas.microsoft.com/office/drawing/2014/main" id="{BCDF6C8F-1796-4669-9BA1-10F42D8870C0}"/>
               </a:ext>
             </a:extLst>
           </p:cNvPr>
@@ -5843,7 +5843,7 @@
           <p:nvPr/>
         </p:nvPicPr>
         <p:blipFill>
-          <a:blip xmlns:r="http://schemas.openxmlformats.org/officeDocument/2006/relationships" xmlns:a="http://schemas.openxmlformats.org/drawingml/2006/main" r:embed="R8fab77e03271484b"/>
+          <a:blip xmlns:r="http://schemas.openxmlformats.org/officeDocument/2006/relationships" xmlns:a="http://schemas.openxmlformats.org/drawingml/2006/main" r:embed="R093806b11f0044f2"/>
           <a:stretch xmlns:a="http://schemas.openxmlformats.org/drawingml/2006/main"/>
         </p:blipFill>
         <p:spPr>
@@ -5859,7 +5859,7 @@
     </p:spTree>
     <p:extLst>
       <p:ext uri="{BB962C8B-B14F-4D97-AF65-F5344CB8AC3E}">
-        <p14:creationId xmlns:p14="http://schemas.microsoft.com/office/powerpoint/2010/main" val="1365824496"/>
+        <p14:creationId xmlns:p14="http://schemas.microsoft.com/office/powerpoint/2010/main" val="1620277623"/>
       </p:ext>
     </p:extLst>
   </p:cSld>
@@ -5890,7 +5890,7 @@
           <p:cNvPr id="9" name="">
             <a:extLst xmlns:a="http://schemas.openxmlformats.org/drawingml/2006/main">
               <a:ext uri="{FF2B5EF4-FFF2-40B4-BE49-F238E27FC236}">
-                <a16:creationId xmlns:a16="http://schemas.microsoft.com/office/drawing/2014/main" id="{9FA9DE71-96B4-459D-B10C-68EE9139A870}"/>
+                <a16:creationId xmlns:a16="http://schemas.microsoft.com/office/drawing/2014/main" id="{D07F87A4-0C7B-48D2-AD8A-858927E6A715}"/>
               </a:ext>
             </a:extLst>
           </p:cNvPr>
@@ -6046,7 +6046,7 @@
           <p:cNvPr id="2" name="">
             <a:extLst xmlns:a="http://schemas.openxmlformats.org/drawingml/2006/main">
               <a:ext uri="{FF2B5EF4-FFF2-40B4-BE49-F238E27FC236}">
-                <a16:creationId xmlns:a16="http://schemas.microsoft.com/office/drawing/2014/main" id="{DE32EF21-9C54-4B41-A419-C4067FBF95D3}"/>
+                <a16:creationId xmlns:a16="http://schemas.microsoft.com/office/drawing/2014/main" id="{8F9EFBD8-3CD2-41EA-889D-2444FA9F15A1}"/>
               </a:ext>
             </a:extLst>
           </p:cNvPr>
@@ -6202,7 +6202,7 @@
           <p:cNvPr id="3" name="">
             <a:extLst xmlns:a="http://schemas.openxmlformats.org/drawingml/2006/main">
               <a:ext uri="{FF2B5EF4-FFF2-40B4-BE49-F238E27FC236}">
-                <a16:creationId xmlns:a16="http://schemas.microsoft.com/office/drawing/2014/main" id="{665A47B4-84AD-4C85-84FE-D299C8EAB6C7}"/>
+                <a16:creationId xmlns:a16="http://schemas.microsoft.com/office/drawing/2014/main" id="{3D75B306-10A3-4C30-B237-F4407B5F9F18}"/>
               </a:ext>
             </a:extLst>
           </p:cNvPr>
@@ -6358,7 +6358,7 @@
           <p:cNvPr id="4" name="">
             <a:extLst xmlns:a="http://schemas.openxmlformats.org/drawingml/2006/main">
               <a:ext uri="{FF2B5EF4-FFF2-40B4-BE49-F238E27FC236}">
-                <a16:creationId xmlns:a16="http://schemas.microsoft.com/office/drawing/2014/main" id="{A8706D6E-2114-46A7-B9DD-4E0357A5301A}"/>
+                <a16:creationId xmlns:a16="http://schemas.microsoft.com/office/drawing/2014/main" id="{5E24A900-8D6A-42D4-A035-444B5FA4FB71}"/>
               </a:ext>
             </a:extLst>
           </p:cNvPr>
@@ -6537,7 +6537,7 @@
           <p:cNvPr id="5" name="">
             <a:extLst xmlns:a="http://schemas.openxmlformats.org/drawingml/2006/main">
               <a:ext uri="{FF2B5EF4-FFF2-40B4-BE49-F238E27FC236}">
-                <a16:creationId xmlns:a16="http://schemas.microsoft.com/office/drawing/2014/main" id="{FCD70DA3-69BD-4F09-8CF7-3FAC54FE0668}"/>
+                <a16:creationId xmlns:a16="http://schemas.microsoft.com/office/drawing/2014/main" id="{3062FFC6-A444-4DB5-9EE7-48F199645BA4}"/>
               </a:ext>
             </a:extLst>
           </p:cNvPr>
@@ -6693,7 +6693,7 @@
           <p:cNvPr id="6" name="">
             <a:extLst xmlns:a="http://schemas.openxmlformats.org/drawingml/2006/main">
               <a:ext uri="{FF2B5EF4-FFF2-40B4-BE49-F238E27FC236}">
-                <a16:creationId xmlns:a16="http://schemas.microsoft.com/office/drawing/2014/main" id="{FD091A3A-B2EA-46A8-811D-FF40723DA02E}"/>
+                <a16:creationId xmlns:a16="http://schemas.microsoft.com/office/drawing/2014/main" id="{D2EDC39D-D29F-4D5F-8CF2-CBE6A5D771D6}"/>
               </a:ext>
             </a:extLst>
           </p:cNvPr>
@@ -6849,7 +6849,7 @@
           <p:cNvPr id="7" name="">
             <a:extLst xmlns:a="http://schemas.openxmlformats.org/drawingml/2006/main">
               <a:ext uri="{FF2B5EF4-FFF2-40B4-BE49-F238E27FC236}">
-                <a16:creationId xmlns:a16="http://schemas.microsoft.com/office/drawing/2014/main" id="{467B7CAC-999B-49C0-854A-6100FF06BEF7}"/>
+                <a16:creationId xmlns:a16="http://schemas.microsoft.com/office/drawing/2014/main" id="{370B16E7-02C4-47CB-9B46-2E8D8A6B0273}"/>
               </a:ext>
             </a:extLst>
           </p:cNvPr>
@@ -7028,7 +7028,7 @@
           <p:cNvPr id="8" name="">
             <a:extLst xmlns:a="http://schemas.openxmlformats.org/drawingml/2006/main">
               <a:ext uri="{FF2B5EF4-FFF2-40B4-BE49-F238E27FC236}">
-                <a16:creationId xmlns:a16="http://schemas.microsoft.com/office/drawing/2014/main" id="{115799A0-B74E-40DA-80F7-F54B942F030B}"/>
+                <a16:creationId xmlns:a16="http://schemas.microsoft.com/office/drawing/2014/main" id="{4743B366-D57D-4211-9FFC-E78014DE120C}"/>
               </a:ext>
             </a:extLst>
           </p:cNvPr>
@@ -7038,7 +7038,7 @@
           <p:nvPr/>
         </p:nvPicPr>
         <p:blipFill>
-          <a:blip xmlns:r="http://schemas.openxmlformats.org/officeDocument/2006/relationships" xmlns:a="http://schemas.openxmlformats.org/drawingml/2006/main" r:embed="R15db016a6c684985"/>
+          <a:blip xmlns:r="http://schemas.openxmlformats.org/officeDocument/2006/relationships" xmlns:a="http://schemas.openxmlformats.org/drawingml/2006/main" r:embed="R61bc9d987a064a4c"/>
           <a:stretch xmlns:a="http://schemas.openxmlformats.org/drawingml/2006/main"/>
         </p:blipFill>
         <p:spPr>
@@ -7054,7 +7054,7 @@
     </p:spTree>
     <p:extLst>
       <p:ext uri="{BB962C8B-B14F-4D97-AF65-F5344CB8AC3E}">
-        <p14:creationId xmlns:p14="http://schemas.microsoft.com/office/powerpoint/2010/main" val="1138058020"/>
+        <p14:creationId xmlns:p14="http://schemas.microsoft.com/office/powerpoint/2010/main" val="1740789796"/>
       </p:ext>
     </p:extLst>
   </p:cSld>
@@ -7085,7 +7085,7 @@
           <p:cNvPr id="8" name="">
             <a:extLst xmlns:a="http://schemas.openxmlformats.org/drawingml/2006/main">
               <a:ext uri="{FF2B5EF4-FFF2-40B4-BE49-F238E27FC236}">
-                <a16:creationId xmlns:a16="http://schemas.microsoft.com/office/drawing/2014/main" id="{7E3DDD6C-F4CA-4B8C-903C-E4D645FD0E92}"/>
+                <a16:creationId xmlns:a16="http://schemas.microsoft.com/office/drawing/2014/main" id="{51A9449F-38DE-4623-9706-B62ABE9026F9}"/>
               </a:ext>
             </a:extLst>
           </p:cNvPr>
@@ -7241,7 +7241,7 @@
           <p:cNvPr id="2" name="">
             <a:extLst xmlns:a="http://schemas.openxmlformats.org/drawingml/2006/main">
               <a:ext uri="{FF2B5EF4-FFF2-40B4-BE49-F238E27FC236}">
-                <a16:creationId xmlns:a16="http://schemas.microsoft.com/office/drawing/2014/main" id="{8583D884-7AF5-4259-B1E4-178E5F6642F3}"/>
+                <a16:creationId xmlns:a16="http://schemas.microsoft.com/office/drawing/2014/main" id="{9EBD285D-2A73-42CB-BE3A-03F6B2C9AB13}"/>
               </a:ext>
             </a:extLst>
           </p:cNvPr>
@@ -7397,7 +7397,7 @@
           <p:cNvPr id="3" name="">
             <a:extLst xmlns:a="http://schemas.openxmlformats.org/drawingml/2006/main">
               <a:ext uri="{FF2B5EF4-FFF2-40B4-BE49-F238E27FC236}">
-                <a16:creationId xmlns:a16="http://schemas.microsoft.com/office/drawing/2014/main" id="{1ED94A44-B712-4047-976C-27FE4972FCCD}"/>
+                <a16:creationId xmlns:a16="http://schemas.microsoft.com/office/drawing/2014/main" id="{B417E273-4CA2-4F49-89B8-8350DBE92EE4}"/>
               </a:ext>
             </a:extLst>
           </p:cNvPr>
@@ -7553,7 +7553,7 @@
           <p:cNvPr id="4" name="">
             <a:extLst xmlns:a="http://schemas.openxmlformats.org/drawingml/2006/main">
               <a:ext uri="{FF2B5EF4-FFF2-40B4-BE49-F238E27FC236}">
-                <a16:creationId xmlns:a16="http://schemas.microsoft.com/office/drawing/2014/main" id="{349546BD-7B64-4592-B81C-1F636FC8E2DC}"/>
+                <a16:creationId xmlns:a16="http://schemas.microsoft.com/office/drawing/2014/main" id="{A07DAFC7-D8C0-4AE8-8A65-41A3D20AC037}"/>
               </a:ext>
             </a:extLst>
           </p:cNvPr>
@@ -7709,7 +7709,7 @@
           <p:cNvPr id="5" name="">
             <a:extLst xmlns:a="http://schemas.openxmlformats.org/drawingml/2006/main">
               <a:ext uri="{FF2B5EF4-FFF2-40B4-BE49-F238E27FC236}">
-                <a16:creationId xmlns:a16="http://schemas.microsoft.com/office/drawing/2014/main" id="{CB50A114-7FB0-4FEF-9890-E4EC38E7F41D}"/>
+                <a16:creationId xmlns:a16="http://schemas.microsoft.com/office/drawing/2014/main" id="{A9B5FD82-2851-4349-8473-3D8A05A927A6}"/>
               </a:ext>
             </a:extLst>
           </p:cNvPr>
@@ -7865,7 +7865,7 @@
           <p:cNvPr id="6" name="">
             <a:extLst xmlns:a="http://schemas.openxmlformats.org/drawingml/2006/main">
               <a:ext uri="{FF2B5EF4-FFF2-40B4-BE49-F238E27FC236}">
-                <a16:creationId xmlns:a16="http://schemas.microsoft.com/office/drawing/2014/main" id="{D2EA15CF-B697-48E7-9EED-D7D504C2A7F8}"/>
+                <a16:creationId xmlns:a16="http://schemas.microsoft.com/office/drawing/2014/main" id="{BB01BE55-C089-4BBF-9BC3-49601919B0B4}"/>
               </a:ext>
             </a:extLst>
           </p:cNvPr>
@@ -8021,7 +8021,7 @@
           <p:cNvPr id="7" name="">
             <a:extLst xmlns:a="http://schemas.openxmlformats.org/drawingml/2006/main">
               <a:ext uri="{FF2B5EF4-FFF2-40B4-BE49-F238E27FC236}">
-                <a16:creationId xmlns:a16="http://schemas.microsoft.com/office/drawing/2014/main" id="{701FBA0C-903C-49B4-9F59-2C25BCD24B59}"/>
+                <a16:creationId xmlns:a16="http://schemas.microsoft.com/office/drawing/2014/main" id="{6E6C3D19-D010-47CE-BBB0-48E6E1B01BDC}"/>
               </a:ext>
             </a:extLst>
           </p:cNvPr>
@@ -8175,7 +8175,7 @@
     </p:spTree>
     <p:extLst>
       <p:ext uri="{BB962C8B-B14F-4D97-AF65-F5344CB8AC3E}">
-        <p14:creationId xmlns:p14="http://schemas.microsoft.com/office/powerpoint/2010/main" val="550808420"/>
+        <p14:creationId xmlns:p14="http://schemas.microsoft.com/office/powerpoint/2010/main" val="154745372"/>
       </p:ext>
     </p:extLst>
   </p:cSld>
@@ -8206,7 +8206,7 @@
           <p:cNvPr id="17" name="">
             <a:extLst xmlns:a="http://schemas.openxmlformats.org/drawingml/2006/main">
               <a:ext uri="{FF2B5EF4-FFF2-40B4-BE49-F238E27FC236}">
-                <a16:creationId xmlns:a16="http://schemas.microsoft.com/office/drawing/2014/main" id="{F4095E7B-FF53-4EEB-817F-1C8AEA309F5D}"/>
+                <a16:creationId xmlns:a16="http://schemas.microsoft.com/office/drawing/2014/main" id="{6E9092D2-EC37-4DB4-AACA-0F3FC58F37D6}"/>
               </a:ext>
             </a:extLst>
           </p:cNvPr>
@@ -8362,7 +8362,7 @@
           <p:cNvPr id="2" name="">
             <a:extLst xmlns:a="http://schemas.openxmlformats.org/drawingml/2006/main">
               <a:ext uri="{FF2B5EF4-FFF2-40B4-BE49-F238E27FC236}">
-                <a16:creationId xmlns:a16="http://schemas.microsoft.com/office/drawing/2014/main" id="{84D16908-6B51-4681-AD0E-1CBD64F121A6}"/>
+                <a16:creationId xmlns:a16="http://schemas.microsoft.com/office/drawing/2014/main" id="{25F99DB0-63B2-4A64-B9DC-7314AEFB83E4}"/>
               </a:ext>
             </a:extLst>
           </p:cNvPr>
@@ -8518,7 +8518,7 @@
           <p:cNvPr id="3" name="">
             <a:extLst xmlns:a="http://schemas.openxmlformats.org/drawingml/2006/main">
               <a:ext uri="{FF2B5EF4-FFF2-40B4-BE49-F238E27FC236}">
-                <a16:creationId xmlns:a16="http://schemas.microsoft.com/office/drawing/2014/main" id="{8F26EB95-0D4B-4100-9DC3-839A83B017E0}"/>
+                <a16:creationId xmlns:a16="http://schemas.microsoft.com/office/drawing/2014/main" id="{E1DE3114-8B22-408B-BACE-248AFCCB31B4}"/>
               </a:ext>
             </a:extLst>
           </p:cNvPr>
@@ -8674,7 +8674,7 @@
           <p:cNvPr id="4" name="">
             <a:extLst xmlns:a="http://schemas.openxmlformats.org/drawingml/2006/main">
               <a:ext uri="{FF2B5EF4-FFF2-40B4-BE49-F238E27FC236}">
-                <a16:creationId xmlns:a16="http://schemas.microsoft.com/office/drawing/2014/main" id="{DD223DD7-396A-46F1-8B6C-D57379A71399}"/>
+                <a16:creationId xmlns:a16="http://schemas.microsoft.com/office/drawing/2014/main" id="{412C6688-30D6-4875-A433-C2E836D22D4D}"/>
               </a:ext>
             </a:extLst>
           </p:cNvPr>
@@ -8857,7 +8857,7 @@
           <p:cNvPr id="5" name="">
             <a:extLst xmlns:a="http://schemas.openxmlformats.org/drawingml/2006/main">
               <a:ext uri="{FF2B5EF4-FFF2-40B4-BE49-F238E27FC236}">
-                <a16:creationId xmlns:a16="http://schemas.microsoft.com/office/drawing/2014/main" id="{1A84AFFE-6840-4870-A0A9-3E69ED9C87B8}"/>
+                <a16:creationId xmlns:a16="http://schemas.microsoft.com/office/drawing/2014/main" id="{60DC3D38-5D5D-4B1D-A686-ECEC4E8B4ABC}"/>
               </a:ext>
             </a:extLst>
           </p:cNvPr>
@@ -9040,7 +9040,7 @@
           <p:cNvPr id="6" name="">
             <a:extLst xmlns:a="http://schemas.openxmlformats.org/drawingml/2006/main">
               <a:ext uri="{FF2B5EF4-FFF2-40B4-BE49-F238E27FC236}">
-                <a16:creationId xmlns:a16="http://schemas.microsoft.com/office/drawing/2014/main" id="{FF2501EF-CFA4-4EB1-B2E5-08F998994FB5}"/>
+                <a16:creationId xmlns:a16="http://schemas.microsoft.com/office/drawing/2014/main" id="{26EEDCEC-3B0B-41BC-874F-19DF05FF7924}"/>
               </a:ext>
             </a:extLst>
           </p:cNvPr>
@@ -9223,7 +9223,7 @@
           <p:cNvPr id="7" name="">
             <a:extLst xmlns:a="http://schemas.openxmlformats.org/drawingml/2006/main">
               <a:ext uri="{FF2B5EF4-FFF2-40B4-BE49-F238E27FC236}">
-                <a16:creationId xmlns:a16="http://schemas.microsoft.com/office/drawing/2014/main" id="{92B22CC5-D0B5-4475-B97C-BDBD09A02ADB}"/>
+                <a16:creationId xmlns:a16="http://schemas.microsoft.com/office/drawing/2014/main" id="{A6393B67-FE2A-4E9E-A283-A4B47476C3B0}"/>
               </a:ext>
             </a:extLst>
           </p:cNvPr>
@@ -9379,7 +9379,7 @@
           <p:cNvPr id="8" name="">
             <a:extLst xmlns:a="http://schemas.openxmlformats.org/drawingml/2006/main">
               <a:ext uri="{FF2B5EF4-FFF2-40B4-BE49-F238E27FC236}">
-                <a16:creationId xmlns:a16="http://schemas.microsoft.com/office/drawing/2014/main" id="{B09F8C49-27B8-49C8-98FA-42A724F996C6}"/>
+                <a16:creationId xmlns:a16="http://schemas.microsoft.com/office/drawing/2014/main" id="{E704C2AE-CDEC-4BEF-955F-27FE4F67F8BC}"/>
               </a:ext>
             </a:extLst>
           </p:cNvPr>
@@ -9535,7 +9535,7 @@
           <p:cNvPr id="9" name="">
             <a:extLst xmlns:a="http://schemas.openxmlformats.org/drawingml/2006/main">
               <a:ext uri="{FF2B5EF4-FFF2-40B4-BE49-F238E27FC236}">
-                <a16:creationId xmlns:a16="http://schemas.microsoft.com/office/drawing/2014/main" id="{1A0162B6-91C4-46EC-AED9-7FD097EAA728}"/>
+                <a16:creationId xmlns:a16="http://schemas.microsoft.com/office/drawing/2014/main" id="{C59E75BC-1CA1-4427-83AE-39B4DFD1E280}"/>
               </a:ext>
             </a:extLst>
           </p:cNvPr>
@@ -9718,7 +9718,7 @@
           <p:cNvPr id="10" name="">
             <a:extLst xmlns:a="http://schemas.openxmlformats.org/drawingml/2006/main">
               <a:ext uri="{FF2B5EF4-FFF2-40B4-BE49-F238E27FC236}">
-                <a16:creationId xmlns:a16="http://schemas.microsoft.com/office/drawing/2014/main" id="{3897FCB1-8B44-4269-93B3-6D730CA1140D}"/>
+                <a16:creationId xmlns:a16="http://schemas.microsoft.com/office/drawing/2014/main" id="{799CBEEC-5D6C-4864-83C4-EF2244E55EBA}"/>
               </a:ext>
             </a:extLst>
           </p:cNvPr>
@@ -9901,7 +9901,7 @@
           <p:cNvPr id="11" name="">
             <a:extLst xmlns:a="http://schemas.openxmlformats.org/drawingml/2006/main">
               <a:ext uri="{FF2B5EF4-FFF2-40B4-BE49-F238E27FC236}">
-                <a16:creationId xmlns:a16="http://schemas.microsoft.com/office/drawing/2014/main" id="{1095626B-AF75-455A-8FA9-C89A7129F005}"/>
+                <a16:creationId xmlns:a16="http://schemas.microsoft.com/office/drawing/2014/main" id="{E250AA86-EC38-47C2-B5B9-51390D2FEF5F}"/>
               </a:ext>
             </a:extLst>
           </p:cNvPr>
@@ -10084,7 +10084,7 @@
           <p:cNvPr id="12" name="">
             <a:extLst xmlns:a="http://schemas.openxmlformats.org/drawingml/2006/main">
               <a:ext uri="{FF2B5EF4-FFF2-40B4-BE49-F238E27FC236}">
-                <a16:creationId xmlns:a16="http://schemas.microsoft.com/office/drawing/2014/main" id="{134A1E08-F629-470D-9424-6420D615B324}"/>
+                <a16:creationId xmlns:a16="http://schemas.microsoft.com/office/drawing/2014/main" id="{C680D17C-BD68-4FA1-8E85-6E00043161A9}"/>
               </a:ext>
             </a:extLst>
           </p:cNvPr>
@@ -10240,7 +10240,7 @@
           <p:cNvPr id="13" name="">
             <a:extLst xmlns:a="http://schemas.openxmlformats.org/drawingml/2006/main">
               <a:ext uri="{FF2B5EF4-FFF2-40B4-BE49-F238E27FC236}">
-                <a16:creationId xmlns:a16="http://schemas.microsoft.com/office/drawing/2014/main" id="{2FEBDF5B-8621-4764-9254-8717BA979FB7}"/>
+                <a16:creationId xmlns:a16="http://schemas.microsoft.com/office/drawing/2014/main" id="{9686E464-8E05-48EB-9AEB-27A6C7F7AE8B}"/>
               </a:ext>
             </a:extLst>
           </p:cNvPr>
@@ -10396,7 +10396,7 @@
           <p:cNvPr id="14" name="">
             <a:extLst xmlns:a="http://schemas.openxmlformats.org/drawingml/2006/main">
               <a:ext uri="{FF2B5EF4-FFF2-40B4-BE49-F238E27FC236}">
-                <a16:creationId xmlns:a16="http://schemas.microsoft.com/office/drawing/2014/main" id="{AB151847-D7CE-4ED1-8AE7-BEE1D15AB459}"/>
+                <a16:creationId xmlns:a16="http://schemas.microsoft.com/office/drawing/2014/main" id="{3B73B9E4-5DAD-45E3-84FC-3000802FCFA5}"/>
               </a:ext>
             </a:extLst>
           </p:cNvPr>
@@ -10552,7 +10552,7 @@
           <p:cNvPr id="15" name="">
             <a:extLst xmlns:a="http://schemas.openxmlformats.org/drawingml/2006/main">
               <a:ext uri="{FF2B5EF4-FFF2-40B4-BE49-F238E27FC236}">
-                <a16:creationId xmlns:a16="http://schemas.microsoft.com/office/drawing/2014/main" id="{00AA963D-0415-4F1F-8A04-B84ECD9D5A7A}"/>
+                <a16:creationId xmlns:a16="http://schemas.microsoft.com/office/drawing/2014/main" id="{5F824FF8-D965-4D3B-A944-CA8921F5951C}"/>
               </a:ext>
             </a:extLst>
           </p:cNvPr>
@@ -10708,7 +10708,7 @@
           <p:cNvPr id="16" name="">
             <a:extLst xmlns:a="http://schemas.openxmlformats.org/drawingml/2006/main">
               <a:ext uri="{FF2B5EF4-FFF2-40B4-BE49-F238E27FC236}">
-                <a16:creationId xmlns:a16="http://schemas.microsoft.com/office/drawing/2014/main" id="{11020D91-D3EE-470D-BD2A-4E8FB09A5532}"/>
+                <a16:creationId xmlns:a16="http://schemas.microsoft.com/office/drawing/2014/main" id="{738ABE9D-9C37-4EEC-8E15-667FB2226956}"/>
               </a:ext>
             </a:extLst>
           </p:cNvPr>
@@ -10862,7 +10862,7 @@
     </p:spTree>
     <p:extLst>
       <p:ext uri="{BB962C8B-B14F-4D97-AF65-F5344CB8AC3E}">
-        <p14:creationId xmlns:p14="http://schemas.microsoft.com/office/powerpoint/2010/main" val="837505189"/>
+        <p14:creationId xmlns:p14="http://schemas.microsoft.com/office/powerpoint/2010/main" val="1039246245"/>
       </p:ext>
     </p:extLst>
   </p:cSld>
@@ -10893,7 +10893,7 @@
           <p:cNvPr id="8" name="">
             <a:extLst xmlns:a="http://schemas.openxmlformats.org/drawingml/2006/main">
               <a:ext uri="{FF2B5EF4-FFF2-40B4-BE49-F238E27FC236}">
-                <a16:creationId xmlns:a16="http://schemas.microsoft.com/office/drawing/2014/main" id="{7E61E142-68C0-4FD0-BE7E-D87FF36A9EAC}"/>
+                <a16:creationId xmlns:a16="http://schemas.microsoft.com/office/drawing/2014/main" id="{53CE4220-896E-4785-9C26-49F01393DE0E}"/>
               </a:ext>
             </a:extLst>
           </p:cNvPr>
@@ -11049,7 +11049,7 @@
           <p:cNvPr id="2" name="">
             <a:extLst xmlns:a="http://schemas.openxmlformats.org/drawingml/2006/main">
               <a:ext uri="{FF2B5EF4-FFF2-40B4-BE49-F238E27FC236}">
-                <a16:creationId xmlns:a16="http://schemas.microsoft.com/office/drawing/2014/main" id="{166FA854-122B-4836-BDC9-4BBC9530A0D4}"/>
+                <a16:creationId xmlns:a16="http://schemas.microsoft.com/office/drawing/2014/main" id="{D29CC27E-1AD0-43CF-8C32-E8EBA0506E88}"/>
               </a:ext>
             </a:extLst>
           </p:cNvPr>
@@ -11205,7 +11205,7 @@
           <p:cNvPr id="3" name="">
             <a:extLst xmlns:a="http://schemas.openxmlformats.org/drawingml/2006/main">
               <a:ext uri="{FF2B5EF4-FFF2-40B4-BE49-F238E27FC236}">
-                <a16:creationId xmlns:a16="http://schemas.microsoft.com/office/drawing/2014/main" id="{42CC9535-C223-4549-9134-76D38E469422}"/>
+                <a16:creationId xmlns:a16="http://schemas.microsoft.com/office/drawing/2014/main" id="{A8F04B21-941A-418B-A0EC-8D6F08BCE39D}"/>
               </a:ext>
             </a:extLst>
           </p:cNvPr>
@@ -11361,7 +11361,7 @@
           <p:cNvPr id="4" name="">
             <a:extLst xmlns:a="http://schemas.openxmlformats.org/drawingml/2006/main">
               <a:ext uri="{FF2B5EF4-FFF2-40B4-BE49-F238E27FC236}">
-                <a16:creationId xmlns:a16="http://schemas.microsoft.com/office/drawing/2014/main" id="{7ACD7DC4-EAFA-4BDB-B5FA-BC6FE377D14D}"/>
+                <a16:creationId xmlns:a16="http://schemas.microsoft.com/office/drawing/2014/main" id="{C0E8C284-5025-407C-A554-B01000153BDF}"/>
               </a:ext>
             </a:extLst>
           </p:cNvPr>
@@ -11801,7 +11801,7 @@
           <p:cNvPr id="5" name="">
             <a:extLst xmlns:a="http://schemas.openxmlformats.org/drawingml/2006/main">
               <a:ext uri="{FF2B5EF4-FFF2-40B4-BE49-F238E27FC236}">
-                <a16:creationId xmlns:a16="http://schemas.microsoft.com/office/drawing/2014/main" id="{832B394B-E0A5-45A4-912A-83A62C07879A}"/>
+                <a16:creationId xmlns:a16="http://schemas.microsoft.com/office/drawing/2014/main" id="{31314528-2E91-401C-A61A-DD9E2A480A99}"/>
               </a:ext>
             </a:extLst>
           </p:cNvPr>
@@ -11957,7 +11957,7 @@
           <p:cNvPr id="6" name="">
             <a:extLst xmlns:a="http://schemas.openxmlformats.org/drawingml/2006/main">
               <a:ext uri="{FF2B5EF4-FFF2-40B4-BE49-F238E27FC236}">
-                <a16:creationId xmlns:a16="http://schemas.microsoft.com/office/drawing/2014/main" id="{1D6A3CED-11C2-42EA-AD34-84C2C14DD341}"/>
+                <a16:creationId xmlns:a16="http://schemas.microsoft.com/office/drawing/2014/main" id="{63FEB702-07BA-4DF4-A41E-97A298C6BC57}"/>
               </a:ext>
             </a:extLst>
           </p:cNvPr>
@@ -12113,7 +12113,7 @@
           <p:cNvPr id="7" name="">
             <a:extLst xmlns:a="http://schemas.openxmlformats.org/drawingml/2006/main">
               <a:ext uri="{FF2B5EF4-FFF2-40B4-BE49-F238E27FC236}">
-                <a16:creationId xmlns:a16="http://schemas.microsoft.com/office/drawing/2014/main" id="{76984364-1630-40BE-8F98-F28D9DF6F9AB}"/>
+                <a16:creationId xmlns:a16="http://schemas.microsoft.com/office/drawing/2014/main" id="{3DC04E4F-5EE3-466A-AAD2-57ED5A5C30C1}"/>
               </a:ext>
             </a:extLst>
           </p:cNvPr>
@@ -12123,7 +12123,7 @@
           <p:nvPr/>
         </p:nvPicPr>
         <p:blipFill>
-          <a:blip xmlns:r="http://schemas.openxmlformats.org/officeDocument/2006/relationships" xmlns:a="http://schemas.openxmlformats.org/drawingml/2006/main" r:embed="R44aade95ddc845b2"/>
+          <a:blip xmlns:r="http://schemas.openxmlformats.org/officeDocument/2006/relationships" xmlns:a="http://schemas.openxmlformats.org/drawingml/2006/main" r:embed="R75148b9a53a5442a"/>
           <a:stretch xmlns:a="http://schemas.openxmlformats.org/drawingml/2006/main"/>
         </p:blipFill>
         <p:spPr>
@@ -12139,7 +12139,7 @@
     </p:spTree>
     <p:extLst>
       <p:ext uri="{BB962C8B-B14F-4D97-AF65-F5344CB8AC3E}">
-        <p14:creationId xmlns:p14="http://schemas.microsoft.com/office/powerpoint/2010/main" val="733509236"/>
+        <p14:creationId xmlns:p14="http://schemas.microsoft.com/office/powerpoint/2010/main" val="1458228675"/>
       </p:ext>
     </p:extLst>
   </p:cSld>
@@ -12170,7 +12170,7 @@
           <p:cNvPr id="10" name="">
             <a:extLst xmlns:a="http://schemas.openxmlformats.org/drawingml/2006/main">
               <a:ext uri="{FF2B5EF4-FFF2-40B4-BE49-F238E27FC236}">
-                <a16:creationId xmlns:a16="http://schemas.microsoft.com/office/drawing/2014/main" id="{09883ADE-BC4D-4FA2-97D8-1C574EAEBAC6}"/>
+                <a16:creationId xmlns:a16="http://schemas.microsoft.com/office/drawing/2014/main" id="{2FFD980E-41A9-4BD8-B72A-CC71583938E3}"/>
               </a:ext>
             </a:extLst>
           </p:cNvPr>
@@ -12326,7 +12326,7 @@
           <p:cNvPr id="2" name="">
             <a:extLst xmlns:a="http://schemas.openxmlformats.org/drawingml/2006/main">
               <a:ext uri="{FF2B5EF4-FFF2-40B4-BE49-F238E27FC236}">
-                <a16:creationId xmlns:a16="http://schemas.microsoft.com/office/drawing/2014/main" id="{9AA4F295-DF28-408C-AA7A-6A7107EF2DCC}"/>
+                <a16:creationId xmlns:a16="http://schemas.microsoft.com/office/drawing/2014/main" id="{1A9B8590-613A-4B8B-BA3A-639B6958E959}"/>
               </a:ext>
             </a:extLst>
           </p:cNvPr>
@@ -12482,7 +12482,7 @@
           <p:cNvPr id="3" name="">
             <a:extLst xmlns:a="http://schemas.openxmlformats.org/drawingml/2006/main">
               <a:ext uri="{FF2B5EF4-FFF2-40B4-BE49-F238E27FC236}">
-                <a16:creationId xmlns:a16="http://schemas.microsoft.com/office/drawing/2014/main" id="{F5D23C42-7CE0-4ABB-BC40-367BFD64CED2}"/>
+                <a16:creationId xmlns:a16="http://schemas.microsoft.com/office/drawing/2014/main" id="{C40097BA-913C-4FBC-9426-F50CE29A1B9C}"/>
               </a:ext>
             </a:extLst>
           </p:cNvPr>
@@ -12638,7 +12638,7 @@
           <p:cNvPr id="4" name="">
             <a:extLst xmlns:a="http://schemas.openxmlformats.org/drawingml/2006/main">
               <a:ext uri="{FF2B5EF4-FFF2-40B4-BE49-F238E27FC236}">
-                <a16:creationId xmlns:a16="http://schemas.microsoft.com/office/drawing/2014/main" id="{68A6DB4A-EF18-4456-9E8C-43445776852B}"/>
+                <a16:creationId xmlns:a16="http://schemas.microsoft.com/office/drawing/2014/main" id="{358766EA-E736-4DF0-8CDA-8F75CD19AC32}"/>
               </a:ext>
             </a:extLst>
           </p:cNvPr>
@@ -12794,7 +12794,7 @@
           <p:cNvPr id="5" name="">
             <a:extLst xmlns:a="http://schemas.openxmlformats.org/drawingml/2006/main">
               <a:ext uri="{FF2B5EF4-FFF2-40B4-BE49-F238E27FC236}">
-                <a16:creationId xmlns:a16="http://schemas.microsoft.com/office/drawing/2014/main" id="{BB7434F3-4F8C-4351-AE07-EC9510892D1E}"/>
+                <a16:creationId xmlns:a16="http://schemas.microsoft.com/office/drawing/2014/main" id="{D397C71E-6395-4C3D-AB2A-CD5D6BD81BCA}"/>
               </a:ext>
             </a:extLst>
           </p:cNvPr>
@@ -12950,7 +12950,7 @@
           <p:cNvPr id="6" name="">
             <a:extLst xmlns:a="http://schemas.openxmlformats.org/drawingml/2006/main">
               <a:ext uri="{FF2B5EF4-FFF2-40B4-BE49-F238E27FC236}">
-                <a16:creationId xmlns:a16="http://schemas.microsoft.com/office/drawing/2014/main" id="{A3273BC3-CB30-440E-9DBF-9797BCB05AEA}"/>
+                <a16:creationId xmlns:a16="http://schemas.microsoft.com/office/drawing/2014/main" id="{E5004240-E499-49DD-99D2-F8967A6A5A75}"/>
               </a:ext>
             </a:extLst>
           </p:cNvPr>
@@ -13106,7 +13106,7 @@
           <p:cNvPr id="7" name="">
             <a:extLst xmlns:a="http://schemas.openxmlformats.org/drawingml/2006/main">
               <a:ext uri="{FF2B5EF4-FFF2-40B4-BE49-F238E27FC236}">
-                <a16:creationId xmlns:a16="http://schemas.microsoft.com/office/drawing/2014/main" id="{DB7F6D87-0F5E-4E15-9B0B-3F8F118C6B4F}"/>
+                <a16:creationId xmlns:a16="http://schemas.microsoft.com/office/drawing/2014/main" id="{9129DBDC-82CE-43C5-9382-E68C89BF770F}"/>
               </a:ext>
             </a:extLst>
           </p:cNvPr>
@@ -13262,7 +13262,7 @@
           <p:cNvPr id="8" name="">
             <a:extLst xmlns:a="http://schemas.openxmlformats.org/drawingml/2006/main">
               <a:ext uri="{FF2B5EF4-FFF2-40B4-BE49-F238E27FC236}">
-                <a16:creationId xmlns:a16="http://schemas.microsoft.com/office/drawing/2014/main" id="{8F499CCB-A8F8-446B-ACBA-E350819050FD}"/>
+                <a16:creationId xmlns:a16="http://schemas.microsoft.com/office/drawing/2014/main" id="{B9C5BFBA-D760-4ADE-992A-00F3C615C35F}"/>
               </a:ext>
             </a:extLst>
           </p:cNvPr>
@@ -13441,7 +13441,7 @@
           <p:cNvPr id="9" name="">
             <a:extLst xmlns:a="http://schemas.openxmlformats.org/drawingml/2006/main">
               <a:ext uri="{FF2B5EF4-FFF2-40B4-BE49-F238E27FC236}">
-                <a16:creationId xmlns:a16="http://schemas.microsoft.com/office/drawing/2014/main" id="{6E65F5BA-BEBE-46A4-924D-193750B237D9}"/>
+                <a16:creationId xmlns:a16="http://schemas.microsoft.com/office/drawing/2014/main" id="{8162AA0A-C4BA-46DF-B901-A4303A362DF3}"/>
               </a:ext>
             </a:extLst>
           </p:cNvPr>
@@ -13451,7 +13451,7 @@
           <p:nvPr/>
         </p:nvPicPr>
         <p:blipFill>
-          <a:blip xmlns:r="http://schemas.openxmlformats.org/officeDocument/2006/relationships" xmlns:a="http://schemas.openxmlformats.org/drawingml/2006/main" r:embed="R2d46ef3310f64827"/>
+          <a:blip xmlns:r="http://schemas.openxmlformats.org/officeDocument/2006/relationships" xmlns:a="http://schemas.openxmlformats.org/drawingml/2006/main" r:embed="R831d94cfe0dc478b"/>
           <a:stretch xmlns:a="http://schemas.openxmlformats.org/drawingml/2006/main"/>
         </p:blipFill>
         <p:spPr>
@@ -13467,7 +13467,7 @@
     </p:spTree>
     <p:extLst>
       <p:ext uri="{BB962C8B-B14F-4D97-AF65-F5344CB8AC3E}">
-        <p14:creationId xmlns:p14="http://schemas.microsoft.com/office/powerpoint/2010/main" val="1432368541"/>
+        <p14:creationId xmlns:p14="http://schemas.microsoft.com/office/powerpoint/2010/main" val="2021819430"/>
       </p:ext>
     </p:extLst>
   </p:cSld>
@@ -13498,7 +13498,7 @@
           <p:cNvPr id="7" name="">
             <a:extLst xmlns:a="http://schemas.openxmlformats.org/drawingml/2006/main">
               <a:ext uri="{FF2B5EF4-FFF2-40B4-BE49-F238E27FC236}">
-                <a16:creationId xmlns:a16="http://schemas.microsoft.com/office/drawing/2014/main" id="{896AEDE1-79A1-499E-AEAC-B3CD49FEA662}"/>
+                <a16:creationId xmlns:a16="http://schemas.microsoft.com/office/drawing/2014/main" id="{125143CA-958A-428C-BDFC-2559FAE35F42}"/>
               </a:ext>
             </a:extLst>
           </p:cNvPr>
@@ -13654,7 +13654,7 @@
           <p:cNvPr id="2" name="">
             <a:extLst xmlns:a="http://schemas.openxmlformats.org/drawingml/2006/main">
               <a:ext uri="{FF2B5EF4-FFF2-40B4-BE49-F238E27FC236}">
-                <a16:creationId xmlns:a16="http://schemas.microsoft.com/office/drawing/2014/main" id="{1E22328C-60EC-430F-9242-36E92954C85C}"/>
+                <a16:creationId xmlns:a16="http://schemas.microsoft.com/office/drawing/2014/main" id="{249DCCFE-0369-4A98-8008-375ADEC52062}"/>
               </a:ext>
             </a:extLst>
           </p:cNvPr>
@@ -13810,7 +13810,7 @@
           <p:cNvPr id="3" name="">
             <a:extLst xmlns:a="http://schemas.openxmlformats.org/drawingml/2006/main">
               <a:ext uri="{FF2B5EF4-FFF2-40B4-BE49-F238E27FC236}">
-                <a16:creationId xmlns:a16="http://schemas.microsoft.com/office/drawing/2014/main" id="{2F9F52F3-0A06-498A-AAAA-BB646DB1EC57}"/>
+                <a16:creationId xmlns:a16="http://schemas.microsoft.com/office/drawing/2014/main" id="{50C1D7D3-FF18-4AF7-9120-C819196266B3}"/>
               </a:ext>
             </a:extLst>
           </p:cNvPr>
@@ -13966,7 +13966,7 @@
           <p:cNvPr id="4" name="">
             <a:extLst xmlns:a="http://schemas.openxmlformats.org/drawingml/2006/main">
               <a:ext uri="{FF2B5EF4-FFF2-40B4-BE49-F238E27FC236}">
-                <a16:creationId xmlns:a16="http://schemas.microsoft.com/office/drawing/2014/main" id="{6D44E37A-C1BC-48C8-A68C-AD8E812DCE1D}"/>
+                <a16:creationId xmlns:a16="http://schemas.microsoft.com/office/drawing/2014/main" id="{5CB48062-3E48-4BAA-9D39-DCFA64155F72}"/>
               </a:ext>
             </a:extLst>
           </p:cNvPr>
@@ -14140,7 +14140,7 @@
                 <a:ea typeface="Arial"/>
                 <a:cs typeface="Arial"/>
               </a:rPr>
-              <a:t>Exact saved evidence</a:t>
+              <a:t>Revocable sessions</a:t>
             </a:r>
           </a:p>
           <a:p xmlns:a="http://schemas.openxmlformats.org/drawingml/2006/main">
@@ -14168,7 +14168,7 @@
                 <a:ea typeface="Arial"/>
                 <a:cs typeface="Arial"/>
               </a:rPr>
-              <a:t>One payment transaction</a:t>
+              <a:t>Private files and usage caps</a:t>
             </a:r>
           </a:p>
           <a:p xmlns:a="http://schemas.openxmlformats.org/drawingml/2006/main">
@@ -14196,7 +14196,7 @@
                 <a:ea typeface="Arial"/>
                 <a:cs typeface="Arial"/>
               </a:rPr>
-              <a:t>Local audit verification</a:t>
+              <a:t>Verifiable audit evidence</a:t>
             </a:r>
           </a:p>
         </p:txBody>
@@ -14206,7 +14206,7 @@
           <p:cNvPr id="5" name="">
             <a:extLst xmlns:a="http://schemas.openxmlformats.org/drawingml/2006/main">
               <a:ext uri="{FF2B5EF4-FFF2-40B4-BE49-F238E27FC236}">
-                <a16:creationId xmlns:a16="http://schemas.microsoft.com/office/drawing/2014/main" id="{CD5354BF-E04D-4539-A69B-FC0DC081A7A5}"/>
+                <a16:creationId xmlns:a16="http://schemas.microsoft.com/office/drawing/2014/main" id="{BA1A30F9-490C-47CA-88F3-050A4E09CDF5}"/>
               </a:ext>
             </a:extLst>
           </p:cNvPr>
@@ -14374,7 +14374,7 @@
                           <a:ea typeface="Arial"/>
                           <a:cs typeface="Arial"/>
                         </a:rPr>
-                        <a:t>203</a:t>
+                        <a:t>225</a:t>
                       </a:r>
                     </a:p>
                   </a:txBody>
@@ -14534,7 +14534,7 @@
                           <a:ea typeface="Arial"/>
                           <a:cs typeface="Arial"/>
                         </a:rPr>
-                        <a:t>16</a:t>
+                        <a:t>18</a:t>
                       </a:r>
                     </a:p>
                   </a:txBody>
@@ -14646,7 +14646,7 @@
           <p:cNvPr id="6" name="">
             <a:extLst xmlns:a="http://schemas.openxmlformats.org/drawingml/2006/main">
               <a:ext uri="{FF2B5EF4-FFF2-40B4-BE49-F238E27FC236}">
-                <a16:creationId xmlns:a16="http://schemas.microsoft.com/office/drawing/2014/main" id="{D153D4F4-437F-4778-A9EC-9BD5FD812B2F}"/>
+                <a16:creationId xmlns:a16="http://schemas.microsoft.com/office/drawing/2014/main" id="{77DD89C1-3D89-4E70-90B6-7C27AD44055E}"/>
               </a:ext>
             </a:extLst>
           </p:cNvPr>
@@ -14800,7 +14800,7 @@
     </p:spTree>
     <p:extLst>
       <p:ext uri="{BB962C8B-B14F-4D97-AF65-F5344CB8AC3E}">
-        <p14:creationId xmlns:p14="http://schemas.microsoft.com/office/powerpoint/2010/main" val="183608808"/>
+        <p14:creationId xmlns:p14="http://schemas.microsoft.com/office/powerpoint/2010/main" val="1138716122"/>
       </p:ext>
     </p:extLst>
   </p:cSld>
@@ -14831,7 +14831,7 @@
           <p:cNvPr id="10" name="">
             <a:extLst xmlns:a="http://schemas.openxmlformats.org/drawingml/2006/main">
               <a:ext uri="{FF2B5EF4-FFF2-40B4-BE49-F238E27FC236}">
-                <a16:creationId xmlns:a16="http://schemas.microsoft.com/office/drawing/2014/main" id="{5BD45E17-9DE9-499B-8E98-F60A1B8C049E}"/>
+                <a16:creationId xmlns:a16="http://schemas.microsoft.com/office/drawing/2014/main" id="{5902A516-2EF7-4197-BC01-516A6570EE85}"/>
               </a:ext>
             </a:extLst>
           </p:cNvPr>
@@ -14987,7 +14987,7 @@
           <p:cNvPr id="2" name="">
             <a:extLst xmlns:a="http://schemas.openxmlformats.org/drawingml/2006/main">
               <a:ext uri="{FF2B5EF4-FFF2-40B4-BE49-F238E27FC236}">
-                <a16:creationId xmlns:a16="http://schemas.microsoft.com/office/drawing/2014/main" id="{65209AF7-BB58-4646-AB18-4BBBEAB93689}"/>
+                <a16:creationId xmlns:a16="http://schemas.microsoft.com/office/drawing/2014/main" id="{0BAF968F-3AC1-48D1-BE1B-0129B6B8CDF8}"/>
               </a:ext>
             </a:extLst>
           </p:cNvPr>
@@ -15143,7 +15143,7 @@
           <p:cNvPr id="3" name="">
             <a:extLst xmlns:a="http://schemas.openxmlformats.org/drawingml/2006/main">
               <a:ext uri="{FF2B5EF4-FFF2-40B4-BE49-F238E27FC236}">
-                <a16:creationId xmlns:a16="http://schemas.microsoft.com/office/drawing/2014/main" id="{C19BCF08-FD29-42F5-BF78-E0707FA92D2E}"/>
+                <a16:creationId xmlns:a16="http://schemas.microsoft.com/office/drawing/2014/main" id="{613B2CC0-9FD7-4330-8726-828E568CE034}"/>
               </a:ext>
             </a:extLst>
           </p:cNvPr>
@@ -15299,7 +15299,7 @@
           <p:cNvPr id="4" name="">
             <a:extLst xmlns:a="http://schemas.openxmlformats.org/drawingml/2006/main">
               <a:ext uri="{FF2B5EF4-FFF2-40B4-BE49-F238E27FC236}">
-                <a16:creationId xmlns:a16="http://schemas.microsoft.com/office/drawing/2014/main" id="{30292761-BAD3-491E-8407-5B573245E7F9}"/>
+                <a16:creationId xmlns:a16="http://schemas.microsoft.com/office/drawing/2014/main" id="{4DADF2D2-54EF-40C8-B07C-D5F2482CBFB7}"/>
               </a:ext>
             </a:extLst>
           </p:cNvPr>
@@ -15455,7 +15455,7 @@
           <p:cNvPr id="5" name="">
             <a:extLst xmlns:a="http://schemas.openxmlformats.org/drawingml/2006/main">
               <a:ext uri="{FF2B5EF4-FFF2-40B4-BE49-F238E27FC236}">
-                <a16:creationId xmlns:a16="http://schemas.microsoft.com/office/drawing/2014/main" id="{A0487BA2-3EB0-4834-8DE5-E7F052230B35}"/>
+                <a16:creationId xmlns:a16="http://schemas.microsoft.com/office/drawing/2014/main" id="{B889DC0A-A602-4AAA-9EA0-F3250BE59D31}"/>
               </a:ext>
             </a:extLst>
           </p:cNvPr>
@@ -15611,7 +15611,7 @@
           <p:cNvPr id="6" name="">
             <a:extLst xmlns:a="http://schemas.openxmlformats.org/drawingml/2006/main">
               <a:ext uri="{FF2B5EF4-FFF2-40B4-BE49-F238E27FC236}">
-                <a16:creationId xmlns:a16="http://schemas.microsoft.com/office/drawing/2014/main" id="{CAF03CA8-4073-473A-A541-7F5D31EAA286}"/>
+                <a16:creationId xmlns:a16="http://schemas.microsoft.com/office/drawing/2014/main" id="{6F2241B8-1C65-40DA-9B3A-A1A381E60E48}"/>
               </a:ext>
             </a:extLst>
           </p:cNvPr>
@@ -15767,7 +15767,7 @@
           <p:cNvPr id="7" name="">
             <a:extLst xmlns:a="http://schemas.openxmlformats.org/drawingml/2006/main">
               <a:ext uri="{FF2B5EF4-FFF2-40B4-BE49-F238E27FC236}">
-                <a16:creationId xmlns:a16="http://schemas.microsoft.com/office/drawing/2014/main" id="{18768C34-4D8D-477A-BF1A-E6D03678EA2D}"/>
+                <a16:creationId xmlns:a16="http://schemas.microsoft.com/office/drawing/2014/main" id="{5C8A1F2D-72F9-41ED-9164-BBF98DC86845}"/>
               </a:ext>
             </a:extLst>
           </p:cNvPr>
@@ -15923,7 +15923,7 @@
           <p:cNvPr id="8" name="">
             <a:extLst xmlns:a="http://schemas.openxmlformats.org/drawingml/2006/main">
               <a:ext uri="{FF2B5EF4-FFF2-40B4-BE49-F238E27FC236}">
-                <a16:creationId xmlns:a16="http://schemas.microsoft.com/office/drawing/2014/main" id="{94733104-FB88-4F8B-AFEF-3440B60068F7}"/>
+                <a16:creationId xmlns:a16="http://schemas.microsoft.com/office/drawing/2014/main" id="{0BCCEA40-676F-4C62-BCCB-745F9CB44643}"/>
               </a:ext>
             </a:extLst>
           </p:cNvPr>
@@ -15933,7 +15933,7 @@
           <p:nvPr/>
         </p:nvPicPr>
         <p:blipFill>
-          <a:blip xmlns:r="http://schemas.openxmlformats.org/officeDocument/2006/relationships" xmlns:a="http://schemas.openxmlformats.org/drawingml/2006/main" r:embed="R138af91f15ae4a40"/>
+          <a:blip xmlns:r="http://schemas.openxmlformats.org/officeDocument/2006/relationships" xmlns:a="http://schemas.openxmlformats.org/drawingml/2006/main" r:embed="Rcaf0225493c24944"/>
           <a:stretch xmlns:a="http://schemas.openxmlformats.org/drawingml/2006/main"/>
         </p:blipFill>
         <p:spPr>
@@ -15951,7 +15951,7 @@
           <p:cNvPr id="9" name="">
             <a:extLst xmlns:a="http://schemas.openxmlformats.org/drawingml/2006/main">
               <a:ext uri="{FF2B5EF4-FFF2-40B4-BE49-F238E27FC236}">
-                <a16:creationId xmlns:a16="http://schemas.microsoft.com/office/drawing/2014/main" id="{B26047EE-98DA-4D16-8EFB-E7023067F49F}"/>
+                <a16:creationId xmlns:a16="http://schemas.microsoft.com/office/drawing/2014/main" id="{7B9D8A91-EC0A-48A6-9EAA-8923CEA686B8}"/>
               </a:ext>
             </a:extLst>
           </p:cNvPr>
@@ -16105,7 +16105,7 @@
     </p:spTree>
     <p:extLst>
       <p:ext uri="{BB962C8B-B14F-4D97-AF65-F5344CB8AC3E}">
-        <p14:creationId xmlns:p14="http://schemas.microsoft.com/office/powerpoint/2010/main" val="1580532482"/>
+        <p14:creationId xmlns:p14="http://schemas.microsoft.com/office/powerpoint/2010/main" val="1786176929"/>
       </p:ext>
     </p:extLst>
   </p:cSld>

</xml_diff>

<commit_message>
Add authenticator security and publish verified judge package
</commit_message>
<xml_diff>
--- a/submission/BuildTrustAI_Presentation.pptx
+++ b/submission/BuildTrustAI_Presentation.pptx
@@ -2,21 +2,21 @@
 <file path=ppt/presentation.xml><?xml version="1.0" encoding="utf-8"?>
 <p:presentation xmlns:p="http://schemas.openxmlformats.org/presentationml/2006/main">
   <p:sldMasterIdLst>
-    <p:sldMasterId xmlns:r="http://schemas.openxmlformats.org/officeDocument/2006/relationships" id="2147483648" r:id="R1d16593f550045b5"/>
+    <p:sldMasterId xmlns:r="http://schemas.openxmlformats.org/officeDocument/2006/relationships" id="2147483648" r:id="R2a2fd2445bc74623"/>
   </p:sldMasterIdLst>
   <p:notesMasterIdLst>
-    <p:notesMasterId xmlns:r="http://schemas.openxmlformats.org/officeDocument/2006/relationships" r:id="R78a4d4bdb3d6479d"/>
+    <p:notesMasterId xmlns:r="http://schemas.openxmlformats.org/officeDocument/2006/relationships" r:id="R6cb10c73967745a1"/>
   </p:notesMasterIdLst>
   <p:sldIdLst>
-    <p:sldId xmlns:r="http://schemas.openxmlformats.org/officeDocument/2006/relationships" id="256" r:id="R3fd8382407cb4384"/>
-    <p:sldId xmlns:r="http://schemas.openxmlformats.org/officeDocument/2006/relationships" id="257" r:id="Raf15624f11b54520"/>
-    <p:sldId xmlns:r="http://schemas.openxmlformats.org/officeDocument/2006/relationships" id="258" r:id="Rb937c27887ec4d7d"/>
-    <p:sldId xmlns:r="http://schemas.openxmlformats.org/officeDocument/2006/relationships" id="259" r:id="Re10e6551fb534dd3"/>
-    <p:sldId xmlns:r="http://schemas.openxmlformats.org/officeDocument/2006/relationships" id="260" r:id="Rf874a2c5a52041be"/>
-    <p:sldId xmlns:r="http://schemas.openxmlformats.org/officeDocument/2006/relationships" id="261" r:id="Rad26df668ffb4d3d"/>
-    <p:sldId xmlns:r="http://schemas.openxmlformats.org/officeDocument/2006/relationships" id="262" r:id="Rcb8cf4c1c6f14b4f"/>
-    <p:sldId xmlns:r="http://schemas.openxmlformats.org/officeDocument/2006/relationships" id="263" r:id="R6b6d1c9adc9a493f"/>
-    <p:sldId xmlns:r="http://schemas.openxmlformats.org/officeDocument/2006/relationships" id="264" r:id="R6b0f397ba79e440d"/>
+    <p:sldId xmlns:r="http://schemas.openxmlformats.org/officeDocument/2006/relationships" id="256" r:id="R775a9c97ac914e2f"/>
+    <p:sldId xmlns:r="http://schemas.openxmlformats.org/officeDocument/2006/relationships" id="257" r:id="R6211515a4b0a4164"/>
+    <p:sldId xmlns:r="http://schemas.openxmlformats.org/officeDocument/2006/relationships" id="258" r:id="Ree3dfeb95ce64155"/>
+    <p:sldId xmlns:r="http://schemas.openxmlformats.org/officeDocument/2006/relationships" id="259" r:id="R267c9a1d76e0400d"/>
+    <p:sldId xmlns:r="http://schemas.openxmlformats.org/officeDocument/2006/relationships" id="260" r:id="Rb442da6c561e4538"/>
+    <p:sldId xmlns:r="http://schemas.openxmlformats.org/officeDocument/2006/relationships" id="261" r:id="R0f26abdccd3c4233"/>
+    <p:sldId xmlns:r="http://schemas.openxmlformats.org/officeDocument/2006/relationships" id="262" r:id="R53d9d391ee604936"/>
+    <p:sldId xmlns:r="http://schemas.openxmlformats.org/officeDocument/2006/relationships" id="263" r:id="R0ed6f840955a4ccd"/>
+    <p:sldId xmlns:r="http://schemas.openxmlformats.org/officeDocument/2006/relationships" id="264" r:id="Rcad743ad65294bdf"/>
   </p:sldIdLst>
   <p:sldSz cx="12192000" cy="6858000"/>
   <p:notesSz cx="6858000" cy="9144000"/>
@@ -940,7 +940,7 @@
           <a:lstStyle xmlns:a="http://schemas.openxmlformats.org/drawingml/2006/main"/>
           <a:p xmlns:a="http://schemas.openxmlformats.org/drawingml/2006/main">
             <a:r>
-              <a:t>6:40–7:50. The table shows actual local results: 225 backend tests, 8 frontend tests, 18 browser workflows and eight original HTTP scenarios. Separate public-demo checks verify four documented logins and preserve the private profile. Tests cover denied roles, changed approvals, expiry, duplicate quantities, competing execution, rollback and retries. Fresh installation checks use a source copy. A passing suite is evidence for tested behavior, not complete security assurance. The audit chain can find inconsistent retained events, but a full database owner can rewrite it. The twenty-item security report also covers revocable sessions, one-time offline recovery, private backups, secret scanning and persistent usage caps. The four public demo passwords stay fixed. Independent security and assistive-technology reviews remain separate. Sources: verification-summary.json; test logs; public-demo-install.json; docs/security-self-assessment.md.</a:t>
+              <a:t>6:40–7:50. The table shows actual local results: 251 backend tests, 10 frontend tests, 20 browser workflows and eight original HTTP scenarios. Separate public-demo checks verify four documented logins and preserve the private profile. Tests cover denied roles, changed approvals, expiry, duplicate quantities, competing execution, rollback and retries. Fresh installation checks use a source copy. A passing suite is evidence for tested behavior, not complete security assurance. The audit chain can find inconsistent retained events, but a full database owner can rewrite it. The original twenty-item review and separate nineteen-control checklist cover revocable sessions, private Admin/Finance authenticator MFA, safe browser requests, offline recovery, private backups, secret scans and persistent caps. Public demo accounts stay exempt from MFA and keep the four README passwords. Native database RLS remains deferred; incoming webhooks are not applicable. Independent security and assistive-technology reviews remain separate. Sources: verification-summary.json; test logs; public-demo-install.json; docs/security-self-assessment.md.</a:t>
             </a:r>
           </a:p>
         </p:txBody>
@@ -1057,7 +1057,7 @@
           <p:cNvPr id="3" name="Title">
             <a:extLst xmlns:a="http://schemas.openxmlformats.org/drawingml/2006/main">
               <a:ext uri="{FF2B5EF4-FFF2-40B4-BE49-F238E27FC236}">
-                <a16:creationId xmlns:a16="http://schemas.microsoft.com/office/drawing/2014/main" id="{07B6597B-F768-414F-AFBA-01BB90618666}"/>
+                <a16:creationId xmlns:a16="http://schemas.microsoft.com/office/drawing/2014/main" id="{B216339B-C961-40CB-92F9-243F62A0B340}"/>
               </a:ext>
             </a:extLst>
           </p:cNvPr>
@@ -1286,7 +1286,7 @@
           <p:cNvPr id="2" name="Subtitle">
             <a:extLst xmlns:a="http://schemas.openxmlformats.org/drawingml/2006/main">
               <a:ext uri="{FF2B5EF4-FFF2-40B4-BE49-F238E27FC236}">
-                <a16:creationId xmlns:a16="http://schemas.microsoft.com/office/drawing/2014/main" id="{29CC0BAF-3504-444D-AC22-6557D57CD54E}"/>
+                <a16:creationId xmlns:a16="http://schemas.microsoft.com/office/drawing/2014/main" id="{C14B0913-8659-4C53-B4BC-D9F4019C3AA4}"/>
               </a:ext>
             </a:extLst>
           </p:cNvPr>
@@ -1532,7 +1532,7 @@
           <p:cNvPr id="2" name="Section title">
             <a:extLst xmlns:a="http://schemas.openxmlformats.org/drawingml/2006/main">
               <a:ext uri="{FF2B5EF4-FFF2-40B4-BE49-F238E27FC236}">
-                <a16:creationId xmlns:a16="http://schemas.microsoft.com/office/drawing/2014/main" id="{B81675F4-CEBE-48CE-8DC9-23EF096DABA2}"/>
+                <a16:creationId xmlns:a16="http://schemas.microsoft.com/office/drawing/2014/main" id="{2CC9BE9A-6F86-46C4-A97E-FDE44E330A65}"/>
               </a:ext>
             </a:extLst>
           </p:cNvPr>
@@ -1778,7 +1778,7 @@
           <p:cNvPr id="3" name="Title">
             <a:extLst xmlns:a="http://schemas.openxmlformats.org/drawingml/2006/main">
               <a:ext uri="{FF2B5EF4-FFF2-40B4-BE49-F238E27FC236}">
-                <a16:creationId xmlns:a16="http://schemas.microsoft.com/office/drawing/2014/main" id="{D7376D18-128B-40BF-A62E-AF1B1F31B1AC}"/>
+                <a16:creationId xmlns:a16="http://schemas.microsoft.com/office/drawing/2014/main" id="{074D51A8-5F90-477F-970C-06ABE0C4CCF3}"/>
               </a:ext>
             </a:extLst>
           </p:cNvPr>
@@ -2007,7 +2007,7 @@
           <p:cNvPr id="2" name="Body">
             <a:extLst xmlns:a="http://schemas.openxmlformats.org/drawingml/2006/main">
               <a:ext uri="{FF2B5EF4-FFF2-40B4-BE49-F238E27FC236}">
-                <a16:creationId xmlns:a16="http://schemas.microsoft.com/office/drawing/2014/main" id="{07711F6A-42CD-44A3-BD68-C2507DF1A2C1}"/>
+                <a16:creationId xmlns:a16="http://schemas.microsoft.com/office/drawing/2014/main" id="{574F4C75-4A1E-4F6A-A346-844476A0AA29}"/>
               </a:ext>
             </a:extLst>
           </p:cNvPr>
@@ -2253,7 +2253,7 @@
           <p:cNvPr id="4" name="Title">
             <a:extLst xmlns:a="http://schemas.openxmlformats.org/drawingml/2006/main">
               <a:ext uri="{FF2B5EF4-FFF2-40B4-BE49-F238E27FC236}">
-                <a16:creationId xmlns:a16="http://schemas.microsoft.com/office/drawing/2014/main" id="{FC9D8805-E046-468E-871C-D66BD9EDED59}"/>
+                <a16:creationId xmlns:a16="http://schemas.microsoft.com/office/drawing/2014/main" id="{81B61265-917F-4718-A5A2-E1B73D403ACB}"/>
               </a:ext>
             </a:extLst>
           </p:cNvPr>
@@ -2482,7 +2482,7 @@
           <p:cNvPr id="2" name="Left column">
             <a:extLst xmlns:a="http://schemas.openxmlformats.org/drawingml/2006/main">
               <a:ext uri="{FF2B5EF4-FFF2-40B4-BE49-F238E27FC236}">
-                <a16:creationId xmlns:a16="http://schemas.microsoft.com/office/drawing/2014/main" id="{CC47B1C5-EC85-4A5D-ABAE-95E11FE71E87}"/>
+                <a16:creationId xmlns:a16="http://schemas.microsoft.com/office/drawing/2014/main" id="{6C729CFD-0DDA-4911-AB99-25B3832EADEB}"/>
               </a:ext>
             </a:extLst>
           </p:cNvPr>
@@ -2711,7 +2711,7 @@
           <p:cNvPr id="3" name="Right column">
             <a:extLst xmlns:a="http://schemas.openxmlformats.org/drawingml/2006/main">
               <a:ext uri="{FF2B5EF4-FFF2-40B4-BE49-F238E27FC236}">
-                <a16:creationId xmlns:a16="http://schemas.microsoft.com/office/drawing/2014/main" id="{4AFCF9EC-E536-49AF-9004-0DBD3786AB31}"/>
+                <a16:creationId xmlns:a16="http://schemas.microsoft.com/office/drawing/2014/main" id="{A26A6933-8622-4FD9-8EC0-C71DF8B7AAE0}"/>
               </a:ext>
             </a:extLst>
           </p:cNvPr>
@@ -2957,7 +2957,7 @@
           <p:cNvPr id="3" name="Title">
             <a:extLst xmlns:a="http://schemas.openxmlformats.org/drawingml/2006/main">
               <a:ext uri="{FF2B5EF4-FFF2-40B4-BE49-F238E27FC236}">
-                <a16:creationId xmlns:a16="http://schemas.microsoft.com/office/drawing/2014/main" id="{C4E15FA4-2F8C-4CC6-93F8-C02AFB06D33D}"/>
+                <a16:creationId xmlns:a16="http://schemas.microsoft.com/office/drawing/2014/main" id="{DA75B608-0FFA-4BE6-B5B3-7A9889CF9BAE}"/>
               </a:ext>
             </a:extLst>
           </p:cNvPr>
@@ -3186,7 +3186,7 @@
           <p:cNvPr id="2" name="Left column">
             <a:extLst xmlns:a="http://schemas.openxmlformats.org/drawingml/2006/main">
               <a:ext uri="{FF2B5EF4-FFF2-40B4-BE49-F238E27FC236}">
-                <a16:creationId xmlns:a16="http://schemas.microsoft.com/office/drawing/2014/main" id="{BEF4090E-5BBC-4162-9413-B867689BC44F}"/>
+                <a16:creationId xmlns:a16="http://schemas.microsoft.com/office/drawing/2014/main" id="{CEB2C4A7-1658-4274-991F-50BE74FFA063}"/>
               </a:ext>
             </a:extLst>
           </p:cNvPr>
@@ -3453,12 +3453,12 @@
   </p:cSld>
   <p:clrMap bg1="lt1" tx1="dk1" bg2="lt2" tx2="dk2" accent1="accent1" accent2="accent2" accent3="accent3" accent4="accent4" accent5="accent5" accent6="accent6" hlink="hlink" folHlink="folHlink"/>
   <p:sldLayoutIdLst>
-    <p:sldLayoutId xmlns:r="http://schemas.openxmlformats.org/officeDocument/2006/relationships" id="2147483649" r:id="Rf89afeb4da27496b"/>
-    <p:sldLayoutId xmlns:r="http://schemas.openxmlformats.org/officeDocument/2006/relationships" id="2147483650" r:id="Rbf8c1552256c493b"/>
-    <p:sldLayoutId xmlns:r="http://schemas.openxmlformats.org/officeDocument/2006/relationships" id="2147483651" r:id="R613cca14d2654c44"/>
-    <p:sldLayoutId xmlns:r="http://schemas.openxmlformats.org/officeDocument/2006/relationships" id="2147483652" r:id="Rbc441527c5e84e09"/>
-    <p:sldLayoutId xmlns:r="http://schemas.openxmlformats.org/officeDocument/2006/relationships" id="2147483653" r:id="R9efc7394896d4c83"/>
-    <p:sldLayoutId xmlns:r="http://schemas.openxmlformats.org/officeDocument/2006/relationships" id="2147483654" r:id="Rdfe1ce67febc4d74"/>
+    <p:sldLayoutId xmlns:r="http://schemas.openxmlformats.org/officeDocument/2006/relationships" id="2147483649" r:id="R190c93d25d8040ff"/>
+    <p:sldLayoutId xmlns:r="http://schemas.openxmlformats.org/officeDocument/2006/relationships" id="2147483650" r:id="R00d795df04a1463f"/>
+    <p:sldLayoutId xmlns:r="http://schemas.openxmlformats.org/officeDocument/2006/relationships" id="2147483651" r:id="R9133309031a74530"/>
+    <p:sldLayoutId xmlns:r="http://schemas.openxmlformats.org/officeDocument/2006/relationships" id="2147483652" r:id="Re65702823d634fc4"/>
+    <p:sldLayoutId xmlns:r="http://schemas.openxmlformats.org/officeDocument/2006/relationships" id="2147483653" r:id="R3684ed9d87c446cf"/>
+    <p:sldLayoutId xmlns:r="http://schemas.openxmlformats.org/officeDocument/2006/relationships" id="2147483654" r:id="R411170bad5ec43c2"/>
   </p:sldLayoutIdLst>
   <p:txStyles>
     <p:titleStyle>
@@ -4009,7 +4009,7 @@
           <p:cNvPr id="7" name="">
             <a:extLst xmlns:a="http://schemas.openxmlformats.org/drawingml/2006/main">
               <a:ext uri="{FF2B5EF4-FFF2-40B4-BE49-F238E27FC236}">
-                <a16:creationId xmlns:a16="http://schemas.microsoft.com/office/drawing/2014/main" id="{CB62F4D2-4FC9-4C5C-9B52-5DCF82D648FF}"/>
+                <a16:creationId xmlns:a16="http://schemas.microsoft.com/office/drawing/2014/main" id="{C843E7EA-A5ED-42A9-9602-3E8EE41C699E}"/>
               </a:ext>
             </a:extLst>
           </p:cNvPr>
@@ -4165,7 +4165,7 @@
           <p:cNvPr id="2" name="">
             <a:extLst xmlns:a="http://schemas.openxmlformats.org/drawingml/2006/main">
               <a:ext uri="{FF2B5EF4-FFF2-40B4-BE49-F238E27FC236}">
-                <a16:creationId xmlns:a16="http://schemas.microsoft.com/office/drawing/2014/main" id="{A34AC906-1888-4E56-9FE4-20E99BD0E217}"/>
+                <a16:creationId xmlns:a16="http://schemas.microsoft.com/office/drawing/2014/main" id="{E2096451-F36C-4D02-913A-26FA359AD50C}"/>
               </a:ext>
             </a:extLst>
           </p:cNvPr>
@@ -4321,7 +4321,7 @@
           <p:cNvPr id="3" name="">
             <a:extLst xmlns:a="http://schemas.openxmlformats.org/drawingml/2006/main">
               <a:ext uri="{FF2B5EF4-FFF2-40B4-BE49-F238E27FC236}">
-                <a16:creationId xmlns:a16="http://schemas.microsoft.com/office/drawing/2014/main" id="{D88BFD13-C428-4335-B3B5-F574EBD32B35}"/>
+                <a16:creationId xmlns:a16="http://schemas.microsoft.com/office/drawing/2014/main" id="{E277D02E-9789-4A36-AEFC-B2C65AC77596}"/>
               </a:ext>
             </a:extLst>
           </p:cNvPr>
@@ -4477,7 +4477,7 @@
           <p:cNvPr id="4" name="">
             <a:extLst xmlns:a="http://schemas.openxmlformats.org/drawingml/2006/main">
               <a:ext uri="{FF2B5EF4-FFF2-40B4-BE49-F238E27FC236}">
-                <a16:creationId xmlns:a16="http://schemas.microsoft.com/office/drawing/2014/main" id="{9B038615-D87E-4272-8961-0790C8CF1568}"/>
+                <a16:creationId xmlns:a16="http://schemas.microsoft.com/office/drawing/2014/main" id="{A584CB2F-873E-4C43-8DAD-F15E51D3F219}"/>
               </a:ext>
             </a:extLst>
           </p:cNvPr>
@@ -4656,7 +4656,7 @@
           <p:cNvPr id="5" name="">
             <a:extLst xmlns:a="http://schemas.openxmlformats.org/drawingml/2006/main">
               <a:ext uri="{FF2B5EF4-FFF2-40B4-BE49-F238E27FC236}">
-                <a16:creationId xmlns:a16="http://schemas.microsoft.com/office/drawing/2014/main" id="{E05CA722-D6A9-4A41-8673-F1CE76928D5B}"/>
+                <a16:creationId xmlns:a16="http://schemas.microsoft.com/office/drawing/2014/main" id="{53CFAAF9-7AD9-45BA-AAFD-8BB329FE96F1}"/>
               </a:ext>
             </a:extLst>
           </p:cNvPr>
@@ -4812,7 +4812,7 @@
           <p:cNvPr id="6" name="">
             <a:extLst xmlns:a="http://schemas.openxmlformats.org/drawingml/2006/main">
               <a:ext uri="{FF2B5EF4-FFF2-40B4-BE49-F238E27FC236}">
-                <a16:creationId xmlns:a16="http://schemas.microsoft.com/office/drawing/2014/main" id="{C11A83DE-F979-456E-966D-613F3C4519BF}"/>
+                <a16:creationId xmlns:a16="http://schemas.microsoft.com/office/drawing/2014/main" id="{7D72008B-C852-44E3-971C-533E6C824FFC}"/>
               </a:ext>
             </a:extLst>
           </p:cNvPr>
@@ -4966,7 +4966,7 @@
     </p:spTree>
     <p:extLst>
       <p:ext uri="{BB962C8B-B14F-4D97-AF65-F5344CB8AC3E}">
-        <p14:creationId xmlns:p14="http://schemas.microsoft.com/office/powerpoint/2010/main" val="354845499"/>
+        <p14:creationId xmlns:p14="http://schemas.microsoft.com/office/powerpoint/2010/main" val="1264427178"/>
       </p:ext>
     </p:extLst>
   </p:cSld>
@@ -4997,7 +4997,7 @@
           <p:cNvPr id="7" name="">
             <a:extLst xmlns:a="http://schemas.openxmlformats.org/drawingml/2006/main">
               <a:ext uri="{FF2B5EF4-FFF2-40B4-BE49-F238E27FC236}">
-                <a16:creationId xmlns:a16="http://schemas.microsoft.com/office/drawing/2014/main" id="{A697521C-C9EA-438B-AC2E-3192A394DE73}"/>
+                <a16:creationId xmlns:a16="http://schemas.microsoft.com/office/drawing/2014/main" id="{538F26E6-4F17-499F-86AE-938B77A80F87}"/>
               </a:ext>
             </a:extLst>
           </p:cNvPr>
@@ -5153,7 +5153,7 @@
           <p:cNvPr id="2" name="">
             <a:extLst xmlns:a="http://schemas.openxmlformats.org/drawingml/2006/main">
               <a:ext uri="{FF2B5EF4-FFF2-40B4-BE49-F238E27FC236}">
-                <a16:creationId xmlns:a16="http://schemas.microsoft.com/office/drawing/2014/main" id="{81FB507C-C4FF-4A8E-987D-B85F7B6803E3}"/>
+                <a16:creationId xmlns:a16="http://schemas.microsoft.com/office/drawing/2014/main" id="{D78421CC-AAF2-4689-B398-C013A9793D19}"/>
               </a:ext>
             </a:extLst>
           </p:cNvPr>
@@ -5309,7 +5309,7 @@
           <p:cNvPr id="3" name="">
             <a:extLst xmlns:a="http://schemas.openxmlformats.org/drawingml/2006/main">
               <a:ext uri="{FF2B5EF4-FFF2-40B4-BE49-F238E27FC236}">
-                <a16:creationId xmlns:a16="http://schemas.microsoft.com/office/drawing/2014/main" id="{9D137614-9882-4481-AF8F-40F85F6EF13C}"/>
+                <a16:creationId xmlns:a16="http://schemas.microsoft.com/office/drawing/2014/main" id="{9F648A61-8C54-42F0-870D-E90502B69A3A}"/>
               </a:ext>
             </a:extLst>
           </p:cNvPr>
@@ -5465,7 +5465,7 @@
           <p:cNvPr id="4" name="">
             <a:extLst xmlns:a="http://schemas.openxmlformats.org/drawingml/2006/main">
               <a:ext uri="{FF2B5EF4-FFF2-40B4-BE49-F238E27FC236}">
-                <a16:creationId xmlns:a16="http://schemas.microsoft.com/office/drawing/2014/main" id="{022CFBBF-1989-4342-9DA5-192B6AEBB2A1}"/>
+                <a16:creationId xmlns:a16="http://schemas.microsoft.com/office/drawing/2014/main" id="{D1000DB8-5FD3-482F-8744-D2319AF61AC1}"/>
               </a:ext>
             </a:extLst>
           </p:cNvPr>
@@ -5621,7 +5621,7 @@
           <p:cNvPr id="5" name="">
             <a:extLst xmlns:a="http://schemas.openxmlformats.org/drawingml/2006/main">
               <a:ext uri="{FF2B5EF4-FFF2-40B4-BE49-F238E27FC236}">
-                <a16:creationId xmlns:a16="http://schemas.microsoft.com/office/drawing/2014/main" id="{97353943-85AC-4E08-B7AC-5BED57FD7E9F}"/>
+                <a16:creationId xmlns:a16="http://schemas.microsoft.com/office/drawing/2014/main" id="{B150AE04-B448-4F05-96B7-E6017CC0B19B}"/>
               </a:ext>
             </a:extLst>
           </p:cNvPr>
@@ -5833,7 +5833,7 @@
           <p:cNvPr id="6" name="">
             <a:extLst xmlns:a="http://schemas.openxmlformats.org/drawingml/2006/main">
               <a:ext uri="{FF2B5EF4-FFF2-40B4-BE49-F238E27FC236}">
-                <a16:creationId xmlns:a16="http://schemas.microsoft.com/office/drawing/2014/main" id="{BCDF6C8F-1796-4669-9BA1-10F42D8870C0}"/>
+                <a16:creationId xmlns:a16="http://schemas.microsoft.com/office/drawing/2014/main" id="{B6EA5C87-0EF5-4745-B981-507BFF1A3557}"/>
               </a:ext>
             </a:extLst>
           </p:cNvPr>
@@ -5843,7 +5843,7 @@
           <p:nvPr/>
         </p:nvPicPr>
         <p:blipFill>
-          <a:blip xmlns:r="http://schemas.openxmlformats.org/officeDocument/2006/relationships" xmlns:a="http://schemas.openxmlformats.org/drawingml/2006/main" r:embed="R093806b11f0044f2"/>
+          <a:blip xmlns:r="http://schemas.openxmlformats.org/officeDocument/2006/relationships" xmlns:a="http://schemas.openxmlformats.org/drawingml/2006/main" r:embed="R3398cec636364f5c"/>
           <a:stretch xmlns:a="http://schemas.openxmlformats.org/drawingml/2006/main"/>
         </p:blipFill>
         <p:spPr>
@@ -5859,7 +5859,7 @@
     </p:spTree>
     <p:extLst>
       <p:ext uri="{BB962C8B-B14F-4D97-AF65-F5344CB8AC3E}">
-        <p14:creationId xmlns:p14="http://schemas.microsoft.com/office/powerpoint/2010/main" val="1620277623"/>
+        <p14:creationId xmlns:p14="http://schemas.microsoft.com/office/powerpoint/2010/main" val="360972637"/>
       </p:ext>
     </p:extLst>
   </p:cSld>
@@ -5890,7 +5890,7 @@
           <p:cNvPr id="9" name="">
             <a:extLst xmlns:a="http://schemas.openxmlformats.org/drawingml/2006/main">
               <a:ext uri="{FF2B5EF4-FFF2-40B4-BE49-F238E27FC236}">
-                <a16:creationId xmlns:a16="http://schemas.microsoft.com/office/drawing/2014/main" id="{D07F87A4-0C7B-48D2-AD8A-858927E6A715}"/>
+                <a16:creationId xmlns:a16="http://schemas.microsoft.com/office/drawing/2014/main" id="{6208AF6D-6149-467E-9B6F-0245391C463F}"/>
               </a:ext>
             </a:extLst>
           </p:cNvPr>
@@ -6046,7 +6046,7 @@
           <p:cNvPr id="2" name="">
             <a:extLst xmlns:a="http://schemas.openxmlformats.org/drawingml/2006/main">
               <a:ext uri="{FF2B5EF4-FFF2-40B4-BE49-F238E27FC236}">
-                <a16:creationId xmlns:a16="http://schemas.microsoft.com/office/drawing/2014/main" id="{8F9EFBD8-3CD2-41EA-889D-2444FA9F15A1}"/>
+                <a16:creationId xmlns:a16="http://schemas.microsoft.com/office/drawing/2014/main" id="{3ACC393D-09D5-4F14-8FBC-489B9A3645E5}"/>
               </a:ext>
             </a:extLst>
           </p:cNvPr>
@@ -6202,7 +6202,7 @@
           <p:cNvPr id="3" name="">
             <a:extLst xmlns:a="http://schemas.openxmlformats.org/drawingml/2006/main">
               <a:ext uri="{FF2B5EF4-FFF2-40B4-BE49-F238E27FC236}">
-                <a16:creationId xmlns:a16="http://schemas.microsoft.com/office/drawing/2014/main" id="{3D75B306-10A3-4C30-B237-F4407B5F9F18}"/>
+                <a16:creationId xmlns:a16="http://schemas.microsoft.com/office/drawing/2014/main" id="{953C3492-9843-4414-9323-B1A52FEB7362}"/>
               </a:ext>
             </a:extLst>
           </p:cNvPr>
@@ -6358,7 +6358,7 @@
           <p:cNvPr id="4" name="">
             <a:extLst xmlns:a="http://schemas.openxmlformats.org/drawingml/2006/main">
               <a:ext uri="{FF2B5EF4-FFF2-40B4-BE49-F238E27FC236}">
-                <a16:creationId xmlns:a16="http://schemas.microsoft.com/office/drawing/2014/main" id="{5E24A900-8D6A-42D4-A035-444B5FA4FB71}"/>
+                <a16:creationId xmlns:a16="http://schemas.microsoft.com/office/drawing/2014/main" id="{341FA53B-196F-4DF6-938D-7EB50D8E7101}"/>
               </a:ext>
             </a:extLst>
           </p:cNvPr>
@@ -6537,7 +6537,7 @@
           <p:cNvPr id="5" name="">
             <a:extLst xmlns:a="http://schemas.openxmlformats.org/drawingml/2006/main">
               <a:ext uri="{FF2B5EF4-FFF2-40B4-BE49-F238E27FC236}">
-                <a16:creationId xmlns:a16="http://schemas.microsoft.com/office/drawing/2014/main" id="{3062FFC6-A444-4DB5-9EE7-48F199645BA4}"/>
+                <a16:creationId xmlns:a16="http://schemas.microsoft.com/office/drawing/2014/main" id="{B3BE656A-80C5-4F94-A6F0-2142D68C596A}"/>
               </a:ext>
             </a:extLst>
           </p:cNvPr>
@@ -6693,7 +6693,7 @@
           <p:cNvPr id="6" name="">
             <a:extLst xmlns:a="http://schemas.openxmlformats.org/drawingml/2006/main">
               <a:ext uri="{FF2B5EF4-FFF2-40B4-BE49-F238E27FC236}">
-                <a16:creationId xmlns:a16="http://schemas.microsoft.com/office/drawing/2014/main" id="{D2EDC39D-D29F-4D5F-8CF2-CBE6A5D771D6}"/>
+                <a16:creationId xmlns:a16="http://schemas.microsoft.com/office/drawing/2014/main" id="{70A5927D-4F4C-4384-A5F8-51B79C9E62AE}"/>
               </a:ext>
             </a:extLst>
           </p:cNvPr>
@@ -6849,7 +6849,7 @@
           <p:cNvPr id="7" name="">
             <a:extLst xmlns:a="http://schemas.openxmlformats.org/drawingml/2006/main">
               <a:ext uri="{FF2B5EF4-FFF2-40B4-BE49-F238E27FC236}">
-                <a16:creationId xmlns:a16="http://schemas.microsoft.com/office/drawing/2014/main" id="{370B16E7-02C4-47CB-9B46-2E8D8A6B0273}"/>
+                <a16:creationId xmlns:a16="http://schemas.microsoft.com/office/drawing/2014/main" id="{EE06FC5D-6A00-494B-9A67-72E96CBB371E}"/>
               </a:ext>
             </a:extLst>
           </p:cNvPr>
@@ -7028,7 +7028,7 @@
           <p:cNvPr id="8" name="">
             <a:extLst xmlns:a="http://schemas.openxmlformats.org/drawingml/2006/main">
               <a:ext uri="{FF2B5EF4-FFF2-40B4-BE49-F238E27FC236}">
-                <a16:creationId xmlns:a16="http://schemas.microsoft.com/office/drawing/2014/main" id="{4743B366-D57D-4211-9FFC-E78014DE120C}"/>
+                <a16:creationId xmlns:a16="http://schemas.microsoft.com/office/drawing/2014/main" id="{2B47652E-C9EC-4D49-A435-D9C9309159CA}"/>
               </a:ext>
             </a:extLst>
           </p:cNvPr>
@@ -7038,7 +7038,7 @@
           <p:nvPr/>
         </p:nvPicPr>
         <p:blipFill>
-          <a:blip xmlns:r="http://schemas.openxmlformats.org/officeDocument/2006/relationships" xmlns:a="http://schemas.openxmlformats.org/drawingml/2006/main" r:embed="R61bc9d987a064a4c"/>
+          <a:blip xmlns:r="http://schemas.openxmlformats.org/officeDocument/2006/relationships" xmlns:a="http://schemas.openxmlformats.org/drawingml/2006/main" r:embed="R61676f9b1aa54817"/>
           <a:stretch xmlns:a="http://schemas.openxmlformats.org/drawingml/2006/main"/>
         </p:blipFill>
         <p:spPr>
@@ -7054,7 +7054,7 @@
     </p:spTree>
     <p:extLst>
       <p:ext uri="{BB962C8B-B14F-4D97-AF65-F5344CB8AC3E}">
-        <p14:creationId xmlns:p14="http://schemas.microsoft.com/office/powerpoint/2010/main" val="1740789796"/>
+        <p14:creationId xmlns:p14="http://schemas.microsoft.com/office/powerpoint/2010/main" val="1123044919"/>
       </p:ext>
     </p:extLst>
   </p:cSld>
@@ -7085,7 +7085,7 @@
           <p:cNvPr id="8" name="">
             <a:extLst xmlns:a="http://schemas.openxmlformats.org/drawingml/2006/main">
               <a:ext uri="{FF2B5EF4-FFF2-40B4-BE49-F238E27FC236}">
-                <a16:creationId xmlns:a16="http://schemas.microsoft.com/office/drawing/2014/main" id="{51A9449F-38DE-4623-9706-B62ABE9026F9}"/>
+                <a16:creationId xmlns:a16="http://schemas.microsoft.com/office/drawing/2014/main" id="{233BCA4C-264A-4D31-9889-DE1B64AC4BBC}"/>
               </a:ext>
             </a:extLst>
           </p:cNvPr>
@@ -7241,7 +7241,7 @@
           <p:cNvPr id="2" name="">
             <a:extLst xmlns:a="http://schemas.openxmlformats.org/drawingml/2006/main">
               <a:ext uri="{FF2B5EF4-FFF2-40B4-BE49-F238E27FC236}">
-                <a16:creationId xmlns:a16="http://schemas.microsoft.com/office/drawing/2014/main" id="{9EBD285D-2A73-42CB-BE3A-03F6B2C9AB13}"/>
+                <a16:creationId xmlns:a16="http://schemas.microsoft.com/office/drawing/2014/main" id="{AAB960BB-F2A1-4E9C-874F-D77E6C04AD8E}"/>
               </a:ext>
             </a:extLst>
           </p:cNvPr>
@@ -7397,7 +7397,7 @@
           <p:cNvPr id="3" name="">
             <a:extLst xmlns:a="http://schemas.openxmlformats.org/drawingml/2006/main">
               <a:ext uri="{FF2B5EF4-FFF2-40B4-BE49-F238E27FC236}">
-                <a16:creationId xmlns:a16="http://schemas.microsoft.com/office/drawing/2014/main" id="{B417E273-4CA2-4F49-89B8-8350DBE92EE4}"/>
+                <a16:creationId xmlns:a16="http://schemas.microsoft.com/office/drawing/2014/main" id="{8013E62F-C98B-441D-A377-31BF1CB6FD75}"/>
               </a:ext>
             </a:extLst>
           </p:cNvPr>
@@ -7553,7 +7553,7 @@
           <p:cNvPr id="4" name="">
             <a:extLst xmlns:a="http://schemas.openxmlformats.org/drawingml/2006/main">
               <a:ext uri="{FF2B5EF4-FFF2-40B4-BE49-F238E27FC236}">
-                <a16:creationId xmlns:a16="http://schemas.microsoft.com/office/drawing/2014/main" id="{A07DAFC7-D8C0-4AE8-8A65-41A3D20AC037}"/>
+                <a16:creationId xmlns:a16="http://schemas.microsoft.com/office/drawing/2014/main" id="{D2BF6AEA-94EF-4E9A-AC52-ED204022AC35}"/>
               </a:ext>
             </a:extLst>
           </p:cNvPr>
@@ -7709,7 +7709,7 @@
           <p:cNvPr id="5" name="">
             <a:extLst xmlns:a="http://schemas.openxmlformats.org/drawingml/2006/main">
               <a:ext uri="{FF2B5EF4-FFF2-40B4-BE49-F238E27FC236}">
-                <a16:creationId xmlns:a16="http://schemas.microsoft.com/office/drawing/2014/main" id="{A9B5FD82-2851-4349-8473-3D8A05A927A6}"/>
+                <a16:creationId xmlns:a16="http://schemas.microsoft.com/office/drawing/2014/main" id="{080E5B54-FE06-4EC8-AD2B-58771BBD9DA9}"/>
               </a:ext>
             </a:extLst>
           </p:cNvPr>
@@ -7865,7 +7865,7 @@
           <p:cNvPr id="6" name="">
             <a:extLst xmlns:a="http://schemas.openxmlformats.org/drawingml/2006/main">
               <a:ext uri="{FF2B5EF4-FFF2-40B4-BE49-F238E27FC236}">
-                <a16:creationId xmlns:a16="http://schemas.microsoft.com/office/drawing/2014/main" id="{BB01BE55-C089-4BBF-9BC3-49601919B0B4}"/>
+                <a16:creationId xmlns:a16="http://schemas.microsoft.com/office/drawing/2014/main" id="{9278E0A8-12A6-4935-9BE5-A559F03730F4}"/>
               </a:ext>
             </a:extLst>
           </p:cNvPr>
@@ -8021,7 +8021,7 @@
           <p:cNvPr id="7" name="">
             <a:extLst xmlns:a="http://schemas.openxmlformats.org/drawingml/2006/main">
               <a:ext uri="{FF2B5EF4-FFF2-40B4-BE49-F238E27FC236}">
-                <a16:creationId xmlns:a16="http://schemas.microsoft.com/office/drawing/2014/main" id="{6E6C3D19-D010-47CE-BBB0-48E6E1B01BDC}"/>
+                <a16:creationId xmlns:a16="http://schemas.microsoft.com/office/drawing/2014/main" id="{2CF233F8-0CD3-4CD6-9340-23F94CA35A3E}"/>
               </a:ext>
             </a:extLst>
           </p:cNvPr>
@@ -8175,7 +8175,7 @@
     </p:spTree>
     <p:extLst>
       <p:ext uri="{BB962C8B-B14F-4D97-AF65-F5344CB8AC3E}">
-        <p14:creationId xmlns:p14="http://schemas.microsoft.com/office/powerpoint/2010/main" val="154745372"/>
+        <p14:creationId xmlns:p14="http://schemas.microsoft.com/office/powerpoint/2010/main" val="829389259"/>
       </p:ext>
     </p:extLst>
   </p:cSld>
@@ -8206,7 +8206,7 @@
           <p:cNvPr id="17" name="">
             <a:extLst xmlns:a="http://schemas.openxmlformats.org/drawingml/2006/main">
               <a:ext uri="{FF2B5EF4-FFF2-40B4-BE49-F238E27FC236}">
-                <a16:creationId xmlns:a16="http://schemas.microsoft.com/office/drawing/2014/main" id="{6E9092D2-EC37-4DB4-AACA-0F3FC58F37D6}"/>
+                <a16:creationId xmlns:a16="http://schemas.microsoft.com/office/drawing/2014/main" id="{4F58F822-8800-4906-8E08-58EBC5A5D971}"/>
               </a:ext>
             </a:extLst>
           </p:cNvPr>
@@ -8362,7 +8362,7 @@
           <p:cNvPr id="2" name="">
             <a:extLst xmlns:a="http://schemas.openxmlformats.org/drawingml/2006/main">
               <a:ext uri="{FF2B5EF4-FFF2-40B4-BE49-F238E27FC236}">
-                <a16:creationId xmlns:a16="http://schemas.microsoft.com/office/drawing/2014/main" id="{25F99DB0-63B2-4A64-B9DC-7314AEFB83E4}"/>
+                <a16:creationId xmlns:a16="http://schemas.microsoft.com/office/drawing/2014/main" id="{CB5AE934-3171-4B22-9514-FA71F2787F74}"/>
               </a:ext>
             </a:extLst>
           </p:cNvPr>
@@ -8518,7 +8518,7 @@
           <p:cNvPr id="3" name="">
             <a:extLst xmlns:a="http://schemas.openxmlformats.org/drawingml/2006/main">
               <a:ext uri="{FF2B5EF4-FFF2-40B4-BE49-F238E27FC236}">
-                <a16:creationId xmlns:a16="http://schemas.microsoft.com/office/drawing/2014/main" id="{E1DE3114-8B22-408B-BACE-248AFCCB31B4}"/>
+                <a16:creationId xmlns:a16="http://schemas.microsoft.com/office/drawing/2014/main" id="{C2A5CB4A-6D61-4671-9C13-6F5D38B7B422}"/>
               </a:ext>
             </a:extLst>
           </p:cNvPr>
@@ -8674,7 +8674,7 @@
           <p:cNvPr id="4" name="">
             <a:extLst xmlns:a="http://schemas.openxmlformats.org/drawingml/2006/main">
               <a:ext uri="{FF2B5EF4-FFF2-40B4-BE49-F238E27FC236}">
-                <a16:creationId xmlns:a16="http://schemas.microsoft.com/office/drawing/2014/main" id="{412C6688-30D6-4875-A433-C2E836D22D4D}"/>
+                <a16:creationId xmlns:a16="http://schemas.microsoft.com/office/drawing/2014/main" id="{62CB6E04-7318-4D53-B71F-EC1337D2BE02}"/>
               </a:ext>
             </a:extLst>
           </p:cNvPr>
@@ -8857,7 +8857,7 @@
           <p:cNvPr id="5" name="">
             <a:extLst xmlns:a="http://schemas.openxmlformats.org/drawingml/2006/main">
               <a:ext uri="{FF2B5EF4-FFF2-40B4-BE49-F238E27FC236}">
-                <a16:creationId xmlns:a16="http://schemas.microsoft.com/office/drawing/2014/main" id="{60DC3D38-5D5D-4B1D-A686-ECEC4E8B4ABC}"/>
+                <a16:creationId xmlns:a16="http://schemas.microsoft.com/office/drawing/2014/main" id="{5D655BE2-55D7-4832-A64E-B0D0AD5398E6}"/>
               </a:ext>
             </a:extLst>
           </p:cNvPr>
@@ -9040,7 +9040,7 @@
           <p:cNvPr id="6" name="">
             <a:extLst xmlns:a="http://schemas.openxmlformats.org/drawingml/2006/main">
               <a:ext uri="{FF2B5EF4-FFF2-40B4-BE49-F238E27FC236}">
-                <a16:creationId xmlns:a16="http://schemas.microsoft.com/office/drawing/2014/main" id="{26EEDCEC-3B0B-41BC-874F-19DF05FF7924}"/>
+                <a16:creationId xmlns:a16="http://schemas.microsoft.com/office/drawing/2014/main" id="{9B9331DD-4FD3-4702-A9F7-9D271D02DD69}"/>
               </a:ext>
             </a:extLst>
           </p:cNvPr>
@@ -9223,7 +9223,7 @@
           <p:cNvPr id="7" name="">
             <a:extLst xmlns:a="http://schemas.openxmlformats.org/drawingml/2006/main">
               <a:ext uri="{FF2B5EF4-FFF2-40B4-BE49-F238E27FC236}">
-                <a16:creationId xmlns:a16="http://schemas.microsoft.com/office/drawing/2014/main" id="{A6393B67-FE2A-4E9E-A283-A4B47476C3B0}"/>
+                <a16:creationId xmlns:a16="http://schemas.microsoft.com/office/drawing/2014/main" id="{BCAB5794-8544-4223-A573-0BCDE46AF471}"/>
               </a:ext>
             </a:extLst>
           </p:cNvPr>
@@ -9379,7 +9379,7 @@
           <p:cNvPr id="8" name="">
             <a:extLst xmlns:a="http://schemas.openxmlformats.org/drawingml/2006/main">
               <a:ext uri="{FF2B5EF4-FFF2-40B4-BE49-F238E27FC236}">
-                <a16:creationId xmlns:a16="http://schemas.microsoft.com/office/drawing/2014/main" id="{E704C2AE-CDEC-4BEF-955F-27FE4F67F8BC}"/>
+                <a16:creationId xmlns:a16="http://schemas.microsoft.com/office/drawing/2014/main" id="{0648F257-9780-4D9A-9AA5-B6C04E468AAA}"/>
               </a:ext>
             </a:extLst>
           </p:cNvPr>
@@ -9535,7 +9535,7 @@
           <p:cNvPr id="9" name="">
             <a:extLst xmlns:a="http://schemas.openxmlformats.org/drawingml/2006/main">
               <a:ext uri="{FF2B5EF4-FFF2-40B4-BE49-F238E27FC236}">
-                <a16:creationId xmlns:a16="http://schemas.microsoft.com/office/drawing/2014/main" id="{C59E75BC-1CA1-4427-83AE-39B4DFD1E280}"/>
+                <a16:creationId xmlns:a16="http://schemas.microsoft.com/office/drawing/2014/main" id="{1DC3D53A-3D05-43A6-BCE1-DF8417F44D02}"/>
               </a:ext>
             </a:extLst>
           </p:cNvPr>
@@ -9718,7 +9718,7 @@
           <p:cNvPr id="10" name="">
             <a:extLst xmlns:a="http://schemas.openxmlformats.org/drawingml/2006/main">
               <a:ext uri="{FF2B5EF4-FFF2-40B4-BE49-F238E27FC236}">
-                <a16:creationId xmlns:a16="http://schemas.microsoft.com/office/drawing/2014/main" id="{799CBEEC-5D6C-4864-83C4-EF2244E55EBA}"/>
+                <a16:creationId xmlns:a16="http://schemas.microsoft.com/office/drawing/2014/main" id="{E2DC2F15-6E9E-4A6D-A409-90AA0F4AB9B7}"/>
               </a:ext>
             </a:extLst>
           </p:cNvPr>
@@ -9901,7 +9901,7 @@
           <p:cNvPr id="11" name="">
             <a:extLst xmlns:a="http://schemas.openxmlformats.org/drawingml/2006/main">
               <a:ext uri="{FF2B5EF4-FFF2-40B4-BE49-F238E27FC236}">
-                <a16:creationId xmlns:a16="http://schemas.microsoft.com/office/drawing/2014/main" id="{E250AA86-EC38-47C2-B5B9-51390D2FEF5F}"/>
+                <a16:creationId xmlns:a16="http://schemas.microsoft.com/office/drawing/2014/main" id="{20A5B96D-F615-42FA-BBB5-021EBCF08088}"/>
               </a:ext>
             </a:extLst>
           </p:cNvPr>
@@ -10084,7 +10084,7 @@
           <p:cNvPr id="12" name="">
             <a:extLst xmlns:a="http://schemas.openxmlformats.org/drawingml/2006/main">
               <a:ext uri="{FF2B5EF4-FFF2-40B4-BE49-F238E27FC236}">
-                <a16:creationId xmlns:a16="http://schemas.microsoft.com/office/drawing/2014/main" id="{C680D17C-BD68-4FA1-8E85-6E00043161A9}"/>
+                <a16:creationId xmlns:a16="http://schemas.microsoft.com/office/drawing/2014/main" id="{2407D7CB-A42E-487D-8B0C-43635D20E872}"/>
               </a:ext>
             </a:extLst>
           </p:cNvPr>
@@ -10240,7 +10240,7 @@
           <p:cNvPr id="13" name="">
             <a:extLst xmlns:a="http://schemas.openxmlformats.org/drawingml/2006/main">
               <a:ext uri="{FF2B5EF4-FFF2-40B4-BE49-F238E27FC236}">
-                <a16:creationId xmlns:a16="http://schemas.microsoft.com/office/drawing/2014/main" id="{9686E464-8E05-48EB-9AEB-27A6C7F7AE8B}"/>
+                <a16:creationId xmlns:a16="http://schemas.microsoft.com/office/drawing/2014/main" id="{9B9040AC-2900-4BE3-8178-6917FD784A06}"/>
               </a:ext>
             </a:extLst>
           </p:cNvPr>
@@ -10396,7 +10396,7 @@
           <p:cNvPr id="14" name="">
             <a:extLst xmlns:a="http://schemas.openxmlformats.org/drawingml/2006/main">
               <a:ext uri="{FF2B5EF4-FFF2-40B4-BE49-F238E27FC236}">
-                <a16:creationId xmlns:a16="http://schemas.microsoft.com/office/drawing/2014/main" id="{3B73B9E4-5DAD-45E3-84FC-3000802FCFA5}"/>
+                <a16:creationId xmlns:a16="http://schemas.microsoft.com/office/drawing/2014/main" id="{3CF435AC-7CF6-4DBD-9BE3-99F37559ED5D}"/>
               </a:ext>
             </a:extLst>
           </p:cNvPr>
@@ -10552,7 +10552,7 @@
           <p:cNvPr id="15" name="">
             <a:extLst xmlns:a="http://schemas.openxmlformats.org/drawingml/2006/main">
               <a:ext uri="{FF2B5EF4-FFF2-40B4-BE49-F238E27FC236}">
-                <a16:creationId xmlns:a16="http://schemas.microsoft.com/office/drawing/2014/main" id="{5F824FF8-D965-4D3B-A944-CA8921F5951C}"/>
+                <a16:creationId xmlns:a16="http://schemas.microsoft.com/office/drawing/2014/main" id="{2555E6B5-CBCC-416D-8DCC-E48440CAE480}"/>
               </a:ext>
             </a:extLst>
           </p:cNvPr>
@@ -10708,7 +10708,7 @@
           <p:cNvPr id="16" name="">
             <a:extLst xmlns:a="http://schemas.openxmlformats.org/drawingml/2006/main">
               <a:ext uri="{FF2B5EF4-FFF2-40B4-BE49-F238E27FC236}">
-                <a16:creationId xmlns:a16="http://schemas.microsoft.com/office/drawing/2014/main" id="{738ABE9D-9C37-4EEC-8E15-667FB2226956}"/>
+                <a16:creationId xmlns:a16="http://schemas.microsoft.com/office/drawing/2014/main" id="{72A9C9B1-F95B-4B0E-A269-73984FB06B19}"/>
               </a:ext>
             </a:extLst>
           </p:cNvPr>
@@ -10862,7 +10862,7 @@
     </p:spTree>
     <p:extLst>
       <p:ext uri="{BB962C8B-B14F-4D97-AF65-F5344CB8AC3E}">
-        <p14:creationId xmlns:p14="http://schemas.microsoft.com/office/powerpoint/2010/main" val="1039246245"/>
+        <p14:creationId xmlns:p14="http://schemas.microsoft.com/office/powerpoint/2010/main" val="1370698051"/>
       </p:ext>
     </p:extLst>
   </p:cSld>
@@ -10893,7 +10893,7 @@
           <p:cNvPr id="8" name="">
             <a:extLst xmlns:a="http://schemas.openxmlformats.org/drawingml/2006/main">
               <a:ext uri="{FF2B5EF4-FFF2-40B4-BE49-F238E27FC236}">
-                <a16:creationId xmlns:a16="http://schemas.microsoft.com/office/drawing/2014/main" id="{53CE4220-896E-4785-9C26-49F01393DE0E}"/>
+                <a16:creationId xmlns:a16="http://schemas.microsoft.com/office/drawing/2014/main" id="{4F1F8E5E-AC57-4E7B-8D36-067A04DCA917}"/>
               </a:ext>
             </a:extLst>
           </p:cNvPr>
@@ -11049,7 +11049,7 @@
           <p:cNvPr id="2" name="">
             <a:extLst xmlns:a="http://schemas.openxmlformats.org/drawingml/2006/main">
               <a:ext uri="{FF2B5EF4-FFF2-40B4-BE49-F238E27FC236}">
-                <a16:creationId xmlns:a16="http://schemas.microsoft.com/office/drawing/2014/main" id="{D29CC27E-1AD0-43CF-8C32-E8EBA0506E88}"/>
+                <a16:creationId xmlns:a16="http://schemas.microsoft.com/office/drawing/2014/main" id="{5ABF2684-8AB5-4B6F-AA9A-A1DA4B78FC68}"/>
               </a:ext>
             </a:extLst>
           </p:cNvPr>
@@ -11205,7 +11205,7 @@
           <p:cNvPr id="3" name="">
             <a:extLst xmlns:a="http://schemas.openxmlformats.org/drawingml/2006/main">
               <a:ext uri="{FF2B5EF4-FFF2-40B4-BE49-F238E27FC236}">
-                <a16:creationId xmlns:a16="http://schemas.microsoft.com/office/drawing/2014/main" id="{A8F04B21-941A-418B-A0EC-8D6F08BCE39D}"/>
+                <a16:creationId xmlns:a16="http://schemas.microsoft.com/office/drawing/2014/main" id="{FBEF9FA0-645F-4D6D-B0FD-65784F42AFDD}"/>
               </a:ext>
             </a:extLst>
           </p:cNvPr>
@@ -11361,7 +11361,7 @@
           <p:cNvPr id="4" name="">
             <a:extLst xmlns:a="http://schemas.openxmlformats.org/drawingml/2006/main">
               <a:ext uri="{FF2B5EF4-FFF2-40B4-BE49-F238E27FC236}">
-                <a16:creationId xmlns:a16="http://schemas.microsoft.com/office/drawing/2014/main" id="{C0E8C284-5025-407C-A554-B01000153BDF}"/>
+                <a16:creationId xmlns:a16="http://schemas.microsoft.com/office/drawing/2014/main" id="{DABB4700-F262-4CB1-BA8B-180CB64BD2AB}"/>
               </a:ext>
             </a:extLst>
           </p:cNvPr>
@@ -11801,7 +11801,7 @@
           <p:cNvPr id="5" name="">
             <a:extLst xmlns:a="http://schemas.openxmlformats.org/drawingml/2006/main">
               <a:ext uri="{FF2B5EF4-FFF2-40B4-BE49-F238E27FC236}">
-                <a16:creationId xmlns:a16="http://schemas.microsoft.com/office/drawing/2014/main" id="{31314528-2E91-401C-A61A-DD9E2A480A99}"/>
+                <a16:creationId xmlns:a16="http://schemas.microsoft.com/office/drawing/2014/main" id="{A332C40C-4290-41A8-BD27-38DCCCB38A87}"/>
               </a:ext>
             </a:extLst>
           </p:cNvPr>
@@ -11957,7 +11957,7 @@
           <p:cNvPr id="6" name="">
             <a:extLst xmlns:a="http://schemas.openxmlformats.org/drawingml/2006/main">
               <a:ext uri="{FF2B5EF4-FFF2-40B4-BE49-F238E27FC236}">
-                <a16:creationId xmlns:a16="http://schemas.microsoft.com/office/drawing/2014/main" id="{63FEB702-07BA-4DF4-A41E-97A298C6BC57}"/>
+                <a16:creationId xmlns:a16="http://schemas.microsoft.com/office/drawing/2014/main" id="{ED995036-6123-4875-86B9-20671788A7A9}"/>
               </a:ext>
             </a:extLst>
           </p:cNvPr>
@@ -12113,7 +12113,7 @@
           <p:cNvPr id="7" name="">
             <a:extLst xmlns:a="http://schemas.openxmlformats.org/drawingml/2006/main">
               <a:ext uri="{FF2B5EF4-FFF2-40B4-BE49-F238E27FC236}">
-                <a16:creationId xmlns:a16="http://schemas.microsoft.com/office/drawing/2014/main" id="{3DC04E4F-5EE3-466A-AAD2-57ED5A5C30C1}"/>
+                <a16:creationId xmlns:a16="http://schemas.microsoft.com/office/drawing/2014/main" id="{4EDD1734-9332-4AFA-ABAD-DDB919C238E8}"/>
               </a:ext>
             </a:extLst>
           </p:cNvPr>
@@ -12123,7 +12123,7 @@
           <p:nvPr/>
         </p:nvPicPr>
         <p:blipFill>
-          <a:blip xmlns:r="http://schemas.openxmlformats.org/officeDocument/2006/relationships" xmlns:a="http://schemas.openxmlformats.org/drawingml/2006/main" r:embed="R75148b9a53a5442a"/>
+          <a:blip xmlns:r="http://schemas.openxmlformats.org/officeDocument/2006/relationships" xmlns:a="http://schemas.openxmlformats.org/drawingml/2006/main" r:embed="R1b3239bddfdf4e58"/>
           <a:stretch xmlns:a="http://schemas.openxmlformats.org/drawingml/2006/main"/>
         </p:blipFill>
         <p:spPr>
@@ -12139,7 +12139,7 @@
     </p:spTree>
     <p:extLst>
       <p:ext uri="{BB962C8B-B14F-4D97-AF65-F5344CB8AC3E}">
-        <p14:creationId xmlns:p14="http://schemas.microsoft.com/office/powerpoint/2010/main" val="1458228675"/>
+        <p14:creationId xmlns:p14="http://schemas.microsoft.com/office/powerpoint/2010/main" val="1943535653"/>
       </p:ext>
     </p:extLst>
   </p:cSld>
@@ -12170,7 +12170,7 @@
           <p:cNvPr id="10" name="">
             <a:extLst xmlns:a="http://schemas.openxmlformats.org/drawingml/2006/main">
               <a:ext uri="{FF2B5EF4-FFF2-40B4-BE49-F238E27FC236}">
-                <a16:creationId xmlns:a16="http://schemas.microsoft.com/office/drawing/2014/main" id="{2FFD980E-41A9-4BD8-B72A-CC71583938E3}"/>
+                <a16:creationId xmlns:a16="http://schemas.microsoft.com/office/drawing/2014/main" id="{DF5D70A2-9B8B-47D8-9BFF-2EFE17F475E5}"/>
               </a:ext>
             </a:extLst>
           </p:cNvPr>
@@ -12326,7 +12326,7 @@
           <p:cNvPr id="2" name="">
             <a:extLst xmlns:a="http://schemas.openxmlformats.org/drawingml/2006/main">
               <a:ext uri="{FF2B5EF4-FFF2-40B4-BE49-F238E27FC236}">
-                <a16:creationId xmlns:a16="http://schemas.microsoft.com/office/drawing/2014/main" id="{1A9B8590-613A-4B8B-BA3A-639B6958E959}"/>
+                <a16:creationId xmlns:a16="http://schemas.microsoft.com/office/drawing/2014/main" id="{34746CBE-DD7D-467D-AF96-D4EDEEB0E823}"/>
               </a:ext>
             </a:extLst>
           </p:cNvPr>
@@ -12482,7 +12482,7 @@
           <p:cNvPr id="3" name="">
             <a:extLst xmlns:a="http://schemas.openxmlformats.org/drawingml/2006/main">
               <a:ext uri="{FF2B5EF4-FFF2-40B4-BE49-F238E27FC236}">
-                <a16:creationId xmlns:a16="http://schemas.microsoft.com/office/drawing/2014/main" id="{C40097BA-913C-4FBC-9426-F50CE29A1B9C}"/>
+                <a16:creationId xmlns:a16="http://schemas.microsoft.com/office/drawing/2014/main" id="{CC00D59D-5F66-483C-B92D-FF40E1AB8F42}"/>
               </a:ext>
             </a:extLst>
           </p:cNvPr>
@@ -12638,7 +12638,7 @@
           <p:cNvPr id="4" name="">
             <a:extLst xmlns:a="http://schemas.openxmlformats.org/drawingml/2006/main">
               <a:ext uri="{FF2B5EF4-FFF2-40B4-BE49-F238E27FC236}">
-                <a16:creationId xmlns:a16="http://schemas.microsoft.com/office/drawing/2014/main" id="{358766EA-E736-4DF0-8CDA-8F75CD19AC32}"/>
+                <a16:creationId xmlns:a16="http://schemas.microsoft.com/office/drawing/2014/main" id="{D5D7A0B9-68C7-4BD6-8F24-4C40675F8F17}"/>
               </a:ext>
             </a:extLst>
           </p:cNvPr>
@@ -12794,7 +12794,7 @@
           <p:cNvPr id="5" name="">
             <a:extLst xmlns:a="http://schemas.openxmlformats.org/drawingml/2006/main">
               <a:ext uri="{FF2B5EF4-FFF2-40B4-BE49-F238E27FC236}">
-                <a16:creationId xmlns:a16="http://schemas.microsoft.com/office/drawing/2014/main" id="{D397C71E-6395-4C3D-AB2A-CD5D6BD81BCA}"/>
+                <a16:creationId xmlns:a16="http://schemas.microsoft.com/office/drawing/2014/main" id="{D7ABA113-4BD4-4482-8544-E8F16A14DF53}"/>
               </a:ext>
             </a:extLst>
           </p:cNvPr>
@@ -12950,7 +12950,7 @@
           <p:cNvPr id="6" name="">
             <a:extLst xmlns:a="http://schemas.openxmlformats.org/drawingml/2006/main">
               <a:ext uri="{FF2B5EF4-FFF2-40B4-BE49-F238E27FC236}">
-                <a16:creationId xmlns:a16="http://schemas.microsoft.com/office/drawing/2014/main" id="{E5004240-E499-49DD-99D2-F8967A6A5A75}"/>
+                <a16:creationId xmlns:a16="http://schemas.microsoft.com/office/drawing/2014/main" id="{C753FA79-94F9-4DE9-BB05-8F8A06A78721}"/>
               </a:ext>
             </a:extLst>
           </p:cNvPr>
@@ -13106,7 +13106,7 @@
           <p:cNvPr id="7" name="">
             <a:extLst xmlns:a="http://schemas.openxmlformats.org/drawingml/2006/main">
               <a:ext uri="{FF2B5EF4-FFF2-40B4-BE49-F238E27FC236}">
-                <a16:creationId xmlns:a16="http://schemas.microsoft.com/office/drawing/2014/main" id="{9129DBDC-82CE-43C5-9382-E68C89BF770F}"/>
+                <a16:creationId xmlns:a16="http://schemas.microsoft.com/office/drawing/2014/main" id="{14E37E5C-2A5E-4FAE-9D70-9D118BFB8D8E}"/>
               </a:ext>
             </a:extLst>
           </p:cNvPr>
@@ -13262,7 +13262,7 @@
           <p:cNvPr id="8" name="">
             <a:extLst xmlns:a="http://schemas.openxmlformats.org/drawingml/2006/main">
               <a:ext uri="{FF2B5EF4-FFF2-40B4-BE49-F238E27FC236}">
-                <a16:creationId xmlns:a16="http://schemas.microsoft.com/office/drawing/2014/main" id="{B9C5BFBA-D760-4ADE-992A-00F3C615C35F}"/>
+                <a16:creationId xmlns:a16="http://schemas.microsoft.com/office/drawing/2014/main" id="{DA28437F-8B01-4BB5-B0F7-DED977CA207A}"/>
               </a:ext>
             </a:extLst>
           </p:cNvPr>
@@ -13441,7 +13441,7 @@
           <p:cNvPr id="9" name="">
             <a:extLst xmlns:a="http://schemas.openxmlformats.org/drawingml/2006/main">
               <a:ext uri="{FF2B5EF4-FFF2-40B4-BE49-F238E27FC236}">
-                <a16:creationId xmlns:a16="http://schemas.microsoft.com/office/drawing/2014/main" id="{8162AA0A-C4BA-46DF-B901-A4303A362DF3}"/>
+                <a16:creationId xmlns:a16="http://schemas.microsoft.com/office/drawing/2014/main" id="{0447B11F-4B73-4442-915B-CFBEA4BD1AD2}"/>
               </a:ext>
             </a:extLst>
           </p:cNvPr>
@@ -13451,7 +13451,7 @@
           <p:nvPr/>
         </p:nvPicPr>
         <p:blipFill>
-          <a:blip xmlns:r="http://schemas.openxmlformats.org/officeDocument/2006/relationships" xmlns:a="http://schemas.openxmlformats.org/drawingml/2006/main" r:embed="R831d94cfe0dc478b"/>
+          <a:blip xmlns:r="http://schemas.openxmlformats.org/officeDocument/2006/relationships" xmlns:a="http://schemas.openxmlformats.org/drawingml/2006/main" r:embed="R9224544c31bc42cd"/>
           <a:stretch xmlns:a="http://schemas.openxmlformats.org/drawingml/2006/main"/>
         </p:blipFill>
         <p:spPr>
@@ -13467,7 +13467,7 @@
     </p:spTree>
     <p:extLst>
       <p:ext uri="{BB962C8B-B14F-4D97-AF65-F5344CB8AC3E}">
-        <p14:creationId xmlns:p14="http://schemas.microsoft.com/office/powerpoint/2010/main" val="2021819430"/>
+        <p14:creationId xmlns:p14="http://schemas.microsoft.com/office/powerpoint/2010/main" val="816723237"/>
       </p:ext>
     </p:extLst>
   </p:cSld>
@@ -13498,7 +13498,7 @@
           <p:cNvPr id="7" name="">
             <a:extLst xmlns:a="http://schemas.openxmlformats.org/drawingml/2006/main">
               <a:ext uri="{FF2B5EF4-FFF2-40B4-BE49-F238E27FC236}">
-                <a16:creationId xmlns:a16="http://schemas.microsoft.com/office/drawing/2014/main" id="{125143CA-958A-428C-BDFC-2559FAE35F42}"/>
+                <a16:creationId xmlns:a16="http://schemas.microsoft.com/office/drawing/2014/main" id="{0E83833F-BB7F-493C-B557-87A32584DFDD}"/>
               </a:ext>
             </a:extLst>
           </p:cNvPr>
@@ -13654,7 +13654,7 @@
           <p:cNvPr id="2" name="">
             <a:extLst xmlns:a="http://schemas.openxmlformats.org/drawingml/2006/main">
               <a:ext uri="{FF2B5EF4-FFF2-40B4-BE49-F238E27FC236}">
-                <a16:creationId xmlns:a16="http://schemas.microsoft.com/office/drawing/2014/main" id="{249DCCFE-0369-4A98-8008-375ADEC52062}"/>
+                <a16:creationId xmlns:a16="http://schemas.microsoft.com/office/drawing/2014/main" id="{956F16A2-7FE6-4A70-8D0A-B6CB2938DE40}"/>
               </a:ext>
             </a:extLst>
           </p:cNvPr>
@@ -13810,7 +13810,7 @@
           <p:cNvPr id="3" name="">
             <a:extLst xmlns:a="http://schemas.openxmlformats.org/drawingml/2006/main">
               <a:ext uri="{FF2B5EF4-FFF2-40B4-BE49-F238E27FC236}">
-                <a16:creationId xmlns:a16="http://schemas.microsoft.com/office/drawing/2014/main" id="{50C1D7D3-FF18-4AF7-9120-C819196266B3}"/>
+                <a16:creationId xmlns:a16="http://schemas.microsoft.com/office/drawing/2014/main" id="{384B6B80-9ED5-48D5-BCCD-ABF36E21100C}"/>
               </a:ext>
             </a:extLst>
           </p:cNvPr>
@@ -13966,7 +13966,7 @@
           <p:cNvPr id="4" name="">
             <a:extLst xmlns:a="http://schemas.openxmlformats.org/drawingml/2006/main">
               <a:ext uri="{FF2B5EF4-FFF2-40B4-BE49-F238E27FC236}">
-                <a16:creationId xmlns:a16="http://schemas.microsoft.com/office/drawing/2014/main" id="{5CB48062-3E48-4BAA-9D39-DCFA64155F72}"/>
+                <a16:creationId xmlns:a16="http://schemas.microsoft.com/office/drawing/2014/main" id="{27AFC2C5-52BE-4498-96A0-6852AEB937EB}"/>
               </a:ext>
             </a:extLst>
           </p:cNvPr>
@@ -14140,7 +14140,7 @@
                 <a:ea typeface="Arial"/>
                 <a:cs typeface="Arial"/>
               </a:rPr>
-              <a:t>Revocable sessions</a:t>
+              <a:t>Private Admin / Finance MFA</a:t>
             </a:r>
           </a:p>
           <a:p xmlns:a="http://schemas.openxmlformats.org/drawingml/2006/main">
@@ -14168,7 +14168,7 @@
                 <a:ea typeface="Arial"/>
                 <a:cs typeface="Arial"/>
               </a:rPr>
-              <a:t>Private files and usage caps</a:t>
+              <a:t>Safe requests and private files</a:t>
             </a:r>
           </a:p>
           <a:p xmlns:a="http://schemas.openxmlformats.org/drawingml/2006/main">
@@ -14206,7 +14206,7 @@
           <p:cNvPr id="5" name="">
             <a:extLst xmlns:a="http://schemas.openxmlformats.org/drawingml/2006/main">
               <a:ext uri="{FF2B5EF4-FFF2-40B4-BE49-F238E27FC236}">
-                <a16:creationId xmlns:a16="http://schemas.microsoft.com/office/drawing/2014/main" id="{BA1A30F9-490C-47CA-88F3-050A4E09CDF5}"/>
+                <a16:creationId xmlns:a16="http://schemas.microsoft.com/office/drawing/2014/main" id="{B4EC6437-4E6F-413A-927C-F93B0A1CCD00}"/>
               </a:ext>
             </a:extLst>
           </p:cNvPr>
@@ -14374,7 +14374,7 @@
                           <a:ea typeface="Arial"/>
                           <a:cs typeface="Arial"/>
                         </a:rPr>
-                        <a:t>225</a:t>
+                        <a:t>251</a:t>
                       </a:r>
                     </a:p>
                   </a:txBody>
@@ -14454,7 +14454,7 @@
                           <a:ea typeface="Arial"/>
                           <a:cs typeface="Arial"/>
                         </a:rPr>
-                        <a:t>8</a:t>
+                        <a:t>10</a:t>
                       </a:r>
                     </a:p>
                   </a:txBody>
@@ -14534,7 +14534,7 @@
                           <a:ea typeface="Arial"/>
                           <a:cs typeface="Arial"/>
                         </a:rPr>
-                        <a:t>18</a:t>
+                        <a:t>20</a:t>
                       </a:r>
                     </a:p>
                   </a:txBody>
@@ -14646,7 +14646,7 @@
           <p:cNvPr id="6" name="">
             <a:extLst xmlns:a="http://schemas.openxmlformats.org/drawingml/2006/main">
               <a:ext uri="{FF2B5EF4-FFF2-40B4-BE49-F238E27FC236}">
-                <a16:creationId xmlns:a16="http://schemas.microsoft.com/office/drawing/2014/main" id="{77DD89C1-3D89-4E70-90B6-7C27AD44055E}"/>
+                <a16:creationId xmlns:a16="http://schemas.microsoft.com/office/drawing/2014/main" id="{9A6F411C-A1B5-4D16-BD54-B3D067180600}"/>
               </a:ext>
             </a:extLst>
           </p:cNvPr>
@@ -14800,7 +14800,7 @@
     </p:spTree>
     <p:extLst>
       <p:ext uri="{BB962C8B-B14F-4D97-AF65-F5344CB8AC3E}">
-        <p14:creationId xmlns:p14="http://schemas.microsoft.com/office/powerpoint/2010/main" val="1138716122"/>
+        <p14:creationId xmlns:p14="http://schemas.microsoft.com/office/powerpoint/2010/main" val="39580290"/>
       </p:ext>
     </p:extLst>
   </p:cSld>
@@ -14831,7 +14831,7 @@
           <p:cNvPr id="10" name="">
             <a:extLst xmlns:a="http://schemas.openxmlformats.org/drawingml/2006/main">
               <a:ext uri="{FF2B5EF4-FFF2-40B4-BE49-F238E27FC236}">
-                <a16:creationId xmlns:a16="http://schemas.microsoft.com/office/drawing/2014/main" id="{5902A516-2EF7-4197-BC01-516A6570EE85}"/>
+                <a16:creationId xmlns:a16="http://schemas.microsoft.com/office/drawing/2014/main" id="{943EAD41-8B07-4999-9EBC-DAEAF685FBF1}"/>
               </a:ext>
             </a:extLst>
           </p:cNvPr>
@@ -14987,7 +14987,7 @@
           <p:cNvPr id="2" name="">
             <a:extLst xmlns:a="http://schemas.openxmlformats.org/drawingml/2006/main">
               <a:ext uri="{FF2B5EF4-FFF2-40B4-BE49-F238E27FC236}">
-                <a16:creationId xmlns:a16="http://schemas.microsoft.com/office/drawing/2014/main" id="{0BAF968F-3AC1-48D1-BE1B-0129B6B8CDF8}"/>
+                <a16:creationId xmlns:a16="http://schemas.microsoft.com/office/drawing/2014/main" id="{5EF3B620-D3E2-4FBD-9F70-7ACDF224C97B}"/>
               </a:ext>
             </a:extLst>
           </p:cNvPr>
@@ -15143,7 +15143,7 @@
           <p:cNvPr id="3" name="">
             <a:extLst xmlns:a="http://schemas.openxmlformats.org/drawingml/2006/main">
               <a:ext uri="{FF2B5EF4-FFF2-40B4-BE49-F238E27FC236}">
-                <a16:creationId xmlns:a16="http://schemas.microsoft.com/office/drawing/2014/main" id="{613B2CC0-9FD7-4330-8726-828E568CE034}"/>
+                <a16:creationId xmlns:a16="http://schemas.microsoft.com/office/drawing/2014/main" id="{65B26FB8-36BD-47B8-A5EE-C5C327FDF46E}"/>
               </a:ext>
             </a:extLst>
           </p:cNvPr>
@@ -15299,7 +15299,7 @@
           <p:cNvPr id="4" name="">
             <a:extLst xmlns:a="http://schemas.openxmlformats.org/drawingml/2006/main">
               <a:ext uri="{FF2B5EF4-FFF2-40B4-BE49-F238E27FC236}">
-                <a16:creationId xmlns:a16="http://schemas.microsoft.com/office/drawing/2014/main" id="{4DADF2D2-54EF-40C8-B07C-D5F2482CBFB7}"/>
+                <a16:creationId xmlns:a16="http://schemas.microsoft.com/office/drawing/2014/main" id="{D897C5D0-2123-4EAD-A3EB-66A3DB075551}"/>
               </a:ext>
             </a:extLst>
           </p:cNvPr>
@@ -15455,7 +15455,7 @@
           <p:cNvPr id="5" name="">
             <a:extLst xmlns:a="http://schemas.openxmlformats.org/drawingml/2006/main">
               <a:ext uri="{FF2B5EF4-FFF2-40B4-BE49-F238E27FC236}">
-                <a16:creationId xmlns:a16="http://schemas.microsoft.com/office/drawing/2014/main" id="{B889DC0A-A602-4AAA-9EA0-F3250BE59D31}"/>
+                <a16:creationId xmlns:a16="http://schemas.microsoft.com/office/drawing/2014/main" id="{805B1F4F-55AC-456F-AB4E-0A21C28C7BEC}"/>
               </a:ext>
             </a:extLst>
           </p:cNvPr>
@@ -15611,7 +15611,7 @@
           <p:cNvPr id="6" name="">
             <a:extLst xmlns:a="http://schemas.openxmlformats.org/drawingml/2006/main">
               <a:ext uri="{FF2B5EF4-FFF2-40B4-BE49-F238E27FC236}">
-                <a16:creationId xmlns:a16="http://schemas.microsoft.com/office/drawing/2014/main" id="{6F2241B8-1C65-40DA-9B3A-A1A381E60E48}"/>
+                <a16:creationId xmlns:a16="http://schemas.microsoft.com/office/drawing/2014/main" id="{A401DB32-6254-4C89-A064-247DF4180A5F}"/>
               </a:ext>
             </a:extLst>
           </p:cNvPr>
@@ -15767,7 +15767,7 @@
           <p:cNvPr id="7" name="">
             <a:extLst xmlns:a="http://schemas.openxmlformats.org/drawingml/2006/main">
               <a:ext uri="{FF2B5EF4-FFF2-40B4-BE49-F238E27FC236}">
-                <a16:creationId xmlns:a16="http://schemas.microsoft.com/office/drawing/2014/main" id="{5C8A1F2D-72F9-41ED-9164-BBF98DC86845}"/>
+                <a16:creationId xmlns:a16="http://schemas.microsoft.com/office/drawing/2014/main" id="{6B94041F-BEC8-4CC1-BC92-20D9908C4707}"/>
               </a:ext>
             </a:extLst>
           </p:cNvPr>
@@ -15923,7 +15923,7 @@
           <p:cNvPr id="8" name="">
             <a:extLst xmlns:a="http://schemas.openxmlformats.org/drawingml/2006/main">
               <a:ext uri="{FF2B5EF4-FFF2-40B4-BE49-F238E27FC236}">
-                <a16:creationId xmlns:a16="http://schemas.microsoft.com/office/drawing/2014/main" id="{0BCCEA40-676F-4C62-BCCB-745F9CB44643}"/>
+                <a16:creationId xmlns:a16="http://schemas.microsoft.com/office/drawing/2014/main" id="{48E96BCB-39C9-48CD-867A-98AD99CA4F4F}"/>
               </a:ext>
             </a:extLst>
           </p:cNvPr>
@@ -15933,7 +15933,7 @@
           <p:nvPr/>
         </p:nvPicPr>
         <p:blipFill>
-          <a:blip xmlns:r="http://schemas.openxmlformats.org/officeDocument/2006/relationships" xmlns:a="http://schemas.openxmlformats.org/drawingml/2006/main" r:embed="Rcaf0225493c24944"/>
+          <a:blip xmlns:r="http://schemas.openxmlformats.org/officeDocument/2006/relationships" xmlns:a="http://schemas.openxmlformats.org/drawingml/2006/main" r:embed="Rcd47037d0b0d468c"/>
           <a:stretch xmlns:a="http://schemas.openxmlformats.org/drawingml/2006/main"/>
         </p:blipFill>
         <p:spPr>
@@ -15951,7 +15951,7 @@
           <p:cNvPr id="9" name="">
             <a:extLst xmlns:a="http://schemas.openxmlformats.org/drawingml/2006/main">
               <a:ext uri="{FF2B5EF4-FFF2-40B4-BE49-F238E27FC236}">
-                <a16:creationId xmlns:a16="http://schemas.microsoft.com/office/drawing/2014/main" id="{7B9D8A91-EC0A-48A6-9EAA-8923CEA686B8}"/>
+                <a16:creationId xmlns:a16="http://schemas.microsoft.com/office/drawing/2014/main" id="{4EF81DA1-B21F-40E9-89B1-27D747F7DD21}"/>
               </a:ext>
             </a:extLst>
           </p:cNvPr>
@@ -16105,7 +16105,7 @@
     </p:spTree>
     <p:extLst>
       <p:ext uri="{BB962C8B-B14F-4D97-AF65-F5344CB8AC3E}">
-        <p14:creationId xmlns:p14="http://schemas.microsoft.com/office/powerpoint/2010/main" val="1786176929"/>
+        <p14:creationId xmlns:p14="http://schemas.microsoft.com/office/powerpoint/2010/main" val="1831396542"/>
       </p:ext>
     </p:extLst>
   </p:cSld>

</xml_diff>

<commit_message>
Refresh submission guides around implemented features and verified security
</commit_message>
<xml_diff>
--- a/submission/BuildTrustAI_Presentation.pptx
+++ b/submission/BuildTrustAI_Presentation.pptx
@@ -2,21 +2,21 @@
 <file path=ppt/presentation.xml><?xml version="1.0" encoding="utf-8"?>
 <p:presentation xmlns:p="http://schemas.openxmlformats.org/presentationml/2006/main">
   <p:sldMasterIdLst>
-    <p:sldMasterId xmlns:r="http://schemas.openxmlformats.org/officeDocument/2006/relationships" id="2147483648" r:id="R2a2fd2445bc74623"/>
+    <p:sldMasterId xmlns:r="http://schemas.openxmlformats.org/officeDocument/2006/relationships" id="2147483648" r:id="Rd578a96ef4a24f04"/>
   </p:sldMasterIdLst>
   <p:notesMasterIdLst>
-    <p:notesMasterId xmlns:r="http://schemas.openxmlformats.org/officeDocument/2006/relationships" r:id="R6cb10c73967745a1"/>
+    <p:notesMasterId xmlns:r="http://schemas.openxmlformats.org/officeDocument/2006/relationships" r:id="R24f9ebd1adfd46f7"/>
   </p:notesMasterIdLst>
   <p:sldIdLst>
-    <p:sldId xmlns:r="http://schemas.openxmlformats.org/officeDocument/2006/relationships" id="256" r:id="R775a9c97ac914e2f"/>
-    <p:sldId xmlns:r="http://schemas.openxmlformats.org/officeDocument/2006/relationships" id="257" r:id="R6211515a4b0a4164"/>
-    <p:sldId xmlns:r="http://schemas.openxmlformats.org/officeDocument/2006/relationships" id="258" r:id="Ree3dfeb95ce64155"/>
-    <p:sldId xmlns:r="http://schemas.openxmlformats.org/officeDocument/2006/relationships" id="259" r:id="R267c9a1d76e0400d"/>
-    <p:sldId xmlns:r="http://schemas.openxmlformats.org/officeDocument/2006/relationships" id="260" r:id="Rb442da6c561e4538"/>
-    <p:sldId xmlns:r="http://schemas.openxmlformats.org/officeDocument/2006/relationships" id="261" r:id="R0f26abdccd3c4233"/>
-    <p:sldId xmlns:r="http://schemas.openxmlformats.org/officeDocument/2006/relationships" id="262" r:id="R53d9d391ee604936"/>
-    <p:sldId xmlns:r="http://schemas.openxmlformats.org/officeDocument/2006/relationships" id="263" r:id="R0ed6f840955a4ccd"/>
-    <p:sldId xmlns:r="http://schemas.openxmlformats.org/officeDocument/2006/relationships" id="264" r:id="Rcad743ad65294bdf"/>
+    <p:sldId xmlns:r="http://schemas.openxmlformats.org/officeDocument/2006/relationships" id="256" r:id="R5b7ca43eb9b4419b"/>
+    <p:sldId xmlns:r="http://schemas.openxmlformats.org/officeDocument/2006/relationships" id="257" r:id="R05bb45aef72f4e6d"/>
+    <p:sldId xmlns:r="http://schemas.openxmlformats.org/officeDocument/2006/relationships" id="258" r:id="R3a37850901b24dde"/>
+    <p:sldId xmlns:r="http://schemas.openxmlformats.org/officeDocument/2006/relationships" id="259" r:id="R81819ff5155d42b9"/>
+    <p:sldId xmlns:r="http://schemas.openxmlformats.org/officeDocument/2006/relationships" id="260" r:id="R25693e49160548cd"/>
+    <p:sldId xmlns:r="http://schemas.openxmlformats.org/officeDocument/2006/relationships" id="261" r:id="Rf394b1a7ad3b4def"/>
+    <p:sldId xmlns:r="http://schemas.openxmlformats.org/officeDocument/2006/relationships" id="262" r:id="R9c0023cfb8bf4ca7"/>
+    <p:sldId xmlns:r="http://schemas.openxmlformats.org/officeDocument/2006/relationships" id="263" r:id="R8e64027f90c94fb7"/>
+    <p:sldId xmlns:r="http://schemas.openxmlformats.org/officeDocument/2006/relationships" id="264" r:id="R017c559911b747a7"/>
   </p:sldIdLst>
   <p:sldSz cx="12192000" cy="6858000"/>
   <p:notesSz cx="6858000" cy="9144000"/>
@@ -940,7 +940,7 @@
           <a:lstStyle xmlns:a="http://schemas.openxmlformats.org/drawingml/2006/main"/>
           <a:p xmlns:a="http://schemas.openxmlformats.org/drawingml/2006/main">
             <a:r>
-              <a:t>6:40–7:50. The table shows actual local results: 251 backend tests, 10 frontend tests, 20 browser workflows and eight original HTTP scenarios. Separate public-demo checks verify four documented logins and preserve the private profile. Tests cover denied roles, changed approvals, expiry, duplicate quantities, competing execution, rollback and retries. Fresh installation checks use a source copy. A passing suite is evidence for tested behavior, not complete security assurance. The audit chain can find inconsistent retained events, but a full database owner can rewrite it. The original twenty-item review and separate nineteen-control checklist cover revocable sessions, private Admin/Finance authenticator MFA, safe browser requests, offline recovery, private backups, secret scans and persistent caps. Public demo accounts stay exempt from MFA and keep the four README passwords. Native database RLS remains deferred; incoming webhooks are not applicable. Independent security and assistive-technology reviews remain separate. Sources: verification-summary.json; test logs; public-demo-install.json; docs/security-self-assessment.md.</a:t>
+              <a:t>6:40–7:50. The table shows actual local results: 251 backend tests, 10 frontend tests, 20 browser workflows and eight original HTTP scenarios. The application and security hardening are implemented. The October 20 hosted Windows and Linux run passed at application revision 0009a198bf9ce7583cd2c870953e21d82a584739. Each runner passed 250 backend tests and skipped the optional OCR model check without its language files. The local suite passed all 251. Separate public-demo checks verify four documented logins and preserve the private profile. Tests cover denied roles, changed approvals, expiry, duplicate quantities, competing execution, rollback and retries. Fresh installation checks use a source copy. A passing suite is evidence for tested behavior, not complete security assurance. The audit chain can find inconsistent retained events, but a full database owner can rewrite it. The original twenty-item review and separate nineteen-control checklist cover revocable sessions, private Admin/Finance authenticator MFA, safe browser requests, offline recovery, private backups, secret scans and persistent caps. Public demo accounts stay exempt from MFA and keep the four README passwords. Native database RLS remains deferred; incoming webhooks are not applicable. Independent security and assistive-technology reviews remain separate. Sources: verification-summary.json; test logs; public-demo-install.json; docs/security-self-assessment.md; https://github.com/md-ishtiak-ahmed-sajib/buildtrust-ai/actions/runs/39419213954.</a:t>
             </a:r>
           </a:p>
         </p:txBody>
@@ -1057,7 +1057,7 @@
           <p:cNvPr id="3" name="Title">
             <a:extLst xmlns:a="http://schemas.openxmlformats.org/drawingml/2006/main">
               <a:ext uri="{FF2B5EF4-FFF2-40B4-BE49-F238E27FC236}">
-                <a16:creationId xmlns:a16="http://schemas.microsoft.com/office/drawing/2014/main" id="{B216339B-C961-40CB-92F9-243F62A0B340}"/>
+                <a16:creationId xmlns:a16="http://schemas.microsoft.com/office/drawing/2014/main" id="{64FF7573-646A-4651-B0A4-51C6E45D5519}"/>
               </a:ext>
             </a:extLst>
           </p:cNvPr>
@@ -1286,7 +1286,7 @@
           <p:cNvPr id="2" name="Subtitle">
             <a:extLst xmlns:a="http://schemas.openxmlformats.org/drawingml/2006/main">
               <a:ext uri="{FF2B5EF4-FFF2-40B4-BE49-F238E27FC236}">
-                <a16:creationId xmlns:a16="http://schemas.microsoft.com/office/drawing/2014/main" id="{C14B0913-8659-4C53-B4BC-D9F4019C3AA4}"/>
+                <a16:creationId xmlns:a16="http://schemas.microsoft.com/office/drawing/2014/main" id="{BEC8DEC8-B54A-44C8-AE7F-351F48684A6D}"/>
               </a:ext>
             </a:extLst>
           </p:cNvPr>
@@ -1532,7 +1532,7 @@
           <p:cNvPr id="2" name="Section title">
             <a:extLst xmlns:a="http://schemas.openxmlformats.org/drawingml/2006/main">
               <a:ext uri="{FF2B5EF4-FFF2-40B4-BE49-F238E27FC236}">
-                <a16:creationId xmlns:a16="http://schemas.microsoft.com/office/drawing/2014/main" id="{2CC9BE9A-6F86-46C4-A97E-FDE44E330A65}"/>
+                <a16:creationId xmlns:a16="http://schemas.microsoft.com/office/drawing/2014/main" id="{E2E9D8A3-3E72-418D-8B2D-B9E89004B30F}"/>
               </a:ext>
             </a:extLst>
           </p:cNvPr>
@@ -1778,7 +1778,7 @@
           <p:cNvPr id="3" name="Title">
             <a:extLst xmlns:a="http://schemas.openxmlformats.org/drawingml/2006/main">
               <a:ext uri="{FF2B5EF4-FFF2-40B4-BE49-F238E27FC236}">
-                <a16:creationId xmlns:a16="http://schemas.microsoft.com/office/drawing/2014/main" id="{074D51A8-5F90-477F-970C-06ABE0C4CCF3}"/>
+                <a16:creationId xmlns:a16="http://schemas.microsoft.com/office/drawing/2014/main" id="{0BDAA5F7-E1FA-4276-B85C-6B442680B58A}"/>
               </a:ext>
             </a:extLst>
           </p:cNvPr>
@@ -2007,7 +2007,7 @@
           <p:cNvPr id="2" name="Body">
             <a:extLst xmlns:a="http://schemas.openxmlformats.org/drawingml/2006/main">
               <a:ext uri="{FF2B5EF4-FFF2-40B4-BE49-F238E27FC236}">
-                <a16:creationId xmlns:a16="http://schemas.microsoft.com/office/drawing/2014/main" id="{574F4C75-4A1E-4F6A-A346-844476A0AA29}"/>
+                <a16:creationId xmlns:a16="http://schemas.microsoft.com/office/drawing/2014/main" id="{0DFA726E-A345-4790-B98A-D1E614DA395E}"/>
               </a:ext>
             </a:extLst>
           </p:cNvPr>
@@ -2253,7 +2253,7 @@
           <p:cNvPr id="4" name="Title">
             <a:extLst xmlns:a="http://schemas.openxmlformats.org/drawingml/2006/main">
               <a:ext uri="{FF2B5EF4-FFF2-40B4-BE49-F238E27FC236}">
-                <a16:creationId xmlns:a16="http://schemas.microsoft.com/office/drawing/2014/main" id="{81B61265-917F-4718-A5A2-E1B73D403ACB}"/>
+                <a16:creationId xmlns:a16="http://schemas.microsoft.com/office/drawing/2014/main" id="{2B46212C-19D9-4C91-AC91-BB98B2E60ADF}"/>
               </a:ext>
             </a:extLst>
           </p:cNvPr>
@@ -2482,7 +2482,7 @@
           <p:cNvPr id="2" name="Left column">
             <a:extLst xmlns:a="http://schemas.openxmlformats.org/drawingml/2006/main">
               <a:ext uri="{FF2B5EF4-FFF2-40B4-BE49-F238E27FC236}">
-                <a16:creationId xmlns:a16="http://schemas.microsoft.com/office/drawing/2014/main" id="{6C729CFD-0DDA-4911-AB99-25B3832EADEB}"/>
+                <a16:creationId xmlns:a16="http://schemas.microsoft.com/office/drawing/2014/main" id="{0C0132F4-3E43-49B9-A345-63C4E270DD07}"/>
               </a:ext>
             </a:extLst>
           </p:cNvPr>
@@ -2711,7 +2711,7 @@
           <p:cNvPr id="3" name="Right column">
             <a:extLst xmlns:a="http://schemas.openxmlformats.org/drawingml/2006/main">
               <a:ext uri="{FF2B5EF4-FFF2-40B4-BE49-F238E27FC236}">
-                <a16:creationId xmlns:a16="http://schemas.microsoft.com/office/drawing/2014/main" id="{A26A6933-8622-4FD9-8EC0-C71DF8B7AAE0}"/>
+                <a16:creationId xmlns:a16="http://schemas.microsoft.com/office/drawing/2014/main" id="{A809B3AB-50DA-438C-9DB9-8C61E55FA67F}"/>
               </a:ext>
             </a:extLst>
           </p:cNvPr>
@@ -2957,7 +2957,7 @@
           <p:cNvPr id="3" name="Title">
             <a:extLst xmlns:a="http://schemas.openxmlformats.org/drawingml/2006/main">
               <a:ext uri="{FF2B5EF4-FFF2-40B4-BE49-F238E27FC236}">
-                <a16:creationId xmlns:a16="http://schemas.microsoft.com/office/drawing/2014/main" id="{DA75B608-0FFA-4BE6-B5B3-7A9889CF9BAE}"/>
+                <a16:creationId xmlns:a16="http://schemas.microsoft.com/office/drawing/2014/main" id="{EBE1189C-51A5-46D4-8252-CD047C50A2AB}"/>
               </a:ext>
             </a:extLst>
           </p:cNvPr>
@@ -3186,7 +3186,7 @@
           <p:cNvPr id="2" name="Left column">
             <a:extLst xmlns:a="http://schemas.openxmlformats.org/drawingml/2006/main">
               <a:ext uri="{FF2B5EF4-FFF2-40B4-BE49-F238E27FC236}">
-                <a16:creationId xmlns:a16="http://schemas.microsoft.com/office/drawing/2014/main" id="{CEB2C4A7-1658-4274-991F-50BE74FFA063}"/>
+                <a16:creationId xmlns:a16="http://schemas.microsoft.com/office/drawing/2014/main" id="{21F86977-1974-4CDB-BB48-19C4413F804F}"/>
               </a:ext>
             </a:extLst>
           </p:cNvPr>
@@ -3453,12 +3453,12 @@
   </p:cSld>
   <p:clrMap bg1="lt1" tx1="dk1" bg2="lt2" tx2="dk2" accent1="accent1" accent2="accent2" accent3="accent3" accent4="accent4" accent5="accent5" accent6="accent6" hlink="hlink" folHlink="folHlink"/>
   <p:sldLayoutIdLst>
-    <p:sldLayoutId xmlns:r="http://schemas.openxmlformats.org/officeDocument/2006/relationships" id="2147483649" r:id="R190c93d25d8040ff"/>
-    <p:sldLayoutId xmlns:r="http://schemas.openxmlformats.org/officeDocument/2006/relationships" id="2147483650" r:id="R00d795df04a1463f"/>
-    <p:sldLayoutId xmlns:r="http://schemas.openxmlformats.org/officeDocument/2006/relationships" id="2147483651" r:id="R9133309031a74530"/>
-    <p:sldLayoutId xmlns:r="http://schemas.openxmlformats.org/officeDocument/2006/relationships" id="2147483652" r:id="Re65702823d634fc4"/>
-    <p:sldLayoutId xmlns:r="http://schemas.openxmlformats.org/officeDocument/2006/relationships" id="2147483653" r:id="R3684ed9d87c446cf"/>
-    <p:sldLayoutId xmlns:r="http://schemas.openxmlformats.org/officeDocument/2006/relationships" id="2147483654" r:id="R411170bad5ec43c2"/>
+    <p:sldLayoutId xmlns:r="http://schemas.openxmlformats.org/officeDocument/2006/relationships" id="2147483649" r:id="R340de51f10854226"/>
+    <p:sldLayoutId xmlns:r="http://schemas.openxmlformats.org/officeDocument/2006/relationships" id="2147483650" r:id="Ra8ccc2e05e824fa1"/>
+    <p:sldLayoutId xmlns:r="http://schemas.openxmlformats.org/officeDocument/2006/relationships" id="2147483651" r:id="R854ed978c10e4460"/>
+    <p:sldLayoutId xmlns:r="http://schemas.openxmlformats.org/officeDocument/2006/relationships" id="2147483652" r:id="R707679a1e057486f"/>
+    <p:sldLayoutId xmlns:r="http://schemas.openxmlformats.org/officeDocument/2006/relationships" id="2147483653" r:id="Ra887e4565d534fa1"/>
+    <p:sldLayoutId xmlns:r="http://schemas.openxmlformats.org/officeDocument/2006/relationships" id="2147483654" r:id="Re53a9136f3ad4ef8"/>
   </p:sldLayoutIdLst>
   <p:txStyles>
     <p:titleStyle>
@@ -4009,7 +4009,7 @@
           <p:cNvPr id="7" name="">
             <a:extLst xmlns:a="http://schemas.openxmlformats.org/drawingml/2006/main">
               <a:ext uri="{FF2B5EF4-FFF2-40B4-BE49-F238E27FC236}">
-                <a16:creationId xmlns:a16="http://schemas.microsoft.com/office/drawing/2014/main" id="{C843E7EA-A5ED-42A9-9602-3E8EE41C699E}"/>
+                <a16:creationId xmlns:a16="http://schemas.microsoft.com/office/drawing/2014/main" id="{5814CBA8-ACB6-4957-8C86-6F8C7EBD6204}"/>
               </a:ext>
             </a:extLst>
           </p:cNvPr>
@@ -4165,7 +4165,7 @@
           <p:cNvPr id="2" name="">
             <a:extLst xmlns:a="http://schemas.openxmlformats.org/drawingml/2006/main">
               <a:ext uri="{FF2B5EF4-FFF2-40B4-BE49-F238E27FC236}">
-                <a16:creationId xmlns:a16="http://schemas.microsoft.com/office/drawing/2014/main" id="{E2096451-F36C-4D02-913A-26FA359AD50C}"/>
+                <a16:creationId xmlns:a16="http://schemas.microsoft.com/office/drawing/2014/main" id="{17C785D0-9D1E-4A84-8EB5-065C2EBDC25D}"/>
               </a:ext>
             </a:extLst>
           </p:cNvPr>
@@ -4321,7 +4321,7 @@
           <p:cNvPr id="3" name="">
             <a:extLst xmlns:a="http://schemas.openxmlformats.org/drawingml/2006/main">
               <a:ext uri="{FF2B5EF4-FFF2-40B4-BE49-F238E27FC236}">
-                <a16:creationId xmlns:a16="http://schemas.microsoft.com/office/drawing/2014/main" id="{E277D02E-9789-4A36-AEFC-B2C65AC77596}"/>
+                <a16:creationId xmlns:a16="http://schemas.microsoft.com/office/drawing/2014/main" id="{0696CC8F-5790-4A2C-AD34-F13610BB653A}"/>
               </a:ext>
             </a:extLst>
           </p:cNvPr>
@@ -4477,7 +4477,7 @@
           <p:cNvPr id="4" name="">
             <a:extLst xmlns:a="http://schemas.openxmlformats.org/drawingml/2006/main">
               <a:ext uri="{FF2B5EF4-FFF2-40B4-BE49-F238E27FC236}">
-                <a16:creationId xmlns:a16="http://schemas.microsoft.com/office/drawing/2014/main" id="{A584CB2F-873E-4C43-8DAD-F15E51D3F219}"/>
+                <a16:creationId xmlns:a16="http://schemas.microsoft.com/office/drawing/2014/main" id="{2A8E7BCF-F449-41A4-9F39-97CD9F14DBA9}"/>
               </a:ext>
             </a:extLst>
           </p:cNvPr>
@@ -4656,7 +4656,7 @@
           <p:cNvPr id="5" name="">
             <a:extLst xmlns:a="http://schemas.openxmlformats.org/drawingml/2006/main">
               <a:ext uri="{FF2B5EF4-FFF2-40B4-BE49-F238E27FC236}">
-                <a16:creationId xmlns:a16="http://schemas.microsoft.com/office/drawing/2014/main" id="{53CFAAF9-7AD9-45BA-AAFD-8BB329FE96F1}"/>
+                <a16:creationId xmlns:a16="http://schemas.microsoft.com/office/drawing/2014/main" id="{DE748299-EE8D-4C2B-9EDD-17A9656D867D}"/>
               </a:ext>
             </a:extLst>
           </p:cNvPr>
@@ -4802,7 +4802,7 @@
                 <a:ea typeface="Arial"/>
                 <a:cs typeface="Arial"/>
               </a:rPr>
-              <a:t>Clear evidence for construction finance.</a:t>
+              <a:t>Implemented application. Security checks completed.</a:t>
             </a:r>
           </a:p>
         </p:txBody>
@@ -4812,7 +4812,7 @@
           <p:cNvPr id="6" name="">
             <a:extLst xmlns:a="http://schemas.openxmlformats.org/drawingml/2006/main">
               <a:ext uri="{FF2B5EF4-FFF2-40B4-BE49-F238E27FC236}">
-                <a16:creationId xmlns:a16="http://schemas.microsoft.com/office/drawing/2014/main" id="{7D72008B-C852-44E3-971C-533E6C824FFC}"/>
+                <a16:creationId xmlns:a16="http://schemas.microsoft.com/office/drawing/2014/main" id="{57884D36-7601-4187-AB00-5CE575757CB7}"/>
               </a:ext>
             </a:extLst>
           </p:cNvPr>
@@ -4966,7 +4966,7 @@
     </p:spTree>
     <p:extLst>
       <p:ext uri="{BB962C8B-B14F-4D97-AF65-F5344CB8AC3E}">
-        <p14:creationId xmlns:p14="http://schemas.microsoft.com/office/powerpoint/2010/main" val="1264427178"/>
+        <p14:creationId xmlns:p14="http://schemas.microsoft.com/office/powerpoint/2010/main" val="417632636"/>
       </p:ext>
     </p:extLst>
   </p:cSld>
@@ -4997,7 +4997,7 @@
           <p:cNvPr id="7" name="">
             <a:extLst xmlns:a="http://schemas.openxmlformats.org/drawingml/2006/main">
               <a:ext uri="{FF2B5EF4-FFF2-40B4-BE49-F238E27FC236}">
-                <a16:creationId xmlns:a16="http://schemas.microsoft.com/office/drawing/2014/main" id="{538F26E6-4F17-499F-86AE-938B77A80F87}"/>
+                <a16:creationId xmlns:a16="http://schemas.microsoft.com/office/drawing/2014/main" id="{13D0C921-471F-4A9A-80CF-2FCEFFC75843}"/>
               </a:ext>
             </a:extLst>
           </p:cNvPr>
@@ -5153,7 +5153,7 @@
           <p:cNvPr id="2" name="">
             <a:extLst xmlns:a="http://schemas.openxmlformats.org/drawingml/2006/main">
               <a:ext uri="{FF2B5EF4-FFF2-40B4-BE49-F238E27FC236}">
-                <a16:creationId xmlns:a16="http://schemas.microsoft.com/office/drawing/2014/main" id="{D78421CC-AAF2-4689-B398-C013A9793D19}"/>
+                <a16:creationId xmlns:a16="http://schemas.microsoft.com/office/drawing/2014/main" id="{B39BE1A6-80DD-419D-9408-1E09D70A9A4B}"/>
               </a:ext>
             </a:extLst>
           </p:cNvPr>
@@ -5309,7 +5309,7 @@
           <p:cNvPr id="3" name="">
             <a:extLst xmlns:a="http://schemas.openxmlformats.org/drawingml/2006/main">
               <a:ext uri="{FF2B5EF4-FFF2-40B4-BE49-F238E27FC236}">
-                <a16:creationId xmlns:a16="http://schemas.microsoft.com/office/drawing/2014/main" id="{9F648A61-8C54-42F0-870D-E90502B69A3A}"/>
+                <a16:creationId xmlns:a16="http://schemas.microsoft.com/office/drawing/2014/main" id="{85834FFD-E66A-46DE-AA6D-853E9F2AA559}"/>
               </a:ext>
             </a:extLst>
           </p:cNvPr>
@@ -5465,7 +5465,7 @@
           <p:cNvPr id="4" name="">
             <a:extLst xmlns:a="http://schemas.openxmlformats.org/drawingml/2006/main">
               <a:ext uri="{FF2B5EF4-FFF2-40B4-BE49-F238E27FC236}">
-                <a16:creationId xmlns:a16="http://schemas.microsoft.com/office/drawing/2014/main" id="{D1000DB8-5FD3-482F-8744-D2319AF61AC1}"/>
+                <a16:creationId xmlns:a16="http://schemas.microsoft.com/office/drawing/2014/main" id="{6A47E907-6797-462E-B3C8-C7C0DA378347}"/>
               </a:ext>
             </a:extLst>
           </p:cNvPr>
@@ -5621,7 +5621,7 @@
           <p:cNvPr id="5" name="">
             <a:extLst xmlns:a="http://schemas.openxmlformats.org/drawingml/2006/main">
               <a:ext uri="{FF2B5EF4-FFF2-40B4-BE49-F238E27FC236}">
-                <a16:creationId xmlns:a16="http://schemas.microsoft.com/office/drawing/2014/main" id="{B150AE04-B448-4F05-96B7-E6017CC0B19B}"/>
+                <a16:creationId xmlns:a16="http://schemas.microsoft.com/office/drawing/2014/main" id="{B6914547-38C1-424B-B39C-D5E8DB0E9B38}"/>
               </a:ext>
             </a:extLst>
           </p:cNvPr>
@@ -5833,7 +5833,7 @@
           <p:cNvPr id="6" name="">
             <a:extLst xmlns:a="http://schemas.openxmlformats.org/drawingml/2006/main">
               <a:ext uri="{FF2B5EF4-FFF2-40B4-BE49-F238E27FC236}">
-                <a16:creationId xmlns:a16="http://schemas.microsoft.com/office/drawing/2014/main" id="{B6EA5C87-0EF5-4745-B981-507BFF1A3557}"/>
+                <a16:creationId xmlns:a16="http://schemas.microsoft.com/office/drawing/2014/main" id="{01FC6DD5-8782-4F99-AFAC-52B7C66E9696}"/>
               </a:ext>
             </a:extLst>
           </p:cNvPr>
@@ -5843,7 +5843,7 @@
           <p:nvPr/>
         </p:nvPicPr>
         <p:blipFill>
-          <a:blip xmlns:r="http://schemas.openxmlformats.org/officeDocument/2006/relationships" xmlns:a="http://schemas.openxmlformats.org/drawingml/2006/main" r:embed="R3398cec636364f5c"/>
+          <a:blip xmlns:r="http://schemas.openxmlformats.org/officeDocument/2006/relationships" xmlns:a="http://schemas.openxmlformats.org/drawingml/2006/main" r:embed="R894fcb0d0fe940ea"/>
           <a:stretch xmlns:a="http://schemas.openxmlformats.org/drawingml/2006/main"/>
         </p:blipFill>
         <p:spPr>
@@ -5859,7 +5859,7 @@
     </p:spTree>
     <p:extLst>
       <p:ext uri="{BB962C8B-B14F-4D97-AF65-F5344CB8AC3E}">
-        <p14:creationId xmlns:p14="http://schemas.microsoft.com/office/powerpoint/2010/main" val="360972637"/>
+        <p14:creationId xmlns:p14="http://schemas.microsoft.com/office/powerpoint/2010/main" val="426469377"/>
       </p:ext>
     </p:extLst>
   </p:cSld>
@@ -5890,7 +5890,7 @@
           <p:cNvPr id="9" name="">
             <a:extLst xmlns:a="http://schemas.openxmlformats.org/drawingml/2006/main">
               <a:ext uri="{FF2B5EF4-FFF2-40B4-BE49-F238E27FC236}">
-                <a16:creationId xmlns:a16="http://schemas.microsoft.com/office/drawing/2014/main" id="{6208AF6D-6149-467E-9B6F-0245391C463F}"/>
+                <a16:creationId xmlns:a16="http://schemas.microsoft.com/office/drawing/2014/main" id="{D0D2BEE9-42E0-4905-B4EE-66DB709C0B98}"/>
               </a:ext>
             </a:extLst>
           </p:cNvPr>
@@ -6046,7 +6046,7 @@
           <p:cNvPr id="2" name="">
             <a:extLst xmlns:a="http://schemas.openxmlformats.org/drawingml/2006/main">
               <a:ext uri="{FF2B5EF4-FFF2-40B4-BE49-F238E27FC236}">
-                <a16:creationId xmlns:a16="http://schemas.microsoft.com/office/drawing/2014/main" id="{3ACC393D-09D5-4F14-8FBC-489B9A3645E5}"/>
+                <a16:creationId xmlns:a16="http://schemas.microsoft.com/office/drawing/2014/main" id="{6EAF3CCF-D33C-40AB-8EEA-F7646A5B0F0B}"/>
               </a:ext>
             </a:extLst>
           </p:cNvPr>
@@ -6202,7 +6202,7 @@
           <p:cNvPr id="3" name="">
             <a:extLst xmlns:a="http://schemas.openxmlformats.org/drawingml/2006/main">
               <a:ext uri="{FF2B5EF4-FFF2-40B4-BE49-F238E27FC236}">
-                <a16:creationId xmlns:a16="http://schemas.microsoft.com/office/drawing/2014/main" id="{953C3492-9843-4414-9323-B1A52FEB7362}"/>
+                <a16:creationId xmlns:a16="http://schemas.microsoft.com/office/drawing/2014/main" id="{F134EBD1-36E9-4559-B7DA-D34204AD06EE}"/>
               </a:ext>
             </a:extLst>
           </p:cNvPr>
@@ -6358,7 +6358,7 @@
           <p:cNvPr id="4" name="">
             <a:extLst xmlns:a="http://schemas.openxmlformats.org/drawingml/2006/main">
               <a:ext uri="{FF2B5EF4-FFF2-40B4-BE49-F238E27FC236}">
-                <a16:creationId xmlns:a16="http://schemas.microsoft.com/office/drawing/2014/main" id="{341FA53B-196F-4DF6-938D-7EB50D8E7101}"/>
+                <a16:creationId xmlns:a16="http://schemas.microsoft.com/office/drawing/2014/main" id="{12D9B6E7-2057-457D-BF2A-5C638B179A31}"/>
               </a:ext>
             </a:extLst>
           </p:cNvPr>
@@ -6537,7 +6537,7 @@
           <p:cNvPr id="5" name="">
             <a:extLst xmlns:a="http://schemas.openxmlformats.org/drawingml/2006/main">
               <a:ext uri="{FF2B5EF4-FFF2-40B4-BE49-F238E27FC236}">
-                <a16:creationId xmlns:a16="http://schemas.microsoft.com/office/drawing/2014/main" id="{B3BE656A-80C5-4F94-A6F0-2142D68C596A}"/>
+                <a16:creationId xmlns:a16="http://schemas.microsoft.com/office/drawing/2014/main" id="{069E2F7F-E4DB-4FA3-B665-CE4337ADB690}"/>
               </a:ext>
             </a:extLst>
           </p:cNvPr>
@@ -6693,7 +6693,7 @@
           <p:cNvPr id="6" name="">
             <a:extLst xmlns:a="http://schemas.openxmlformats.org/drawingml/2006/main">
               <a:ext uri="{FF2B5EF4-FFF2-40B4-BE49-F238E27FC236}">
-                <a16:creationId xmlns:a16="http://schemas.microsoft.com/office/drawing/2014/main" id="{70A5927D-4F4C-4384-A5F8-51B79C9E62AE}"/>
+                <a16:creationId xmlns:a16="http://schemas.microsoft.com/office/drawing/2014/main" id="{C252D25B-AFA4-4E68-8A84-3CCF1A6905D4}"/>
               </a:ext>
             </a:extLst>
           </p:cNvPr>
@@ -6849,7 +6849,7 @@
           <p:cNvPr id="7" name="">
             <a:extLst xmlns:a="http://schemas.openxmlformats.org/drawingml/2006/main">
               <a:ext uri="{FF2B5EF4-FFF2-40B4-BE49-F238E27FC236}">
-                <a16:creationId xmlns:a16="http://schemas.microsoft.com/office/drawing/2014/main" id="{EE06FC5D-6A00-494B-9A67-72E96CBB371E}"/>
+                <a16:creationId xmlns:a16="http://schemas.microsoft.com/office/drawing/2014/main" id="{EAA5CB40-7293-4215-948F-ED12809FD101}"/>
               </a:ext>
             </a:extLst>
           </p:cNvPr>
@@ -7028,7 +7028,7 @@
           <p:cNvPr id="8" name="">
             <a:extLst xmlns:a="http://schemas.openxmlformats.org/drawingml/2006/main">
               <a:ext uri="{FF2B5EF4-FFF2-40B4-BE49-F238E27FC236}">
-                <a16:creationId xmlns:a16="http://schemas.microsoft.com/office/drawing/2014/main" id="{2B47652E-C9EC-4D49-A435-D9C9309159CA}"/>
+                <a16:creationId xmlns:a16="http://schemas.microsoft.com/office/drawing/2014/main" id="{47732290-6656-48B7-9A35-774A70043B35}"/>
               </a:ext>
             </a:extLst>
           </p:cNvPr>
@@ -7038,7 +7038,7 @@
           <p:nvPr/>
         </p:nvPicPr>
         <p:blipFill>
-          <a:blip xmlns:r="http://schemas.openxmlformats.org/officeDocument/2006/relationships" xmlns:a="http://schemas.openxmlformats.org/drawingml/2006/main" r:embed="R61676f9b1aa54817"/>
+          <a:blip xmlns:r="http://schemas.openxmlformats.org/officeDocument/2006/relationships" xmlns:a="http://schemas.openxmlformats.org/drawingml/2006/main" r:embed="R4e112df4c0904b05"/>
           <a:stretch xmlns:a="http://schemas.openxmlformats.org/drawingml/2006/main"/>
         </p:blipFill>
         <p:spPr>
@@ -7054,7 +7054,7 @@
     </p:spTree>
     <p:extLst>
       <p:ext uri="{BB962C8B-B14F-4D97-AF65-F5344CB8AC3E}">
-        <p14:creationId xmlns:p14="http://schemas.microsoft.com/office/powerpoint/2010/main" val="1123044919"/>
+        <p14:creationId xmlns:p14="http://schemas.microsoft.com/office/powerpoint/2010/main" val="1940835299"/>
       </p:ext>
     </p:extLst>
   </p:cSld>
@@ -7085,7 +7085,7 @@
           <p:cNvPr id="8" name="">
             <a:extLst xmlns:a="http://schemas.openxmlformats.org/drawingml/2006/main">
               <a:ext uri="{FF2B5EF4-FFF2-40B4-BE49-F238E27FC236}">
-                <a16:creationId xmlns:a16="http://schemas.microsoft.com/office/drawing/2014/main" id="{233BCA4C-264A-4D31-9889-DE1B64AC4BBC}"/>
+                <a16:creationId xmlns:a16="http://schemas.microsoft.com/office/drawing/2014/main" id="{6CBF29CD-073C-4758-AA93-8B08730F7A6A}"/>
               </a:ext>
             </a:extLst>
           </p:cNvPr>
@@ -7241,7 +7241,7 @@
           <p:cNvPr id="2" name="">
             <a:extLst xmlns:a="http://schemas.openxmlformats.org/drawingml/2006/main">
               <a:ext uri="{FF2B5EF4-FFF2-40B4-BE49-F238E27FC236}">
-                <a16:creationId xmlns:a16="http://schemas.microsoft.com/office/drawing/2014/main" id="{AAB960BB-F2A1-4E9C-874F-D77E6C04AD8E}"/>
+                <a16:creationId xmlns:a16="http://schemas.microsoft.com/office/drawing/2014/main" id="{945C13CC-B66C-4DA1-B461-A7564B048CF6}"/>
               </a:ext>
             </a:extLst>
           </p:cNvPr>
@@ -7397,7 +7397,7 @@
           <p:cNvPr id="3" name="">
             <a:extLst xmlns:a="http://schemas.openxmlformats.org/drawingml/2006/main">
               <a:ext uri="{FF2B5EF4-FFF2-40B4-BE49-F238E27FC236}">
-                <a16:creationId xmlns:a16="http://schemas.microsoft.com/office/drawing/2014/main" id="{8013E62F-C98B-441D-A377-31BF1CB6FD75}"/>
+                <a16:creationId xmlns:a16="http://schemas.microsoft.com/office/drawing/2014/main" id="{D82A4592-AE16-4571-AA3D-B383CC5F142C}"/>
               </a:ext>
             </a:extLst>
           </p:cNvPr>
@@ -7553,7 +7553,7 @@
           <p:cNvPr id="4" name="">
             <a:extLst xmlns:a="http://schemas.openxmlformats.org/drawingml/2006/main">
               <a:ext uri="{FF2B5EF4-FFF2-40B4-BE49-F238E27FC236}">
-                <a16:creationId xmlns:a16="http://schemas.microsoft.com/office/drawing/2014/main" id="{D2BF6AEA-94EF-4E9A-AC52-ED204022AC35}"/>
+                <a16:creationId xmlns:a16="http://schemas.microsoft.com/office/drawing/2014/main" id="{624CB936-1C32-4007-8261-88A2E60CBF01}"/>
               </a:ext>
             </a:extLst>
           </p:cNvPr>
@@ -7709,7 +7709,7 @@
           <p:cNvPr id="5" name="">
             <a:extLst xmlns:a="http://schemas.openxmlformats.org/drawingml/2006/main">
               <a:ext uri="{FF2B5EF4-FFF2-40B4-BE49-F238E27FC236}">
-                <a16:creationId xmlns:a16="http://schemas.microsoft.com/office/drawing/2014/main" id="{080E5B54-FE06-4EC8-AD2B-58771BBD9DA9}"/>
+                <a16:creationId xmlns:a16="http://schemas.microsoft.com/office/drawing/2014/main" id="{E4D4BEB3-FD1E-4739-A73E-74D251D1CCB0}"/>
               </a:ext>
             </a:extLst>
           </p:cNvPr>
@@ -7865,7 +7865,7 @@
           <p:cNvPr id="6" name="">
             <a:extLst xmlns:a="http://schemas.openxmlformats.org/drawingml/2006/main">
               <a:ext uri="{FF2B5EF4-FFF2-40B4-BE49-F238E27FC236}">
-                <a16:creationId xmlns:a16="http://schemas.microsoft.com/office/drawing/2014/main" id="{9278E0A8-12A6-4935-9BE5-A559F03730F4}"/>
+                <a16:creationId xmlns:a16="http://schemas.microsoft.com/office/drawing/2014/main" id="{3A07E19E-680C-4BB4-AA7B-EE40EE3BAC9D}"/>
               </a:ext>
             </a:extLst>
           </p:cNvPr>
@@ -8021,7 +8021,7 @@
           <p:cNvPr id="7" name="">
             <a:extLst xmlns:a="http://schemas.openxmlformats.org/drawingml/2006/main">
               <a:ext uri="{FF2B5EF4-FFF2-40B4-BE49-F238E27FC236}">
-                <a16:creationId xmlns:a16="http://schemas.microsoft.com/office/drawing/2014/main" id="{2CF233F8-0CD3-4CD6-9340-23F94CA35A3E}"/>
+                <a16:creationId xmlns:a16="http://schemas.microsoft.com/office/drawing/2014/main" id="{AA1B6180-A092-46AA-ACD7-B4D22FBFD832}"/>
               </a:ext>
             </a:extLst>
           </p:cNvPr>
@@ -8175,7 +8175,7 @@
     </p:spTree>
     <p:extLst>
       <p:ext uri="{BB962C8B-B14F-4D97-AF65-F5344CB8AC3E}">
-        <p14:creationId xmlns:p14="http://schemas.microsoft.com/office/powerpoint/2010/main" val="829389259"/>
+        <p14:creationId xmlns:p14="http://schemas.microsoft.com/office/powerpoint/2010/main" val="1450554488"/>
       </p:ext>
     </p:extLst>
   </p:cSld>
@@ -8206,7 +8206,7 @@
           <p:cNvPr id="17" name="">
             <a:extLst xmlns:a="http://schemas.openxmlformats.org/drawingml/2006/main">
               <a:ext uri="{FF2B5EF4-FFF2-40B4-BE49-F238E27FC236}">
-                <a16:creationId xmlns:a16="http://schemas.microsoft.com/office/drawing/2014/main" id="{4F58F822-8800-4906-8E08-58EBC5A5D971}"/>
+                <a16:creationId xmlns:a16="http://schemas.microsoft.com/office/drawing/2014/main" id="{2279800B-9410-431F-96F4-9FAAA60B2BB5}"/>
               </a:ext>
             </a:extLst>
           </p:cNvPr>
@@ -8362,7 +8362,7 @@
           <p:cNvPr id="2" name="">
             <a:extLst xmlns:a="http://schemas.openxmlformats.org/drawingml/2006/main">
               <a:ext uri="{FF2B5EF4-FFF2-40B4-BE49-F238E27FC236}">
-                <a16:creationId xmlns:a16="http://schemas.microsoft.com/office/drawing/2014/main" id="{CB5AE934-3171-4B22-9514-FA71F2787F74}"/>
+                <a16:creationId xmlns:a16="http://schemas.microsoft.com/office/drawing/2014/main" id="{A7EEE31C-7FE8-47FE-A44C-B0AE3FFD91B9}"/>
               </a:ext>
             </a:extLst>
           </p:cNvPr>
@@ -8518,7 +8518,7 @@
           <p:cNvPr id="3" name="">
             <a:extLst xmlns:a="http://schemas.openxmlformats.org/drawingml/2006/main">
               <a:ext uri="{FF2B5EF4-FFF2-40B4-BE49-F238E27FC236}">
-                <a16:creationId xmlns:a16="http://schemas.microsoft.com/office/drawing/2014/main" id="{C2A5CB4A-6D61-4671-9C13-6F5D38B7B422}"/>
+                <a16:creationId xmlns:a16="http://schemas.microsoft.com/office/drawing/2014/main" id="{6259D33B-74CD-4465-86E1-3A30A8170226}"/>
               </a:ext>
             </a:extLst>
           </p:cNvPr>
@@ -8674,7 +8674,7 @@
           <p:cNvPr id="4" name="">
             <a:extLst xmlns:a="http://schemas.openxmlformats.org/drawingml/2006/main">
               <a:ext uri="{FF2B5EF4-FFF2-40B4-BE49-F238E27FC236}">
-                <a16:creationId xmlns:a16="http://schemas.microsoft.com/office/drawing/2014/main" id="{62CB6E04-7318-4D53-B71F-EC1337D2BE02}"/>
+                <a16:creationId xmlns:a16="http://schemas.microsoft.com/office/drawing/2014/main" id="{38022060-3E6F-4570-9D74-B83C47E56D91}"/>
               </a:ext>
             </a:extLst>
           </p:cNvPr>
@@ -8857,7 +8857,7 @@
           <p:cNvPr id="5" name="">
             <a:extLst xmlns:a="http://schemas.openxmlformats.org/drawingml/2006/main">
               <a:ext uri="{FF2B5EF4-FFF2-40B4-BE49-F238E27FC236}">
-                <a16:creationId xmlns:a16="http://schemas.microsoft.com/office/drawing/2014/main" id="{5D655BE2-55D7-4832-A64E-B0D0AD5398E6}"/>
+                <a16:creationId xmlns:a16="http://schemas.microsoft.com/office/drawing/2014/main" id="{876C5159-6BD6-4874-9ADC-AEB854CB770C}"/>
               </a:ext>
             </a:extLst>
           </p:cNvPr>
@@ -9040,7 +9040,7 @@
           <p:cNvPr id="6" name="">
             <a:extLst xmlns:a="http://schemas.openxmlformats.org/drawingml/2006/main">
               <a:ext uri="{FF2B5EF4-FFF2-40B4-BE49-F238E27FC236}">
-                <a16:creationId xmlns:a16="http://schemas.microsoft.com/office/drawing/2014/main" id="{9B9331DD-4FD3-4702-A9F7-9D271D02DD69}"/>
+                <a16:creationId xmlns:a16="http://schemas.microsoft.com/office/drawing/2014/main" id="{78344741-F7E1-447F-BB6C-84587F48CE20}"/>
               </a:ext>
             </a:extLst>
           </p:cNvPr>
@@ -9223,7 +9223,7 @@
           <p:cNvPr id="7" name="">
             <a:extLst xmlns:a="http://schemas.openxmlformats.org/drawingml/2006/main">
               <a:ext uri="{FF2B5EF4-FFF2-40B4-BE49-F238E27FC236}">
-                <a16:creationId xmlns:a16="http://schemas.microsoft.com/office/drawing/2014/main" id="{BCAB5794-8544-4223-A573-0BCDE46AF471}"/>
+                <a16:creationId xmlns:a16="http://schemas.microsoft.com/office/drawing/2014/main" id="{52562ED0-1260-438F-A8DD-DCC8DC9E457D}"/>
               </a:ext>
             </a:extLst>
           </p:cNvPr>
@@ -9379,7 +9379,7 @@
           <p:cNvPr id="8" name="">
             <a:extLst xmlns:a="http://schemas.openxmlformats.org/drawingml/2006/main">
               <a:ext uri="{FF2B5EF4-FFF2-40B4-BE49-F238E27FC236}">
-                <a16:creationId xmlns:a16="http://schemas.microsoft.com/office/drawing/2014/main" id="{0648F257-9780-4D9A-9AA5-B6C04E468AAA}"/>
+                <a16:creationId xmlns:a16="http://schemas.microsoft.com/office/drawing/2014/main" id="{4A17D949-D59C-4FFD-911D-ABF70EFFB99D}"/>
               </a:ext>
             </a:extLst>
           </p:cNvPr>
@@ -9535,7 +9535,7 @@
           <p:cNvPr id="9" name="">
             <a:extLst xmlns:a="http://schemas.openxmlformats.org/drawingml/2006/main">
               <a:ext uri="{FF2B5EF4-FFF2-40B4-BE49-F238E27FC236}">
-                <a16:creationId xmlns:a16="http://schemas.microsoft.com/office/drawing/2014/main" id="{1DC3D53A-3D05-43A6-BCE1-DF8417F44D02}"/>
+                <a16:creationId xmlns:a16="http://schemas.microsoft.com/office/drawing/2014/main" id="{223DE40D-291A-4D26-A33D-B7FAB6A3E084}"/>
               </a:ext>
             </a:extLst>
           </p:cNvPr>
@@ -9718,7 +9718,7 @@
           <p:cNvPr id="10" name="">
             <a:extLst xmlns:a="http://schemas.openxmlformats.org/drawingml/2006/main">
               <a:ext uri="{FF2B5EF4-FFF2-40B4-BE49-F238E27FC236}">
-                <a16:creationId xmlns:a16="http://schemas.microsoft.com/office/drawing/2014/main" id="{E2DC2F15-6E9E-4A6D-A409-90AA0F4AB9B7}"/>
+                <a16:creationId xmlns:a16="http://schemas.microsoft.com/office/drawing/2014/main" id="{EF6ECBBE-3616-4137-A3BF-13AA503AF3F8}"/>
               </a:ext>
             </a:extLst>
           </p:cNvPr>
@@ -9901,7 +9901,7 @@
           <p:cNvPr id="11" name="">
             <a:extLst xmlns:a="http://schemas.openxmlformats.org/drawingml/2006/main">
               <a:ext uri="{FF2B5EF4-FFF2-40B4-BE49-F238E27FC236}">
-                <a16:creationId xmlns:a16="http://schemas.microsoft.com/office/drawing/2014/main" id="{20A5B96D-F615-42FA-BBB5-021EBCF08088}"/>
+                <a16:creationId xmlns:a16="http://schemas.microsoft.com/office/drawing/2014/main" id="{9772EF15-2E3C-472D-B874-7D4604FD00BD}"/>
               </a:ext>
             </a:extLst>
           </p:cNvPr>
@@ -10084,7 +10084,7 @@
           <p:cNvPr id="12" name="">
             <a:extLst xmlns:a="http://schemas.openxmlformats.org/drawingml/2006/main">
               <a:ext uri="{FF2B5EF4-FFF2-40B4-BE49-F238E27FC236}">
-                <a16:creationId xmlns:a16="http://schemas.microsoft.com/office/drawing/2014/main" id="{2407D7CB-A42E-487D-8B0C-43635D20E872}"/>
+                <a16:creationId xmlns:a16="http://schemas.microsoft.com/office/drawing/2014/main" id="{3D297721-543A-4797-9922-D786103A6855}"/>
               </a:ext>
             </a:extLst>
           </p:cNvPr>
@@ -10240,7 +10240,7 @@
           <p:cNvPr id="13" name="">
             <a:extLst xmlns:a="http://schemas.openxmlformats.org/drawingml/2006/main">
               <a:ext uri="{FF2B5EF4-FFF2-40B4-BE49-F238E27FC236}">
-                <a16:creationId xmlns:a16="http://schemas.microsoft.com/office/drawing/2014/main" id="{9B9040AC-2900-4BE3-8178-6917FD784A06}"/>
+                <a16:creationId xmlns:a16="http://schemas.microsoft.com/office/drawing/2014/main" id="{7962465A-5AB1-41A8-826E-48AB3DD7E9C8}"/>
               </a:ext>
             </a:extLst>
           </p:cNvPr>
@@ -10396,7 +10396,7 @@
           <p:cNvPr id="14" name="">
             <a:extLst xmlns:a="http://schemas.openxmlformats.org/drawingml/2006/main">
               <a:ext uri="{FF2B5EF4-FFF2-40B4-BE49-F238E27FC236}">
-                <a16:creationId xmlns:a16="http://schemas.microsoft.com/office/drawing/2014/main" id="{3CF435AC-7CF6-4DBD-9BE3-99F37559ED5D}"/>
+                <a16:creationId xmlns:a16="http://schemas.microsoft.com/office/drawing/2014/main" id="{AF6837A6-D23D-4D62-98F8-F48692F837F1}"/>
               </a:ext>
             </a:extLst>
           </p:cNvPr>
@@ -10552,7 +10552,7 @@
           <p:cNvPr id="15" name="">
             <a:extLst xmlns:a="http://schemas.openxmlformats.org/drawingml/2006/main">
               <a:ext uri="{FF2B5EF4-FFF2-40B4-BE49-F238E27FC236}">
-                <a16:creationId xmlns:a16="http://schemas.microsoft.com/office/drawing/2014/main" id="{2555E6B5-CBCC-416D-8DCC-E48440CAE480}"/>
+                <a16:creationId xmlns:a16="http://schemas.microsoft.com/office/drawing/2014/main" id="{EDF00CD0-19E3-466C-98C5-DA8DC571344F}"/>
               </a:ext>
             </a:extLst>
           </p:cNvPr>
@@ -10708,7 +10708,7 @@
           <p:cNvPr id="16" name="">
             <a:extLst xmlns:a="http://schemas.openxmlformats.org/drawingml/2006/main">
               <a:ext uri="{FF2B5EF4-FFF2-40B4-BE49-F238E27FC236}">
-                <a16:creationId xmlns:a16="http://schemas.microsoft.com/office/drawing/2014/main" id="{72A9C9B1-F95B-4B0E-A269-73984FB06B19}"/>
+                <a16:creationId xmlns:a16="http://schemas.microsoft.com/office/drawing/2014/main" id="{F9F55EB3-3513-42A5-B05C-12095BDDE205}"/>
               </a:ext>
             </a:extLst>
           </p:cNvPr>
@@ -10862,7 +10862,7 @@
     </p:spTree>
     <p:extLst>
       <p:ext uri="{BB962C8B-B14F-4D97-AF65-F5344CB8AC3E}">
-        <p14:creationId xmlns:p14="http://schemas.microsoft.com/office/powerpoint/2010/main" val="1370698051"/>
+        <p14:creationId xmlns:p14="http://schemas.microsoft.com/office/powerpoint/2010/main" val="754307602"/>
       </p:ext>
     </p:extLst>
   </p:cSld>
@@ -10893,7 +10893,7 @@
           <p:cNvPr id="8" name="">
             <a:extLst xmlns:a="http://schemas.openxmlformats.org/drawingml/2006/main">
               <a:ext uri="{FF2B5EF4-FFF2-40B4-BE49-F238E27FC236}">
-                <a16:creationId xmlns:a16="http://schemas.microsoft.com/office/drawing/2014/main" id="{4F1F8E5E-AC57-4E7B-8D36-067A04DCA917}"/>
+                <a16:creationId xmlns:a16="http://schemas.microsoft.com/office/drawing/2014/main" id="{8EC47BDF-E468-43B6-9247-C3DC88E4590C}"/>
               </a:ext>
             </a:extLst>
           </p:cNvPr>
@@ -11049,7 +11049,7 @@
           <p:cNvPr id="2" name="">
             <a:extLst xmlns:a="http://schemas.openxmlformats.org/drawingml/2006/main">
               <a:ext uri="{FF2B5EF4-FFF2-40B4-BE49-F238E27FC236}">
-                <a16:creationId xmlns:a16="http://schemas.microsoft.com/office/drawing/2014/main" id="{5ABF2684-8AB5-4B6F-AA9A-A1DA4B78FC68}"/>
+                <a16:creationId xmlns:a16="http://schemas.microsoft.com/office/drawing/2014/main" id="{A428DB58-B704-4D16-804D-990DEBE20E0B}"/>
               </a:ext>
             </a:extLst>
           </p:cNvPr>
@@ -11205,7 +11205,7 @@
           <p:cNvPr id="3" name="">
             <a:extLst xmlns:a="http://schemas.openxmlformats.org/drawingml/2006/main">
               <a:ext uri="{FF2B5EF4-FFF2-40B4-BE49-F238E27FC236}">
-                <a16:creationId xmlns:a16="http://schemas.microsoft.com/office/drawing/2014/main" id="{FBEF9FA0-645F-4D6D-B0FD-65784F42AFDD}"/>
+                <a16:creationId xmlns:a16="http://schemas.microsoft.com/office/drawing/2014/main" id="{0054F478-240B-4DFC-87A9-61A4D745FE36}"/>
               </a:ext>
             </a:extLst>
           </p:cNvPr>
@@ -11361,7 +11361,7 @@
           <p:cNvPr id="4" name="">
             <a:extLst xmlns:a="http://schemas.openxmlformats.org/drawingml/2006/main">
               <a:ext uri="{FF2B5EF4-FFF2-40B4-BE49-F238E27FC236}">
-                <a16:creationId xmlns:a16="http://schemas.microsoft.com/office/drawing/2014/main" id="{DABB4700-F262-4CB1-BA8B-180CB64BD2AB}"/>
+                <a16:creationId xmlns:a16="http://schemas.microsoft.com/office/drawing/2014/main" id="{ADC10BBB-7A3B-4A92-967E-68C8EF21A46E}"/>
               </a:ext>
             </a:extLst>
           </p:cNvPr>
@@ -11801,7 +11801,7 @@
           <p:cNvPr id="5" name="">
             <a:extLst xmlns:a="http://schemas.openxmlformats.org/drawingml/2006/main">
               <a:ext uri="{FF2B5EF4-FFF2-40B4-BE49-F238E27FC236}">
-                <a16:creationId xmlns:a16="http://schemas.microsoft.com/office/drawing/2014/main" id="{A332C40C-4290-41A8-BD27-38DCCCB38A87}"/>
+                <a16:creationId xmlns:a16="http://schemas.microsoft.com/office/drawing/2014/main" id="{7B432F5F-C642-4F93-B6E4-6C3B9F4368A6}"/>
               </a:ext>
             </a:extLst>
           </p:cNvPr>
@@ -11957,7 +11957,7 @@
           <p:cNvPr id="6" name="">
             <a:extLst xmlns:a="http://schemas.openxmlformats.org/drawingml/2006/main">
               <a:ext uri="{FF2B5EF4-FFF2-40B4-BE49-F238E27FC236}">
-                <a16:creationId xmlns:a16="http://schemas.microsoft.com/office/drawing/2014/main" id="{ED995036-6123-4875-86B9-20671788A7A9}"/>
+                <a16:creationId xmlns:a16="http://schemas.microsoft.com/office/drawing/2014/main" id="{0A5D3A95-3C13-4D34-853C-F99C5D8A43EF}"/>
               </a:ext>
             </a:extLst>
           </p:cNvPr>
@@ -12113,7 +12113,7 @@
           <p:cNvPr id="7" name="">
             <a:extLst xmlns:a="http://schemas.openxmlformats.org/drawingml/2006/main">
               <a:ext uri="{FF2B5EF4-FFF2-40B4-BE49-F238E27FC236}">
-                <a16:creationId xmlns:a16="http://schemas.microsoft.com/office/drawing/2014/main" id="{4EDD1734-9332-4AFA-ABAD-DDB919C238E8}"/>
+                <a16:creationId xmlns:a16="http://schemas.microsoft.com/office/drawing/2014/main" id="{5D89F3A0-0AE0-470B-BFAA-3A33105EBBF8}"/>
               </a:ext>
             </a:extLst>
           </p:cNvPr>
@@ -12123,7 +12123,7 @@
           <p:nvPr/>
         </p:nvPicPr>
         <p:blipFill>
-          <a:blip xmlns:r="http://schemas.openxmlformats.org/officeDocument/2006/relationships" xmlns:a="http://schemas.openxmlformats.org/drawingml/2006/main" r:embed="R1b3239bddfdf4e58"/>
+          <a:blip xmlns:r="http://schemas.openxmlformats.org/officeDocument/2006/relationships" xmlns:a="http://schemas.openxmlformats.org/drawingml/2006/main" r:embed="R1e553a2e4a5c43b6"/>
           <a:stretch xmlns:a="http://schemas.openxmlformats.org/drawingml/2006/main"/>
         </p:blipFill>
         <p:spPr>
@@ -12139,7 +12139,7 @@
     </p:spTree>
     <p:extLst>
       <p:ext uri="{BB962C8B-B14F-4D97-AF65-F5344CB8AC3E}">
-        <p14:creationId xmlns:p14="http://schemas.microsoft.com/office/powerpoint/2010/main" val="1943535653"/>
+        <p14:creationId xmlns:p14="http://schemas.microsoft.com/office/powerpoint/2010/main" val="79623420"/>
       </p:ext>
     </p:extLst>
   </p:cSld>
@@ -12170,7 +12170,7 @@
           <p:cNvPr id="10" name="">
             <a:extLst xmlns:a="http://schemas.openxmlformats.org/drawingml/2006/main">
               <a:ext uri="{FF2B5EF4-FFF2-40B4-BE49-F238E27FC236}">
-                <a16:creationId xmlns:a16="http://schemas.microsoft.com/office/drawing/2014/main" id="{DF5D70A2-9B8B-47D8-9BFF-2EFE17F475E5}"/>
+                <a16:creationId xmlns:a16="http://schemas.microsoft.com/office/drawing/2014/main" id="{55206E9A-825D-47D4-ABA3-278F30000E63}"/>
               </a:ext>
             </a:extLst>
           </p:cNvPr>
@@ -12326,7 +12326,7 @@
           <p:cNvPr id="2" name="">
             <a:extLst xmlns:a="http://schemas.openxmlformats.org/drawingml/2006/main">
               <a:ext uri="{FF2B5EF4-FFF2-40B4-BE49-F238E27FC236}">
-                <a16:creationId xmlns:a16="http://schemas.microsoft.com/office/drawing/2014/main" id="{34746CBE-DD7D-467D-AF96-D4EDEEB0E823}"/>
+                <a16:creationId xmlns:a16="http://schemas.microsoft.com/office/drawing/2014/main" id="{68C0C212-AFA9-4271-AFB2-52FE73A9C235}"/>
               </a:ext>
             </a:extLst>
           </p:cNvPr>
@@ -12482,7 +12482,7 @@
           <p:cNvPr id="3" name="">
             <a:extLst xmlns:a="http://schemas.openxmlformats.org/drawingml/2006/main">
               <a:ext uri="{FF2B5EF4-FFF2-40B4-BE49-F238E27FC236}">
-                <a16:creationId xmlns:a16="http://schemas.microsoft.com/office/drawing/2014/main" id="{CC00D59D-5F66-483C-B92D-FF40E1AB8F42}"/>
+                <a16:creationId xmlns:a16="http://schemas.microsoft.com/office/drawing/2014/main" id="{E14A3E13-A69B-4236-B31C-94080C0F6C77}"/>
               </a:ext>
             </a:extLst>
           </p:cNvPr>
@@ -12638,7 +12638,7 @@
           <p:cNvPr id="4" name="">
             <a:extLst xmlns:a="http://schemas.openxmlformats.org/drawingml/2006/main">
               <a:ext uri="{FF2B5EF4-FFF2-40B4-BE49-F238E27FC236}">
-                <a16:creationId xmlns:a16="http://schemas.microsoft.com/office/drawing/2014/main" id="{D5D7A0B9-68C7-4BD6-8F24-4C40675F8F17}"/>
+                <a16:creationId xmlns:a16="http://schemas.microsoft.com/office/drawing/2014/main" id="{A9283D4B-85D1-4A2D-A032-0F897B79BF2F}"/>
               </a:ext>
             </a:extLst>
           </p:cNvPr>
@@ -12794,7 +12794,7 @@
           <p:cNvPr id="5" name="">
             <a:extLst xmlns:a="http://schemas.openxmlformats.org/drawingml/2006/main">
               <a:ext uri="{FF2B5EF4-FFF2-40B4-BE49-F238E27FC236}">
-                <a16:creationId xmlns:a16="http://schemas.microsoft.com/office/drawing/2014/main" id="{D7ABA113-4BD4-4482-8544-E8F16A14DF53}"/>
+                <a16:creationId xmlns:a16="http://schemas.microsoft.com/office/drawing/2014/main" id="{5B773EE8-E0A2-46F1-B515-9DF1E7202D89}"/>
               </a:ext>
             </a:extLst>
           </p:cNvPr>
@@ -12950,7 +12950,7 @@
           <p:cNvPr id="6" name="">
             <a:extLst xmlns:a="http://schemas.openxmlformats.org/drawingml/2006/main">
               <a:ext uri="{FF2B5EF4-FFF2-40B4-BE49-F238E27FC236}">
-                <a16:creationId xmlns:a16="http://schemas.microsoft.com/office/drawing/2014/main" id="{C753FA79-94F9-4DE9-BB05-8F8A06A78721}"/>
+                <a16:creationId xmlns:a16="http://schemas.microsoft.com/office/drawing/2014/main" id="{ACAD04CA-5876-4BEC-96E0-296015A04332}"/>
               </a:ext>
             </a:extLst>
           </p:cNvPr>
@@ -13106,7 +13106,7 @@
           <p:cNvPr id="7" name="">
             <a:extLst xmlns:a="http://schemas.openxmlformats.org/drawingml/2006/main">
               <a:ext uri="{FF2B5EF4-FFF2-40B4-BE49-F238E27FC236}">
-                <a16:creationId xmlns:a16="http://schemas.microsoft.com/office/drawing/2014/main" id="{14E37E5C-2A5E-4FAE-9D70-9D118BFB8D8E}"/>
+                <a16:creationId xmlns:a16="http://schemas.microsoft.com/office/drawing/2014/main" id="{5BCC0DBE-AB88-4262-BCDC-DC0B2746C2E3}"/>
               </a:ext>
             </a:extLst>
           </p:cNvPr>
@@ -13262,7 +13262,7 @@
           <p:cNvPr id="8" name="">
             <a:extLst xmlns:a="http://schemas.openxmlformats.org/drawingml/2006/main">
               <a:ext uri="{FF2B5EF4-FFF2-40B4-BE49-F238E27FC236}">
-                <a16:creationId xmlns:a16="http://schemas.microsoft.com/office/drawing/2014/main" id="{DA28437F-8B01-4BB5-B0F7-DED977CA207A}"/>
+                <a16:creationId xmlns:a16="http://schemas.microsoft.com/office/drawing/2014/main" id="{D6E6AF63-5995-43E7-A5D0-15D331A8AA76}"/>
               </a:ext>
             </a:extLst>
           </p:cNvPr>
@@ -13441,7 +13441,7 @@
           <p:cNvPr id="9" name="">
             <a:extLst xmlns:a="http://schemas.openxmlformats.org/drawingml/2006/main">
               <a:ext uri="{FF2B5EF4-FFF2-40B4-BE49-F238E27FC236}">
-                <a16:creationId xmlns:a16="http://schemas.microsoft.com/office/drawing/2014/main" id="{0447B11F-4B73-4442-915B-CFBEA4BD1AD2}"/>
+                <a16:creationId xmlns:a16="http://schemas.microsoft.com/office/drawing/2014/main" id="{200E9F4B-C3D7-4353-80A4-CF22648699CF}"/>
               </a:ext>
             </a:extLst>
           </p:cNvPr>
@@ -13451,7 +13451,7 @@
           <p:nvPr/>
         </p:nvPicPr>
         <p:blipFill>
-          <a:blip xmlns:r="http://schemas.openxmlformats.org/officeDocument/2006/relationships" xmlns:a="http://schemas.openxmlformats.org/drawingml/2006/main" r:embed="R9224544c31bc42cd"/>
+          <a:blip xmlns:r="http://schemas.openxmlformats.org/officeDocument/2006/relationships" xmlns:a="http://schemas.openxmlformats.org/drawingml/2006/main" r:embed="R98dcd8844a47447e"/>
           <a:stretch xmlns:a="http://schemas.openxmlformats.org/drawingml/2006/main"/>
         </p:blipFill>
         <p:spPr>
@@ -13467,7 +13467,7 @@
     </p:spTree>
     <p:extLst>
       <p:ext uri="{BB962C8B-B14F-4D97-AF65-F5344CB8AC3E}">
-        <p14:creationId xmlns:p14="http://schemas.microsoft.com/office/powerpoint/2010/main" val="816723237"/>
+        <p14:creationId xmlns:p14="http://schemas.microsoft.com/office/powerpoint/2010/main" val="94023259"/>
       </p:ext>
     </p:extLst>
   </p:cSld>
@@ -13498,7 +13498,7 @@
           <p:cNvPr id="7" name="">
             <a:extLst xmlns:a="http://schemas.openxmlformats.org/drawingml/2006/main">
               <a:ext uri="{FF2B5EF4-FFF2-40B4-BE49-F238E27FC236}">
-                <a16:creationId xmlns:a16="http://schemas.microsoft.com/office/drawing/2014/main" id="{0E83833F-BB7F-493C-B557-87A32584DFDD}"/>
+                <a16:creationId xmlns:a16="http://schemas.microsoft.com/office/drawing/2014/main" id="{1B40EF54-187C-47CB-9BD5-9255499E8A0B}"/>
               </a:ext>
             </a:extLst>
           </p:cNvPr>
@@ -13644,7 +13644,7 @@
                 <a:ea typeface="Arial"/>
                 <a:cs typeface="Arial"/>
               </a:rPr>
-              <a:t>Checks and limits</a:t>
+              <a:t>Implemented and checked</a:t>
             </a:r>
           </a:p>
         </p:txBody>
@@ -13654,7 +13654,7 @@
           <p:cNvPr id="2" name="">
             <a:extLst xmlns:a="http://schemas.openxmlformats.org/drawingml/2006/main">
               <a:ext uri="{FF2B5EF4-FFF2-40B4-BE49-F238E27FC236}">
-                <a16:creationId xmlns:a16="http://schemas.microsoft.com/office/drawing/2014/main" id="{956F16A2-7FE6-4A70-8D0A-B6CB2938DE40}"/>
+                <a16:creationId xmlns:a16="http://schemas.microsoft.com/office/drawing/2014/main" id="{B4375B79-ACFB-4326-9DD4-B029E4593584}"/>
               </a:ext>
             </a:extLst>
           </p:cNvPr>
@@ -13810,7 +13810,7 @@
           <p:cNvPr id="3" name="">
             <a:extLst xmlns:a="http://schemas.openxmlformats.org/drawingml/2006/main">
               <a:ext uri="{FF2B5EF4-FFF2-40B4-BE49-F238E27FC236}">
-                <a16:creationId xmlns:a16="http://schemas.microsoft.com/office/drawing/2014/main" id="{384B6B80-9ED5-48D5-BCCD-ABF36E21100C}"/>
+                <a16:creationId xmlns:a16="http://schemas.microsoft.com/office/drawing/2014/main" id="{D9566F89-DEBB-48D0-AF1F-6CED48B4BFA7}"/>
               </a:ext>
             </a:extLst>
           </p:cNvPr>
@@ -13966,7 +13966,7 @@
           <p:cNvPr id="4" name="">
             <a:extLst xmlns:a="http://schemas.openxmlformats.org/drawingml/2006/main">
               <a:ext uri="{FF2B5EF4-FFF2-40B4-BE49-F238E27FC236}">
-                <a16:creationId xmlns:a16="http://schemas.microsoft.com/office/drawing/2014/main" id="{27AFC2C5-52BE-4498-96A0-6852AEB937EB}"/>
+                <a16:creationId xmlns:a16="http://schemas.microsoft.com/office/drawing/2014/main" id="{BE1C2FF7-0F35-4CB6-B192-3E6524CE53D8}"/>
               </a:ext>
             </a:extLst>
           </p:cNvPr>
@@ -14112,7 +14112,7 @@
                 <a:ea typeface="Arial"/>
                 <a:cs typeface="Arial"/>
               </a:rPr>
-              <a:t>Independent approval</a:t>
+              <a:t>Security hardening implemented</a:t>
             </a:r>
           </a:p>
           <a:p xmlns:a="http://schemas.openxmlformats.org/drawingml/2006/main">
@@ -14168,7 +14168,7 @@
                 <a:ea typeface="Arial"/>
                 <a:cs typeface="Arial"/>
               </a:rPr>
-              <a:t>Safe requests and private files</a:t>
+              <a:t>Windows and Linux checks passed</a:t>
             </a:r>
           </a:p>
           <a:p xmlns:a="http://schemas.openxmlformats.org/drawingml/2006/main">
@@ -14196,7 +14196,7 @@
                 <a:ea typeface="Arial"/>
                 <a:cs typeface="Arial"/>
               </a:rPr>
-              <a:t>Verifiable audit evidence</a:t>
+              <a:t>Independent financial approval</a:t>
             </a:r>
           </a:p>
         </p:txBody>
@@ -14206,7 +14206,7 @@
           <p:cNvPr id="5" name="">
             <a:extLst xmlns:a="http://schemas.openxmlformats.org/drawingml/2006/main">
               <a:ext uri="{FF2B5EF4-FFF2-40B4-BE49-F238E27FC236}">
-                <a16:creationId xmlns:a16="http://schemas.microsoft.com/office/drawing/2014/main" id="{B4EC6437-4E6F-413A-927C-F93B0A1CCD00}"/>
+                <a16:creationId xmlns:a16="http://schemas.microsoft.com/office/drawing/2014/main" id="{A601EF71-252F-4075-865D-0FA6AF98EEE8}"/>
               </a:ext>
             </a:extLst>
           </p:cNvPr>
@@ -14646,7 +14646,7 @@
           <p:cNvPr id="6" name="">
             <a:extLst xmlns:a="http://schemas.openxmlformats.org/drawingml/2006/main">
               <a:ext uri="{FF2B5EF4-FFF2-40B4-BE49-F238E27FC236}">
-                <a16:creationId xmlns:a16="http://schemas.microsoft.com/office/drawing/2014/main" id="{9A6F411C-A1B5-4D16-BD54-B3D067180600}"/>
+                <a16:creationId xmlns:a16="http://schemas.microsoft.com/office/drawing/2014/main" id="{74E01E6D-5490-48FA-B259-6E32CAE943E0}"/>
               </a:ext>
             </a:extLst>
           </p:cNvPr>
@@ -14800,7 +14800,7 @@
     </p:spTree>
     <p:extLst>
       <p:ext uri="{BB962C8B-B14F-4D97-AF65-F5344CB8AC3E}">
-        <p14:creationId xmlns:p14="http://schemas.microsoft.com/office/powerpoint/2010/main" val="39580290"/>
+        <p14:creationId xmlns:p14="http://schemas.microsoft.com/office/powerpoint/2010/main" val="1255985559"/>
       </p:ext>
     </p:extLst>
   </p:cSld>
@@ -14831,7 +14831,7 @@
           <p:cNvPr id="10" name="">
             <a:extLst xmlns:a="http://schemas.openxmlformats.org/drawingml/2006/main">
               <a:ext uri="{FF2B5EF4-FFF2-40B4-BE49-F238E27FC236}">
-                <a16:creationId xmlns:a16="http://schemas.microsoft.com/office/drawing/2014/main" id="{943EAD41-8B07-4999-9EBC-DAEAF685FBF1}"/>
+                <a16:creationId xmlns:a16="http://schemas.microsoft.com/office/drawing/2014/main" id="{CDB037F9-E3A6-4413-997A-735675039BA4}"/>
               </a:ext>
             </a:extLst>
           </p:cNvPr>
@@ -14987,7 +14987,7 @@
           <p:cNvPr id="2" name="">
             <a:extLst xmlns:a="http://schemas.openxmlformats.org/drawingml/2006/main">
               <a:ext uri="{FF2B5EF4-FFF2-40B4-BE49-F238E27FC236}">
-                <a16:creationId xmlns:a16="http://schemas.microsoft.com/office/drawing/2014/main" id="{5EF3B620-D3E2-4FBD-9F70-7ACDF224C97B}"/>
+                <a16:creationId xmlns:a16="http://schemas.microsoft.com/office/drawing/2014/main" id="{74CC01E0-F338-4F4F-ADD7-8ABCB84C6DA4}"/>
               </a:ext>
             </a:extLst>
           </p:cNvPr>
@@ -15143,7 +15143,7 @@
           <p:cNvPr id="3" name="">
             <a:extLst xmlns:a="http://schemas.openxmlformats.org/drawingml/2006/main">
               <a:ext uri="{FF2B5EF4-FFF2-40B4-BE49-F238E27FC236}">
-                <a16:creationId xmlns:a16="http://schemas.microsoft.com/office/drawing/2014/main" id="{65B26FB8-36BD-47B8-A5EE-C5C327FDF46E}"/>
+                <a16:creationId xmlns:a16="http://schemas.microsoft.com/office/drawing/2014/main" id="{E35BE5AF-1F23-4DB7-81A5-62CE7E2AA6C3}"/>
               </a:ext>
             </a:extLst>
           </p:cNvPr>
@@ -15299,7 +15299,7 @@
           <p:cNvPr id="4" name="">
             <a:extLst xmlns:a="http://schemas.openxmlformats.org/drawingml/2006/main">
               <a:ext uri="{FF2B5EF4-FFF2-40B4-BE49-F238E27FC236}">
-                <a16:creationId xmlns:a16="http://schemas.microsoft.com/office/drawing/2014/main" id="{D897C5D0-2123-4EAD-A3EB-66A3DB075551}"/>
+                <a16:creationId xmlns:a16="http://schemas.microsoft.com/office/drawing/2014/main" id="{24D84C19-3316-408C-B257-5E5231D5F928}"/>
               </a:ext>
             </a:extLst>
           </p:cNvPr>
@@ -15455,7 +15455,7 @@
           <p:cNvPr id="5" name="">
             <a:extLst xmlns:a="http://schemas.openxmlformats.org/drawingml/2006/main">
               <a:ext uri="{FF2B5EF4-FFF2-40B4-BE49-F238E27FC236}">
-                <a16:creationId xmlns:a16="http://schemas.microsoft.com/office/drawing/2014/main" id="{805B1F4F-55AC-456F-AB4E-0A21C28C7BEC}"/>
+                <a16:creationId xmlns:a16="http://schemas.microsoft.com/office/drawing/2014/main" id="{5BBB7A6E-9758-47B8-B3C7-CB0A65026AF3}"/>
               </a:ext>
             </a:extLst>
           </p:cNvPr>
@@ -15611,7 +15611,7 @@
           <p:cNvPr id="6" name="">
             <a:extLst xmlns:a="http://schemas.openxmlformats.org/drawingml/2006/main">
               <a:ext uri="{FF2B5EF4-FFF2-40B4-BE49-F238E27FC236}">
-                <a16:creationId xmlns:a16="http://schemas.microsoft.com/office/drawing/2014/main" id="{A401DB32-6254-4C89-A064-247DF4180A5F}"/>
+                <a16:creationId xmlns:a16="http://schemas.microsoft.com/office/drawing/2014/main" id="{1C7817F0-47A3-43A0-A395-AAC603E41B52}"/>
               </a:ext>
             </a:extLst>
           </p:cNvPr>
@@ -15767,7 +15767,7 @@
           <p:cNvPr id="7" name="">
             <a:extLst xmlns:a="http://schemas.openxmlformats.org/drawingml/2006/main">
               <a:ext uri="{FF2B5EF4-FFF2-40B4-BE49-F238E27FC236}">
-                <a16:creationId xmlns:a16="http://schemas.microsoft.com/office/drawing/2014/main" id="{6B94041F-BEC8-4CC1-BC92-20D9908C4707}"/>
+                <a16:creationId xmlns:a16="http://schemas.microsoft.com/office/drawing/2014/main" id="{A57D4930-4AC5-4D09-A606-7CA05F1B2446}"/>
               </a:ext>
             </a:extLst>
           </p:cNvPr>
@@ -15923,7 +15923,7 @@
           <p:cNvPr id="8" name="">
             <a:extLst xmlns:a="http://schemas.openxmlformats.org/drawingml/2006/main">
               <a:ext uri="{FF2B5EF4-FFF2-40B4-BE49-F238E27FC236}">
-                <a16:creationId xmlns:a16="http://schemas.microsoft.com/office/drawing/2014/main" id="{48E96BCB-39C9-48CD-867A-98AD99CA4F4F}"/>
+                <a16:creationId xmlns:a16="http://schemas.microsoft.com/office/drawing/2014/main" id="{F20DDE9F-6858-4F9E-87A8-0EEE4A3DCABB}"/>
               </a:ext>
             </a:extLst>
           </p:cNvPr>
@@ -15933,7 +15933,7 @@
           <p:nvPr/>
         </p:nvPicPr>
         <p:blipFill>
-          <a:blip xmlns:r="http://schemas.openxmlformats.org/officeDocument/2006/relationships" xmlns:a="http://schemas.openxmlformats.org/drawingml/2006/main" r:embed="Rcd47037d0b0d468c"/>
+          <a:blip xmlns:r="http://schemas.openxmlformats.org/officeDocument/2006/relationships" xmlns:a="http://schemas.openxmlformats.org/drawingml/2006/main" r:embed="R10e3271f097541e4"/>
           <a:stretch xmlns:a="http://schemas.openxmlformats.org/drawingml/2006/main"/>
         </p:blipFill>
         <p:spPr>
@@ -15951,7 +15951,7 @@
           <p:cNvPr id="9" name="">
             <a:extLst xmlns:a="http://schemas.openxmlformats.org/drawingml/2006/main">
               <a:ext uri="{FF2B5EF4-FFF2-40B4-BE49-F238E27FC236}">
-                <a16:creationId xmlns:a16="http://schemas.microsoft.com/office/drawing/2014/main" id="{4EF81DA1-B21F-40E9-89B1-27D747F7DD21}"/>
+                <a16:creationId xmlns:a16="http://schemas.microsoft.com/office/drawing/2014/main" id="{32B0709B-DD5D-4AC2-938A-E7C534CD56F1}"/>
               </a:ext>
             </a:extLst>
           </p:cNvPr>
@@ -16105,7 +16105,7 @@
     </p:spTree>
     <p:extLst>
       <p:ext uri="{BB962C8B-B14F-4D97-AF65-F5344CB8AC3E}">
-        <p14:creationId xmlns:p14="http://schemas.microsoft.com/office/powerpoint/2010/main" val="1831396542"/>
+        <p14:creationId xmlns:p14="http://schemas.microsoft.com/office/powerpoint/2010/main" val="1221708302"/>
       </p:ext>
     </p:extLst>
   </p:cSld>

</xml_diff>